<commit_message>
Aggiorna lead generation con dati HubSpot/MyArea
Sostituiti i dati GA4 con quelli corretti da HubSpot e MyArea:
- 215 preventivi dalla landing rivenditori (nuovo canale)
- 244 lead tradizionali vs 323 del 2025 (-24,5%)
- 459 lead totali incl. Preventivo LP
- Dettaglio per tipologia: FEEL5 -45,5%, info prodotto -39%,
  registrazioni area +1,8%, form contatto +5,6%
Aggiornato riepilogo con narrativa corretta.

Co-Authored-By: Claude Opus 4.6 <noreply@anthropic.com>
Claude-Session: https://claude.ai/code/session_01Nok6HhGnvhEchJRhgCetML
</commit_message>
<xml_diff>
--- a/FerreroLegnoReport_settembre_2026.pptx
+++ b/FerreroLegnoReport_settembre_2026.pptx
@@ -124,12 +124,12 @@
   <p:extLst>
     <p:ext uri="{521415D9-36F7-43E2-AB2F-B90AF26B5E84}">
       <p14:sectionLst xmlns:p14="http://schemas.microsoft.com/office/powerpoint/2010/main">
-        <p14:section name="Cover" id="{333bd486-02d4-1d9c-bf7f-4253b81eab15}">
+        <p14:section name="Cover" id="{ef0b8b8b-a6ea-407b-54d2-5650dd4685f8}">
           <p14:sldIdLst>
             <p14:sldId id="256"/>
           </p14:sldIdLst>
         </p14:section>
-        <p14:section name="Andamento e risultati" id="{250afe10-0d50-c55c-6d39-4f7009dd7019}">
+        <p14:section name="Andamento e risultati" id="{dcc1baca-2cef-74e9-b6be-bac7e00f55ff}">
           <p14:sldIdLst>
             <p14:sldId id="257"/>
             <p14:sldId id="258"/>
@@ -141,31 +141,31 @@
             <p14:sldId id="264"/>
           </p14:sldIdLst>
         </p14:section>
-        <p14:section name="Lead Generation" id="{67205f5a-f36a-56c6-1d50-4ea9a3a5156e}">
+        <p14:section name="Lead Generation" id="{0a22a415-e55c-947f-3084-9b9d85481f20}">
           <p14:sldIdLst>
             <p14:sldId id="265"/>
             <p14:sldId id="266"/>
           </p14:sldIdLst>
         </p14:section>
-        <p14:section name="Focus Magazine" id="{6e5db727-3523-61ee-0c12-e488e4668a64}">
+        <p14:section name="Focus Magazine" id="{cdfcd327-0e6f-9867-ee3e-8274c207a52e}">
           <p14:sldIdLst>
             <p14:sldId id="267"/>
             <p14:sldId id="268"/>
             <p14:sldId id="269"/>
           </p14:sldIdLst>
         </p14:section>
-        <p14:section name="Pinterest" id="{c2005d22-cfe0-cd9a-ed88-5394d1d1d412}">
+        <p14:section name="Pinterest" id="{3fba6989-5023-a8ae-415a-567d2e8c8a82}">
           <p14:sldIdLst>
             <p14:sldId id="270"/>
           </p14:sldIdLst>
         </p14:section>
-        <p14:section name="In chiusura" id="{5280ad25-9758-e89c-095c-ae4935cf043b}">
+        <p14:section name="In chiusura" id="{d504f03f-1197-5270-0f4a-91c40b0e278b}">
           <p14:sldIdLst>
             <p14:sldId id="271"/>
             <p14:sldId id="272"/>
           </p14:sldIdLst>
         </p14:section>
-        <p14:section name="Contatti" id="{43f4e7ec-3163-5b5a-7f6b-42184c92a404}">
+        <p14:section name="Contatti" id="{0d4594fb-b417-f1d5-0e6e-da16dfe6079a}">
           <p14:sldIdLst>
             <p14:sldId id="273"/>
           </p14:sldIdLst>
@@ -4471,7 +4471,7 @@
                 <a:ea typeface="Figtree" pitchFamily="34" charset="-122"/>
                 <a:cs typeface="Figtree" pitchFamily="34" charset="-120"/>
               </a:rPr>
-              <a:t>Le lead totali da sito raddoppiano YoY, trainate dalle landing rivenditori e dalle nuove campagne</a:t>
+              <a:t>La nuova landing rivenditori porta 215 preventivi, compensando il calo delle lead tradizionali (-24,5%)</a:t>
             </a:r>
             <a:endParaRPr lang="en-US" sz="2000" dirty="0"/>
           </a:p>
@@ -4500,10 +4500,11 @@
             <a:tbl>
               <a:tblPr/>
               <a:tblGrid>
-                <a:gridCol w="5029200"/>
+                <a:gridCol w="3657600"/>
                 <a:gridCol w="1828800"/>
-                <a:gridCol w="1828800"/>
-                <a:gridCol w="1828800"/>
+                <a:gridCol w="1645920"/>
+                <a:gridCol w="1645920"/>
+                <a:gridCol w="1645920"/>
               </a:tblGrid>
               <a:tr h="365760">
                 <a:tc>
@@ -4523,7 +4524,51 @@
                           <a:ea typeface="Figtree" pitchFamily="34" charset="-122"/>
                           <a:cs typeface="Figtree" pitchFamily="34" charset="-120"/>
                         </a:rPr>
-                        <a:t>Tipologia form</a:t>
+                        <a:t>Tipologia lead</a:t>
+                      </a:r>
+                      <a:endParaRPr lang="en-US" sz="900" dirty="0">
+                        <a:latin typeface="Figtree" charset="0"/>
+                        <a:ea typeface="Figtree" charset="0"/>
+                        <a:cs typeface="Figtree" charset="0"/>
+                      </a:endParaRPr>
+                    </a:p>
+                  </a:txBody>
+                  <a:tcPr marL="91440" marR="91440" marT="45720" marB="45720">
+                    <a:lnL w="0" cap="flat" cmpd="sng" algn="ctr">
+                      <a:noFill/>
+                    </a:lnL>
+                    <a:lnR w="0" cap="flat" cmpd="sng" algn="ctr">
+                      <a:noFill/>
+                    </a:lnR>
+                    <a:lnT w="0" cap="flat" cmpd="sng" algn="ctr">
+                      <a:noFill/>
+                    </a:lnT>
+                    <a:lnB w="0" cap="flat" cmpd="sng" algn="ctr">
+                      <a:noFill/>
+                    </a:lnB>
+                    <a:solidFill>
+                      <a:srgbClr val="191919"/>
+                    </a:solidFill>
+                  </a:tcPr>
+                </a:tc>
+                <a:tc>
+                  <a:txBody>
+                    <a:bodyPr/>
+                    <a:lstStyle/>
+                    <a:p>
+                      <a:pPr indent="0" marL="0">
+                        <a:buNone/>
+                      </a:pPr>
+                      <a:r>
+                        <a:rPr lang="en-US" sz="900" b="1" dirty="0">
+                          <a:solidFill>
+                            <a:srgbClr val="FFFFFF"/>
+                          </a:solidFill>
+                          <a:latin typeface="Figtree" pitchFamily="34" charset="0"/>
+                          <a:ea typeface="Figtree" pitchFamily="34" charset="-122"/>
+                          <a:cs typeface="Figtree" pitchFamily="34" charset="-120"/>
+                        </a:rPr>
+                        <a:t>Fonte</a:t>
                       </a:r>
                       <a:endParaRPr lang="en-US" sz="900" dirty="0">
                         <a:latin typeface="Figtree" charset="0"/>
@@ -4701,7 +4746,51 @@
                           <a:ea typeface="Figtree" pitchFamily="34" charset="-122"/>
                           <a:cs typeface="Figtree" pitchFamily="34" charset="-120"/>
                         </a:rPr>
-                        <a:t>Form contatto generico (generate_lead)</a:t>
+                        <a:t>Preventivo LP (landing rivenditori)</a:t>
+                      </a:r>
+                      <a:endParaRPr lang="en-US" sz="1000" dirty="0">
+                        <a:latin typeface="Figtree" charset="0"/>
+                        <a:ea typeface="Figtree" charset="0"/>
+                        <a:cs typeface="Figtree" charset="0"/>
+                      </a:endParaRPr>
+                    </a:p>
+                  </a:txBody>
+                  <a:tcPr marL="91440" marR="91440" marT="45720" marB="45720">
+                    <a:lnL w="0" cap="flat" cmpd="sng" algn="ctr">
+                      <a:noFill/>
+                    </a:lnL>
+                    <a:lnR w="0" cap="flat" cmpd="sng" algn="ctr">
+                      <a:noFill/>
+                    </a:lnR>
+                    <a:lnT w="0" cap="flat" cmpd="sng" algn="ctr">
+                      <a:noFill/>
+                    </a:lnT>
+                    <a:lnB w="0" cap="flat" cmpd="sng" algn="ctr">
+                      <a:noFill/>
+                    </a:lnB>
+                    <a:solidFill>
+                      <a:srgbClr val="FFFFFF"/>
+                    </a:solidFill>
+                  </a:tcPr>
+                </a:tc>
+                <a:tc>
+                  <a:txBody>
+                    <a:bodyPr/>
+                    <a:lstStyle/>
+                    <a:p>
+                      <a:pPr algn="l" indent="0" marL="0">
+                        <a:buNone/>
+                      </a:pPr>
+                      <a:r>
+                        <a:rPr lang="en-US" sz="1000" dirty="0">
+                          <a:solidFill>
+                            <a:srgbClr val="191919"/>
+                          </a:solidFill>
+                          <a:latin typeface="Figtree" pitchFamily="34" charset="0"/>
+                          <a:ea typeface="Figtree" pitchFamily="34" charset="-122"/>
+                          <a:cs typeface="Figtree" pitchFamily="34" charset="-120"/>
+                        </a:rPr>
+                        <a:t>HubSpot</a:t>
                       </a:r>
                       <a:endParaRPr lang="en-US" sz="1000" dirty="0">
                         <a:latin typeface="Figtree" charset="0"/>
@@ -4745,363 +4834,7 @@
                           <a:ea typeface="Figtree" pitchFamily="34" charset="-122"/>
                           <a:cs typeface="Figtree" pitchFamily="34" charset="-120"/>
                         </a:rPr>
-                        <a:t>231</a:t>
-                      </a:r>
-                      <a:endParaRPr lang="en-US" sz="1000" dirty="0">
-                        <a:latin typeface="Figtree" charset="0"/>
-                        <a:ea typeface="Figtree" charset="0"/>
-                        <a:cs typeface="Figtree" charset="0"/>
-                      </a:endParaRPr>
-                    </a:p>
-                  </a:txBody>
-                  <a:tcPr marL="91440" marR="91440" marT="45720" marB="45720">
-                    <a:lnL w="0" cap="flat" cmpd="sng" algn="ctr">
-                      <a:noFill/>
-                    </a:lnL>
-                    <a:lnR w="0" cap="flat" cmpd="sng" algn="ctr">
-                      <a:noFill/>
-                    </a:lnR>
-                    <a:lnT w="0" cap="flat" cmpd="sng" algn="ctr">
-                      <a:noFill/>
-                    </a:lnT>
-                    <a:lnB w="0" cap="flat" cmpd="sng" algn="ctr">
-                      <a:noFill/>
-                    </a:lnB>
-                    <a:solidFill>
-                      <a:srgbClr val="FFFFFF"/>
-                    </a:solidFill>
-                  </a:tcPr>
-                </a:tc>
-                <a:tc>
-                  <a:txBody>
-                    <a:bodyPr/>
-                    <a:lstStyle/>
-                    <a:p>
-                      <a:pPr algn="r" indent="0" marL="0">
-                        <a:buNone/>
-                      </a:pPr>
-                      <a:r>
-                        <a:rPr lang="en-US" sz="1000" dirty="0">
-                          <a:solidFill>
-                            <a:srgbClr val="191919"/>
-                          </a:solidFill>
-                          <a:latin typeface="Figtree" pitchFamily="34" charset="0"/>
-                          <a:ea typeface="Figtree" pitchFamily="34" charset="-122"/>
-                          <a:cs typeface="Figtree" pitchFamily="34" charset="-120"/>
-                        </a:rPr>
-                        <a:t>193</a:t>
-                      </a:r>
-                      <a:endParaRPr lang="en-US" sz="1000" dirty="0">
-                        <a:latin typeface="Figtree" charset="0"/>
-                        <a:ea typeface="Figtree" charset="0"/>
-                        <a:cs typeface="Figtree" charset="0"/>
-                      </a:endParaRPr>
-                    </a:p>
-                  </a:txBody>
-                  <a:tcPr marL="91440" marR="91440" marT="45720" marB="45720">
-                    <a:lnL w="0" cap="flat" cmpd="sng" algn="ctr">
-                      <a:noFill/>
-                    </a:lnL>
-                    <a:lnR w="0" cap="flat" cmpd="sng" algn="ctr">
-                      <a:noFill/>
-                    </a:lnR>
-                    <a:lnT w="0" cap="flat" cmpd="sng" algn="ctr">
-                      <a:noFill/>
-                    </a:lnT>
-                    <a:lnB w="0" cap="flat" cmpd="sng" algn="ctr">
-                      <a:noFill/>
-                    </a:lnB>
-                    <a:solidFill>
-                      <a:srgbClr val="FFFFFF"/>
-                    </a:solidFill>
-                  </a:tcPr>
-                </a:tc>
-                <a:tc>
-                  <a:txBody>
-                    <a:bodyPr/>
-                    <a:lstStyle/>
-                    <a:p>
-                      <a:pPr algn="r" indent="0" marL="0">
-                        <a:buNone/>
-                      </a:pPr>
-                      <a:r>
-                        <a:rPr lang="en-US" sz="1000" dirty="0">
-                          <a:solidFill>
-                            <a:srgbClr val="118541"/>
-                          </a:solidFill>
-                          <a:latin typeface="Figtree" pitchFamily="34" charset="0"/>
-                          <a:ea typeface="Figtree" pitchFamily="34" charset="-122"/>
-                          <a:cs typeface="Figtree" pitchFamily="34" charset="-120"/>
-                        </a:rPr>
-                        <a:t>+19,7%</a:t>
-                      </a:r>
-                      <a:endParaRPr lang="en-US" sz="1000" dirty="0">
-                        <a:latin typeface="Figtree" charset="0"/>
-                        <a:ea typeface="Figtree" charset="0"/>
-                        <a:cs typeface="Figtree" charset="0"/>
-                      </a:endParaRPr>
-                    </a:p>
-                  </a:txBody>
-                  <a:tcPr marL="91440" marR="91440" marT="45720" marB="45720">
-                    <a:lnL w="0" cap="flat" cmpd="sng" algn="ctr">
-                      <a:noFill/>
-                    </a:lnL>
-                    <a:lnR w="0" cap="flat" cmpd="sng" algn="ctr">
-                      <a:noFill/>
-                    </a:lnR>
-                    <a:lnT w="0" cap="flat" cmpd="sng" algn="ctr">
-                      <a:noFill/>
-                    </a:lnT>
-                    <a:lnB w="0" cap="flat" cmpd="sng" algn="ctr">
-                      <a:noFill/>
-                    </a:lnB>
-                    <a:solidFill>
-                      <a:srgbClr val="FFFFFF"/>
-                    </a:solidFill>
-                  </a:tcPr>
-                </a:tc>
-              </a:tr>
-              <a:tr h="365760">
-                <a:tc>
-                  <a:txBody>
-                    <a:bodyPr/>
-                    <a:lstStyle/>
-                    <a:p>
-                      <a:pPr algn="l" indent="0" marL="0">
-                        <a:buNone/>
-                      </a:pPr>
-                      <a:r>
-                        <a:rPr lang="en-US" sz="1000" dirty="0">
-                          <a:solidFill>
-                            <a:srgbClr val="191919"/>
-                          </a:solidFill>
-                          <a:latin typeface="Figtree" pitchFamily="34" charset="0"/>
-                          <a:ea typeface="Figtree" pitchFamily="34" charset="-122"/>
-                          <a:cs typeface="Figtree" pitchFamily="34" charset="-120"/>
-                        </a:rPr>
-                        <a:t>Invii form landing rivenditori</a:t>
-                      </a:r>
-                      <a:endParaRPr lang="en-US" sz="1000" dirty="0">
-                        <a:latin typeface="Figtree" charset="0"/>
-                        <a:ea typeface="Figtree" charset="0"/>
-                        <a:cs typeface="Figtree" charset="0"/>
-                      </a:endParaRPr>
-                    </a:p>
-                  </a:txBody>
-                  <a:tcPr marL="91440" marR="91440" marT="45720" marB="45720">
-                    <a:lnL w="0" cap="flat" cmpd="sng" algn="ctr">
-                      <a:noFill/>
-                    </a:lnL>
-                    <a:lnR w="0" cap="flat" cmpd="sng" algn="ctr">
-                      <a:noFill/>
-                    </a:lnR>
-                    <a:lnT w="0" cap="flat" cmpd="sng" algn="ctr">
-                      <a:noFill/>
-                    </a:lnT>
-                    <a:lnB w="0" cap="flat" cmpd="sng" algn="ctr">
-                      <a:noFill/>
-                    </a:lnB>
-                    <a:solidFill>
-                      <a:srgbClr val="F4F5F6"/>
-                    </a:solidFill>
-                  </a:tcPr>
-                </a:tc>
-                <a:tc>
-                  <a:txBody>
-                    <a:bodyPr/>
-                    <a:lstStyle/>
-                    <a:p>
-                      <a:pPr algn="r" indent="0" marL="0">
-                        <a:buNone/>
-                      </a:pPr>
-                      <a:r>
-                        <a:rPr lang="en-US" sz="1000" dirty="0">
-                          <a:solidFill>
-                            <a:srgbClr val="191919"/>
-                          </a:solidFill>
-                          <a:latin typeface="Figtree" pitchFamily="34" charset="0"/>
-                          <a:ea typeface="Figtree" pitchFamily="34" charset="-122"/>
-                          <a:cs typeface="Figtree" pitchFamily="34" charset="-120"/>
-                        </a:rPr>
-                        <a:t>155</a:t>
-                      </a:r>
-                      <a:endParaRPr lang="en-US" sz="1000" dirty="0">
-                        <a:latin typeface="Figtree" charset="0"/>
-                        <a:ea typeface="Figtree" charset="0"/>
-                        <a:cs typeface="Figtree" charset="0"/>
-                      </a:endParaRPr>
-                    </a:p>
-                  </a:txBody>
-                  <a:tcPr marL="91440" marR="91440" marT="45720" marB="45720">
-                    <a:lnL w="0" cap="flat" cmpd="sng" algn="ctr">
-                      <a:noFill/>
-                    </a:lnL>
-                    <a:lnR w="0" cap="flat" cmpd="sng" algn="ctr">
-                      <a:noFill/>
-                    </a:lnR>
-                    <a:lnT w="0" cap="flat" cmpd="sng" algn="ctr">
-                      <a:noFill/>
-                    </a:lnT>
-                    <a:lnB w="0" cap="flat" cmpd="sng" algn="ctr">
-                      <a:noFill/>
-                    </a:lnB>
-                    <a:solidFill>
-                      <a:srgbClr val="F4F5F6"/>
-                    </a:solidFill>
-                  </a:tcPr>
-                </a:tc>
-                <a:tc>
-                  <a:txBody>
-                    <a:bodyPr/>
-                    <a:lstStyle/>
-                    <a:p>
-                      <a:pPr algn="r" indent="0" marL="0">
-                        <a:buNone/>
-                      </a:pPr>
-                      <a:r>
-                        <a:rPr lang="en-US" sz="1000" dirty="0">
-                          <a:solidFill>
-                            <a:srgbClr val="191919"/>
-                          </a:solidFill>
-                          <a:latin typeface="Figtree" pitchFamily="34" charset="0"/>
-                          <a:ea typeface="Figtree" pitchFamily="34" charset="-122"/>
-                          <a:cs typeface="Figtree" pitchFamily="34" charset="-120"/>
-                        </a:rPr>
-                        <a:t>-</a:t>
-                      </a:r>
-                      <a:endParaRPr lang="en-US" sz="1000" dirty="0">
-                        <a:latin typeface="Figtree" charset="0"/>
-                        <a:ea typeface="Figtree" charset="0"/>
-                        <a:cs typeface="Figtree" charset="0"/>
-                      </a:endParaRPr>
-                    </a:p>
-                  </a:txBody>
-                  <a:tcPr marL="91440" marR="91440" marT="45720" marB="45720">
-                    <a:lnL w="0" cap="flat" cmpd="sng" algn="ctr">
-                      <a:noFill/>
-                    </a:lnL>
-                    <a:lnR w="0" cap="flat" cmpd="sng" algn="ctr">
-                      <a:noFill/>
-                    </a:lnR>
-                    <a:lnT w="0" cap="flat" cmpd="sng" algn="ctr">
-                      <a:noFill/>
-                    </a:lnT>
-                    <a:lnB w="0" cap="flat" cmpd="sng" algn="ctr">
-                      <a:noFill/>
-                    </a:lnB>
-                    <a:solidFill>
-                      <a:srgbClr val="F4F5F6"/>
-                    </a:solidFill>
-                  </a:tcPr>
-                </a:tc>
-                <a:tc>
-                  <a:txBody>
-                    <a:bodyPr/>
-                    <a:lstStyle/>
-                    <a:p>
-                      <a:pPr algn="r" indent="0" marL="0">
-                        <a:buNone/>
-                      </a:pPr>
-                      <a:r>
-                        <a:rPr lang="en-US" sz="1000" dirty="0">
-                          <a:solidFill>
-                            <a:srgbClr val="191919"/>
-                          </a:solidFill>
-                          <a:latin typeface="Figtree" pitchFamily="34" charset="0"/>
-                          <a:ea typeface="Figtree" pitchFamily="34" charset="-122"/>
-                          <a:cs typeface="Figtree" pitchFamily="34" charset="-120"/>
-                        </a:rPr>
-                        <a:t>nuovo</a:t>
-                      </a:r>
-                      <a:endParaRPr lang="en-US" sz="1000" dirty="0">
-                        <a:latin typeface="Figtree" charset="0"/>
-                        <a:ea typeface="Figtree" charset="0"/>
-                        <a:cs typeface="Figtree" charset="0"/>
-                      </a:endParaRPr>
-                    </a:p>
-                  </a:txBody>
-                  <a:tcPr marL="91440" marR="91440" marT="45720" marB="45720">
-                    <a:lnL w="0" cap="flat" cmpd="sng" algn="ctr">
-                      <a:noFill/>
-                    </a:lnL>
-                    <a:lnR w="0" cap="flat" cmpd="sng" algn="ctr">
-                      <a:noFill/>
-                    </a:lnR>
-                    <a:lnT w="0" cap="flat" cmpd="sng" algn="ctr">
-                      <a:noFill/>
-                    </a:lnT>
-                    <a:lnB w="0" cap="flat" cmpd="sng" algn="ctr">
-                      <a:noFill/>
-                    </a:lnB>
-                    <a:solidFill>
-                      <a:srgbClr val="F4F5F6"/>
-                    </a:solidFill>
-                  </a:tcPr>
-                </a:tc>
-              </a:tr>
-              <a:tr h="365760">
-                <a:tc>
-                  <a:txBody>
-                    <a:bodyPr/>
-                    <a:lstStyle/>
-                    <a:p>
-                      <a:pPr algn="l" indent="0" marL="0">
-                        <a:buNone/>
-                      </a:pPr>
-                      <a:r>
-                        <a:rPr lang="en-US" sz="1000" dirty="0">
-                          <a:solidFill>
-                            <a:srgbClr val="191919"/>
-                          </a:solidFill>
-                          <a:latin typeface="Figtree" pitchFamily="34" charset="0"/>
-                          <a:ea typeface="Figtree" pitchFamily="34" charset="-122"/>
-                          <a:cs typeface="Figtree" pitchFamily="34" charset="-120"/>
-                        </a:rPr>
-                        <a:t>Richieste informazioni prodotto</a:t>
-                      </a:r>
-                      <a:endParaRPr lang="en-US" sz="1000" dirty="0">
-                        <a:latin typeface="Figtree" charset="0"/>
-                        <a:ea typeface="Figtree" charset="0"/>
-                        <a:cs typeface="Figtree" charset="0"/>
-                      </a:endParaRPr>
-                    </a:p>
-                  </a:txBody>
-                  <a:tcPr marL="91440" marR="91440" marT="45720" marB="45720">
-                    <a:lnL w="0" cap="flat" cmpd="sng" algn="ctr">
-                      <a:noFill/>
-                    </a:lnL>
-                    <a:lnR w="0" cap="flat" cmpd="sng" algn="ctr">
-                      <a:noFill/>
-                    </a:lnR>
-                    <a:lnT w="0" cap="flat" cmpd="sng" algn="ctr">
-                      <a:noFill/>
-                    </a:lnT>
-                    <a:lnB w="0" cap="flat" cmpd="sng" algn="ctr">
-                      <a:noFill/>
-                    </a:lnB>
-                    <a:solidFill>
-                      <a:srgbClr val="FFFFFF"/>
-                    </a:solidFill>
-                  </a:tcPr>
-                </a:tc>
-                <a:tc>
-                  <a:txBody>
-                    <a:bodyPr/>
-                    <a:lstStyle/>
-                    <a:p>
-                      <a:pPr algn="r" indent="0" marL="0">
-                        <a:buNone/>
-                      </a:pPr>
-                      <a:r>
-                        <a:rPr lang="en-US" sz="1000" dirty="0">
-                          <a:solidFill>
-                            <a:srgbClr val="191919"/>
-                          </a:solidFill>
-                          <a:latin typeface="Figtree" pitchFamily="34" charset="0"/>
-                          <a:ea typeface="Figtree" pitchFamily="34" charset="-122"/>
-                          <a:cs typeface="Figtree" pitchFamily="34" charset="-120"/>
-                        </a:rPr>
-                        <a:t>84</a:t>
+                        <a:t>215</a:t>
                       </a:r>
                       <a:endParaRPr lang="en-US" sz="1000" dirty="0">
                         <a:latin typeface="Figtree" charset="0"/>
@@ -5235,7 +4968,51 @@
                           <a:ea typeface="Figtree" pitchFamily="34" charset="-122"/>
                           <a:cs typeface="Figtree" pitchFamily="34" charset="-120"/>
                         </a:rPr>
-                        <a:t>Download magazine FEEL</a:t>
+                        <a:t>Info prodotto (totale)</a:t>
+                      </a:r>
+                      <a:endParaRPr lang="en-US" sz="1000" dirty="0">
+                        <a:latin typeface="Figtree" charset="0"/>
+                        <a:ea typeface="Figtree" charset="0"/>
+                        <a:cs typeface="Figtree" charset="0"/>
+                      </a:endParaRPr>
+                    </a:p>
+                  </a:txBody>
+                  <a:tcPr marL="91440" marR="91440" marT="45720" marB="45720">
+                    <a:lnL w="0" cap="flat" cmpd="sng" algn="ctr">
+                      <a:noFill/>
+                    </a:lnL>
+                    <a:lnR w="0" cap="flat" cmpd="sng" algn="ctr">
+                      <a:noFill/>
+                    </a:lnR>
+                    <a:lnT w="0" cap="flat" cmpd="sng" algn="ctr">
+                      <a:noFill/>
+                    </a:lnT>
+                    <a:lnB w="0" cap="flat" cmpd="sng" algn="ctr">
+                      <a:noFill/>
+                    </a:lnB>
+                    <a:solidFill>
+                      <a:srgbClr val="F4F5F6"/>
+                    </a:solidFill>
+                  </a:tcPr>
+                </a:tc>
+                <a:tc>
+                  <a:txBody>
+                    <a:bodyPr/>
+                    <a:lstStyle/>
+                    <a:p>
+                      <a:pPr algn="l" indent="0" marL="0">
+                        <a:buNone/>
+                      </a:pPr>
+                      <a:r>
+                        <a:rPr lang="en-US" sz="1000" dirty="0">
+                          <a:solidFill>
+                            <a:srgbClr val="191919"/>
+                          </a:solidFill>
+                          <a:latin typeface="Figtree" pitchFamily="34" charset="0"/>
+                          <a:ea typeface="Figtree" pitchFamily="34" charset="-122"/>
+                          <a:cs typeface="Figtree" pitchFamily="34" charset="-120"/>
+                        </a:rPr>
+                        <a:t>HubSpot + MyArea</a:t>
                       </a:r>
                       <a:endParaRPr lang="en-US" sz="1000" dirty="0">
                         <a:latin typeface="Figtree" charset="0"/>
@@ -5279,7 +5056,7 @@
                           <a:ea typeface="Figtree" pitchFamily="34" charset="-122"/>
                           <a:cs typeface="Figtree" pitchFamily="34" charset="-120"/>
                         </a:rPr>
-                        <a:t>35</a:t>
+                        <a:t>61</a:t>
                       </a:r>
                       <a:endParaRPr lang="en-US" sz="1000" dirty="0">
                         <a:latin typeface="Figtree" charset="0"/>
@@ -5323,7 +5100,7 @@
                           <a:ea typeface="Figtree" pitchFamily="34" charset="-122"/>
                           <a:cs typeface="Figtree" pitchFamily="34" charset="-120"/>
                         </a:rPr>
-                        <a:t>69</a:t>
+                        <a:t>100</a:t>
                       </a:r>
                       <a:endParaRPr lang="en-US" sz="1000" dirty="0">
                         <a:latin typeface="Figtree" charset="0"/>
@@ -5367,7 +5144,7 @@
                           <a:ea typeface="Figtree" pitchFamily="34" charset="-122"/>
                           <a:cs typeface="Figtree" pitchFamily="34" charset="-120"/>
                         </a:rPr>
-                        <a:t>-49,3%</a:t>
+                        <a:t>-39,0%</a:t>
                       </a:r>
                       <a:endParaRPr lang="en-US" sz="1000" dirty="0">
                         <a:latin typeface="Figtree" charset="0"/>
@@ -5413,7 +5190,51 @@
                           <a:ea typeface="Figtree" pitchFamily="34" charset="-122"/>
                           <a:cs typeface="Figtree" pitchFamily="34" charset="-120"/>
                         </a:rPr>
-                        <a:t>Registrazione Area Pro</a:t>
+                        <a:t>Registrazioni area</a:t>
+                      </a:r>
+                      <a:endParaRPr lang="en-US" sz="1000" dirty="0">
+                        <a:latin typeface="Figtree" charset="0"/>
+                        <a:ea typeface="Figtree" charset="0"/>
+                        <a:cs typeface="Figtree" charset="0"/>
+                      </a:endParaRPr>
+                    </a:p>
+                  </a:txBody>
+                  <a:tcPr marL="91440" marR="91440" marT="45720" marB="45720">
+                    <a:lnL w="0" cap="flat" cmpd="sng" algn="ctr">
+                      <a:noFill/>
+                    </a:lnL>
+                    <a:lnR w="0" cap="flat" cmpd="sng" algn="ctr">
+                      <a:noFill/>
+                    </a:lnR>
+                    <a:lnT w="0" cap="flat" cmpd="sng" algn="ctr">
+                      <a:noFill/>
+                    </a:lnT>
+                    <a:lnB w="0" cap="flat" cmpd="sng" algn="ctr">
+                      <a:noFill/>
+                    </a:lnB>
+                    <a:solidFill>
+                      <a:srgbClr val="FFFFFF"/>
+                    </a:solidFill>
+                  </a:tcPr>
+                </a:tc>
+                <a:tc>
+                  <a:txBody>
+                    <a:bodyPr/>
+                    <a:lstStyle/>
+                    <a:p>
+                      <a:pPr algn="l" indent="0" marL="0">
+                        <a:buNone/>
+                      </a:pPr>
+                      <a:r>
+                        <a:rPr lang="en-US" sz="1000" dirty="0">
+                          <a:solidFill>
+                            <a:srgbClr val="191919"/>
+                          </a:solidFill>
+                          <a:latin typeface="Figtree" pitchFamily="34" charset="0"/>
+                          <a:ea typeface="Figtree" pitchFamily="34" charset="-122"/>
+                          <a:cs typeface="Figtree" pitchFamily="34" charset="-120"/>
+                        </a:rPr>
+                        <a:t>HubSpot</a:t>
                       </a:r>
                       <a:endParaRPr lang="en-US" sz="1000" dirty="0">
                         <a:latin typeface="Figtree" charset="0"/>
@@ -5457,7 +5278,7 @@
                           <a:ea typeface="Figtree" pitchFamily="34" charset="-122"/>
                           <a:cs typeface="Figtree" pitchFamily="34" charset="-120"/>
                         </a:rPr>
-                        <a:t>33</a:t>
+                        <a:t>56</a:t>
                       </a:r>
                       <a:endParaRPr lang="en-US" sz="1000" dirty="0">
                         <a:latin typeface="Figtree" charset="0"/>
@@ -5501,7 +5322,7 @@
                           <a:ea typeface="Figtree" pitchFamily="34" charset="-122"/>
                           <a:cs typeface="Figtree" pitchFamily="34" charset="-120"/>
                         </a:rPr>
-                        <a:t>24</a:t>
+                        <a:t>55</a:t>
                       </a:r>
                       <a:endParaRPr lang="en-US" sz="1000" dirty="0">
                         <a:latin typeface="Figtree" charset="0"/>
@@ -5545,7 +5366,7 @@
                           <a:ea typeface="Figtree" pitchFamily="34" charset="-122"/>
                           <a:cs typeface="Figtree" pitchFamily="34" charset="-120"/>
                         </a:rPr>
-                        <a:t>+37,5%</a:t>
+                        <a:t>+1,8%</a:t>
                       </a:r>
                       <a:endParaRPr lang="en-US" sz="1000" dirty="0">
                         <a:latin typeface="Figtree" charset="0"/>
@@ -5591,7 +5412,51 @@
                           <a:ea typeface="Figtree" pitchFamily="34" charset="-122"/>
                           <a:cs typeface="Figtree" pitchFamily="34" charset="-120"/>
                         </a:rPr>
-                        <a:t>Form contatto sito</a:t>
+                        <a:t>FEEL5</a:t>
+                      </a:r>
+                      <a:endParaRPr lang="en-US" sz="1000" dirty="0">
+                        <a:latin typeface="Figtree" charset="0"/>
+                        <a:ea typeface="Figtree" charset="0"/>
+                        <a:cs typeface="Figtree" charset="0"/>
+                      </a:endParaRPr>
+                    </a:p>
+                  </a:txBody>
+                  <a:tcPr marL="91440" marR="91440" marT="45720" marB="45720">
+                    <a:lnL w="0" cap="flat" cmpd="sng" algn="ctr">
+                      <a:noFill/>
+                    </a:lnL>
+                    <a:lnR w="0" cap="flat" cmpd="sng" algn="ctr">
+                      <a:noFill/>
+                    </a:lnR>
+                    <a:lnT w="0" cap="flat" cmpd="sng" algn="ctr">
+                      <a:noFill/>
+                    </a:lnT>
+                    <a:lnB w="0" cap="flat" cmpd="sng" algn="ctr">
+                      <a:noFill/>
+                    </a:lnB>
+                    <a:solidFill>
+                      <a:srgbClr val="F4F5F6"/>
+                    </a:solidFill>
+                  </a:tcPr>
+                </a:tc>
+                <a:tc>
+                  <a:txBody>
+                    <a:bodyPr/>
+                    <a:lstStyle/>
+                    <a:p>
+                      <a:pPr algn="l" indent="0" marL="0">
+                        <a:buNone/>
+                      </a:pPr>
+                      <a:r>
+                        <a:rPr lang="en-US" sz="1000" dirty="0">
+                          <a:solidFill>
+                            <a:srgbClr val="191919"/>
+                          </a:solidFill>
+                          <a:latin typeface="Figtree" pitchFamily="34" charset="0"/>
+                          <a:ea typeface="Figtree" pitchFamily="34" charset="-122"/>
+                          <a:cs typeface="Figtree" pitchFamily="34" charset="-120"/>
+                        </a:rPr>
+                        <a:t>HubSpot</a:t>
                       </a:r>
                       <a:endParaRPr lang="en-US" sz="1000" dirty="0">
                         <a:latin typeface="Figtree" charset="0"/>
@@ -5635,7 +5500,7 @@
                           <a:ea typeface="Figtree" pitchFamily="34" charset="-122"/>
                           <a:cs typeface="Figtree" pitchFamily="34" charset="-120"/>
                         </a:rPr>
-                        <a:t>19</a:t>
+                        <a:t>54</a:t>
                       </a:r>
                       <a:endParaRPr lang="en-US" sz="1000" dirty="0">
                         <a:latin typeface="Figtree" charset="0"/>
@@ -5679,7 +5544,7 @@
                           <a:ea typeface="Figtree" pitchFamily="34" charset="-122"/>
                           <a:cs typeface="Figtree" pitchFamily="34" charset="-120"/>
                         </a:rPr>
-                        <a:t>22</a:t>
+                        <a:t>99</a:t>
                       </a:r>
                       <a:endParaRPr lang="en-US" sz="1000" dirty="0">
                         <a:latin typeface="Figtree" charset="0"/>
@@ -5723,7 +5588,7 @@
                           <a:ea typeface="Figtree" pitchFamily="34" charset="-122"/>
                           <a:cs typeface="Figtree" pitchFamily="34" charset="-120"/>
                         </a:rPr>
-                        <a:t>-13,6%</a:t>
+                        <a:t>-45,5%</a:t>
                       </a:r>
                       <a:endParaRPr lang="en-US" sz="1000" dirty="0">
                         <a:latin typeface="Figtree" charset="0"/>
@@ -5769,7 +5634,51 @@
                           <a:ea typeface="Figtree" pitchFamily="34" charset="-122"/>
                           <a:cs typeface="Figtree" pitchFamily="34" charset="-120"/>
                         </a:rPr>
-                        <a:t>Clic iscrizione professionisti</a:t>
+                        <a:t>Form contatto (IT/EN/ES/FR)</a:t>
+                      </a:r>
+                      <a:endParaRPr lang="en-US" sz="1000" dirty="0">
+                        <a:latin typeface="Figtree" charset="0"/>
+                        <a:ea typeface="Figtree" charset="0"/>
+                        <a:cs typeface="Figtree" charset="0"/>
+                      </a:endParaRPr>
+                    </a:p>
+                  </a:txBody>
+                  <a:tcPr marL="91440" marR="91440" marT="45720" marB="45720">
+                    <a:lnL w="0" cap="flat" cmpd="sng" algn="ctr">
+                      <a:noFill/>
+                    </a:lnL>
+                    <a:lnR w="0" cap="flat" cmpd="sng" algn="ctr">
+                      <a:noFill/>
+                    </a:lnR>
+                    <a:lnT w="0" cap="flat" cmpd="sng" algn="ctr">
+                      <a:noFill/>
+                    </a:lnT>
+                    <a:lnB w="0" cap="flat" cmpd="sng" algn="ctr">
+                      <a:noFill/>
+                    </a:lnB>
+                    <a:solidFill>
+                      <a:srgbClr val="FFFFFF"/>
+                    </a:solidFill>
+                  </a:tcPr>
+                </a:tc>
+                <a:tc>
+                  <a:txBody>
+                    <a:bodyPr/>
+                    <a:lstStyle/>
+                    <a:p>
+                      <a:pPr algn="l" indent="0" marL="0">
+                        <a:buNone/>
+                      </a:pPr>
+                      <a:r>
+                        <a:rPr lang="en-US" sz="1000" dirty="0">
+                          <a:solidFill>
+                            <a:srgbClr val="191919"/>
+                          </a:solidFill>
+                          <a:latin typeface="Figtree" pitchFamily="34" charset="0"/>
+                          <a:ea typeface="Figtree" pitchFamily="34" charset="-122"/>
+                          <a:cs typeface="Figtree" pitchFamily="34" charset="-120"/>
+                        </a:rPr>
+                        <a:t>HubSpot</a:t>
                       </a:r>
                       <a:endParaRPr lang="en-US" sz="1000" dirty="0">
                         <a:latin typeface="Figtree" charset="0"/>
@@ -5813,7 +5722,7 @@
                           <a:ea typeface="Figtree" pitchFamily="34" charset="-122"/>
                           <a:cs typeface="Figtree" pitchFamily="34" charset="-120"/>
                         </a:rPr>
-                        <a:t>15</a:t>
+                        <a:t>38</a:t>
                       </a:r>
                       <a:endParaRPr lang="en-US" sz="1000" dirty="0">
                         <a:latin typeface="Figtree" charset="0"/>
@@ -5857,7 +5766,7 @@
                           <a:ea typeface="Figtree" pitchFamily="34" charset="-122"/>
                           <a:cs typeface="Figtree" pitchFamily="34" charset="-120"/>
                         </a:rPr>
-                        <a:t>14</a:t>
+                        <a:t>36</a:t>
                       </a:r>
                       <a:endParaRPr lang="en-US" sz="1000" dirty="0">
                         <a:latin typeface="Figtree" charset="0"/>
@@ -5901,7 +5810,7 @@
                           <a:ea typeface="Figtree" pitchFamily="34" charset="-122"/>
                           <a:cs typeface="Figtree" pitchFamily="34" charset="-120"/>
                         </a:rPr>
-                        <a:t>+7,1%</a:t>
+                        <a:t>+5,6%</a:t>
                       </a:r>
                       <a:endParaRPr lang="en-US" sz="1000" dirty="0">
                         <a:latin typeface="Figtree" charset="0"/>
@@ -5925,6 +5834,672 @@
                     </a:lnB>
                     <a:solidFill>
                       <a:srgbClr val="FFFFFF"/>
+                    </a:solidFill>
+                  </a:tcPr>
+                </a:tc>
+              </a:tr>
+              <a:tr h="365760">
+                <a:tc>
+                  <a:txBody>
+                    <a:bodyPr/>
+                    <a:lstStyle/>
+                    <a:p>
+                      <a:pPr algn="l" indent="0" marL="0">
+                        <a:buNone/>
+                      </a:pPr>
+                      <a:r>
+                        <a:rPr lang="en-US" sz="1000" dirty="0">
+                          <a:solidFill>
+                            <a:srgbClr val="191919"/>
+                          </a:solidFill>
+                          <a:latin typeface="Figtree" pitchFamily="34" charset="0"/>
+                          <a:ea typeface="Figtree" pitchFamily="34" charset="-122"/>
+                          <a:cs typeface="Figtree" pitchFamily="34" charset="-120"/>
+                        </a:rPr>
+                        <a:t>Contatta PV</a:t>
+                      </a:r>
+                      <a:endParaRPr lang="en-US" sz="1000" dirty="0">
+                        <a:latin typeface="Figtree" charset="0"/>
+                        <a:ea typeface="Figtree" charset="0"/>
+                        <a:cs typeface="Figtree" charset="0"/>
+                      </a:endParaRPr>
+                    </a:p>
+                  </a:txBody>
+                  <a:tcPr marL="91440" marR="91440" marT="45720" marB="45720">
+                    <a:lnL w="0" cap="flat" cmpd="sng" algn="ctr">
+                      <a:noFill/>
+                    </a:lnL>
+                    <a:lnR w="0" cap="flat" cmpd="sng" algn="ctr">
+                      <a:noFill/>
+                    </a:lnR>
+                    <a:lnT w="0" cap="flat" cmpd="sng" algn="ctr">
+                      <a:noFill/>
+                    </a:lnT>
+                    <a:lnB w="0" cap="flat" cmpd="sng" algn="ctr">
+                      <a:noFill/>
+                    </a:lnB>
+                    <a:solidFill>
+                      <a:srgbClr val="F4F5F6"/>
+                    </a:solidFill>
+                  </a:tcPr>
+                </a:tc>
+                <a:tc>
+                  <a:txBody>
+                    <a:bodyPr/>
+                    <a:lstStyle/>
+                    <a:p>
+                      <a:pPr algn="l" indent="0" marL="0">
+                        <a:buNone/>
+                      </a:pPr>
+                      <a:r>
+                        <a:rPr lang="en-US" sz="1000" dirty="0">
+                          <a:solidFill>
+                            <a:srgbClr val="191919"/>
+                          </a:solidFill>
+                          <a:latin typeface="Figtree" pitchFamily="34" charset="0"/>
+                          <a:ea typeface="Figtree" pitchFamily="34" charset="-122"/>
+                          <a:cs typeface="Figtree" pitchFamily="34" charset="-120"/>
+                        </a:rPr>
+                        <a:t>MyArea</a:t>
+                      </a:r>
+                      <a:endParaRPr lang="en-US" sz="1000" dirty="0">
+                        <a:latin typeface="Figtree" charset="0"/>
+                        <a:ea typeface="Figtree" charset="0"/>
+                        <a:cs typeface="Figtree" charset="0"/>
+                      </a:endParaRPr>
+                    </a:p>
+                  </a:txBody>
+                  <a:tcPr marL="91440" marR="91440" marT="45720" marB="45720">
+                    <a:lnL w="0" cap="flat" cmpd="sng" algn="ctr">
+                      <a:noFill/>
+                    </a:lnL>
+                    <a:lnR w="0" cap="flat" cmpd="sng" algn="ctr">
+                      <a:noFill/>
+                    </a:lnR>
+                    <a:lnT w="0" cap="flat" cmpd="sng" algn="ctr">
+                      <a:noFill/>
+                    </a:lnT>
+                    <a:lnB w="0" cap="flat" cmpd="sng" algn="ctr">
+                      <a:noFill/>
+                    </a:lnB>
+                    <a:solidFill>
+                      <a:srgbClr val="F4F5F6"/>
+                    </a:solidFill>
+                  </a:tcPr>
+                </a:tc>
+                <a:tc>
+                  <a:txBody>
+                    <a:bodyPr/>
+                    <a:lstStyle/>
+                    <a:p>
+                      <a:pPr algn="r" indent="0" marL="0">
+                        <a:buNone/>
+                      </a:pPr>
+                      <a:r>
+                        <a:rPr lang="en-US" sz="1000" dirty="0">
+                          <a:solidFill>
+                            <a:srgbClr val="191919"/>
+                          </a:solidFill>
+                          <a:latin typeface="Figtree" pitchFamily="34" charset="0"/>
+                          <a:ea typeface="Figtree" pitchFamily="34" charset="-122"/>
+                          <a:cs typeface="Figtree" pitchFamily="34" charset="-120"/>
+                        </a:rPr>
+                        <a:t>25</a:t>
+                      </a:r>
+                      <a:endParaRPr lang="en-US" sz="1000" dirty="0">
+                        <a:latin typeface="Figtree" charset="0"/>
+                        <a:ea typeface="Figtree" charset="0"/>
+                        <a:cs typeface="Figtree" charset="0"/>
+                      </a:endParaRPr>
+                    </a:p>
+                  </a:txBody>
+                  <a:tcPr marL="91440" marR="91440" marT="45720" marB="45720">
+                    <a:lnL w="0" cap="flat" cmpd="sng" algn="ctr">
+                      <a:noFill/>
+                    </a:lnL>
+                    <a:lnR w="0" cap="flat" cmpd="sng" algn="ctr">
+                      <a:noFill/>
+                    </a:lnR>
+                    <a:lnT w="0" cap="flat" cmpd="sng" algn="ctr">
+                      <a:noFill/>
+                    </a:lnT>
+                    <a:lnB w="0" cap="flat" cmpd="sng" algn="ctr">
+                      <a:noFill/>
+                    </a:lnB>
+                    <a:solidFill>
+                      <a:srgbClr val="F4F5F6"/>
+                    </a:solidFill>
+                  </a:tcPr>
+                </a:tc>
+                <a:tc>
+                  <a:txBody>
+                    <a:bodyPr/>
+                    <a:lstStyle/>
+                    <a:p>
+                      <a:pPr algn="r" indent="0" marL="0">
+                        <a:buNone/>
+                      </a:pPr>
+                      <a:r>
+                        <a:rPr lang="en-US" sz="1000" dirty="0">
+                          <a:solidFill>
+                            <a:srgbClr val="191919"/>
+                          </a:solidFill>
+                          <a:latin typeface="Figtree" pitchFamily="34" charset="0"/>
+                          <a:ea typeface="Figtree" pitchFamily="34" charset="-122"/>
+                          <a:cs typeface="Figtree" pitchFamily="34" charset="-120"/>
+                        </a:rPr>
+                        <a:t>29</a:t>
+                      </a:r>
+                      <a:endParaRPr lang="en-US" sz="1000" dirty="0">
+                        <a:latin typeface="Figtree" charset="0"/>
+                        <a:ea typeface="Figtree" charset="0"/>
+                        <a:cs typeface="Figtree" charset="0"/>
+                      </a:endParaRPr>
+                    </a:p>
+                  </a:txBody>
+                  <a:tcPr marL="91440" marR="91440" marT="45720" marB="45720">
+                    <a:lnL w="0" cap="flat" cmpd="sng" algn="ctr">
+                      <a:noFill/>
+                    </a:lnL>
+                    <a:lnR w="0" cap="flat" cmpd="sng" algn="ctr">
+                      <a:noFill/>
+                    </a:lnR>
+                    <a:lnT w="0" cap="flat" cmpd="sng" algn="ctr">
+                      <a:noFill/>
+                    </a:lnT>
+                    <a:lnB w="0" cap="flat" cmpd="sng" algn="ctr">
+                      <a:noFill/>
+                    </a:lnB>
+                    <a:solidFill>
+                      <a:srgbClr val="F4F5F6"/>
+                    </a:solidFill>
+                  </a:tcPr>
+                </a:tc>
+                <a:tc>
+                  <a:txBody>
+                    <a:bodyPr/>
+                    <a:lstStyle/>
+                    <a:p>
+                      <a:pPr algn="r" indent="0" marL="0">
+                        <a:buNone/>
+                      </a:pPr>
+                      <a:r>
+                        <a:rPr lang="en-US" sz="1000" dirty="0">
+                          <a:solidFill>
+                            <a:srgbClr val="E52217"/>
+                          </a:solidFill>
+                          <a:latin typeface="Figtree" pitchFamily="34" charset="0"/>
+                          <a:ea typeface="Figtree" pitchFamily="34" charset="-122"/>
+                          <a:cs typeface="Figtree" pitchFamily="34" charset="-120"/>
+                        </a:rPr>
+                        <a:t>-13,8%</a:t>
+                      </a:r>
+                      <a:endParaRPr lang="en-US" sz="1000" dirty="0">
+                        <a:latin typeface="Figtree" charset="0"/>
+                        <a:ea typeface="Figtree" charset="0"/>
+                        <a:cs typeface="Figtree" charset="0"/>
+                      </a:endParaRPr>
+                    </a:p>
+                  </a:txBody>
+                  <a:tcPr marL="91440" marR="91440" marT="45720" marB="45720">
+                    <a:lnL w="0" cap="flat" cmpd="sng" algn="ctr">
+                      <a:noFill/>
+                    </a:lnL>
+                    <a:lnR w="0" cap="flat" cmpd="sng" algn="ctr">
+                      <a:noFill/>
+                    </a:lnR>
+                    <a:lnT w="0" cap="flat" cmpd="sng" algn="ctr">
+                      <a:noFill/>
+                    </a:lnT>
+                    <a:lnB w="0" cap="flat" cmpd="sng" algn="ctr">
+                      <a:noFill/>
+                    </a:lnB>
+                    <a:solidFill>
+                      <a:srgbClr val="F4F5F6"/>
+                    </a:solidFill>
+                  </a:tcPr>
+                </a:tc>
+              </a:tr>
+              <a:tr h="365760">
+                <a:tc>
+                  <a:txBody>
+                    <a:bodyPr/>
+                    <a:lstStyle/>
+                    <a:p>
+                      <a:pPr algn="l" indent="0" marL="0">
+                        <a:buNone/>
+                      </a:pPr>
+                      <a:r>
+                        <a:rPr lang="en-US" sz="1000" dirty="0">
+                          <a:solidFill>
+                            <a:srgbClr val="191919"/>
+                          </a:solidFill>
+                          <a:latin typeface="Figtree" pitchFamily="34" charset="0"/>
+                          <a:ea typeface="Figtree" pitchFamily="34" charset="-122"/>
+                          <a:cs typeface="Figtree" pitchFamily="34" charset="-120"/>
+                        </a:rPr>
+                        <a:t>FEEL4</a:t>
+                      </a:r>
+                      <a:endParaRPr lang="en-US" sz="1000" dirty="0">
+                        <a:latin typeface="Figtree" charset="0"/>
+                        <a:ea typeface="Figtree" charset="0"/>
+                        <a:cs typeface="Figtree" charset="0"/>
+                      </a:endParaRPr>
+                    </a:p>
+                  </a:txBody>
+                  <a:tcPr marL="91440" marR="91440" marT="45720" marB="45720">
+                    <a:lnL w="0" cap="flat" cmpd="sng" algn="ctr">
+                      <a:noFill/>
+                    </a:lnL>
+                    <a:lnR w="0" cap="flat" cmpd="sng" algn="ctr">
+                      <a:noFill/>
+                    </a:lnR>
+                    <a:lnT w="0" cap="flat" cmpd="sng" algn="ctr">
+                      <a:noFill/>
+                    </a:lnT>
+                    <a:lnB w="0" cap="flat" cmpd="sng" algn="ctr">
+                      <a:noFill/>
+                    </a:lnB>
+                    <a:solidFill>
+                      <a:srgbClr val="FFFFFF"/>
+                    </a:solidFill>
+                  </a:tcPr>
+                </a:tc>
+                <a:tc>
+                  <a:txBody>
+                    <a:bodyPr/>
+                    <a:lstStyle/>
+                    <a:p>
+                      <a:pPr algn="l" indent="0" marL="0">
+                        <a:buNone/>
+                      </a:pPr>
+                      <a:r>
+                        <a:rPr lang="en-US" sz="1000" dirty="0">
+                          <a:solidFill>
+                            <a:srgbClr val="191919"/>
+                          </a:solidFill>
+                          <a:latin typeface="Figtree" pitchFamily="34" charset="0"/>
+                          <a:ea typeface="Figtree" pitchFamily="34" charset="-122"/>
+                          <a:cs typeface="Figtree" pitchFamily="34" charset="-120"/>
+                        </a:rPr>
+                        <a:t>HubSpot</a:t>
+                      </a:r>
+                      <a:endParaRPr lang="en-US" sz="1000" dirty="0">
+                        <a:latin typeface="Figtree" charset="0"/>
+                        <a:ea typeface="Figtree" charset="0"/>
+                        <a:cs typeface="Figtree" charset="0"/>
+                      </a:endParaRPr>
+                    </a:p>
+                  </a:txBody>
+                  <a:tcPr marL="91440" marR="91440" marT="45720" marB="45720">
+                    <a:lnL w="0" cap="flat" cmpd="sng" algn="ctr">
+                      <a:noFill/>
+                    </a:lnL>
+                    <a:lnR w="0" cap="flat" cmpd="sng" algn="ctr">
+                      <a:noFill/>
+                    </a:lnR>
+                    <a:lnT w="0" cap="flat" cmpd="sng" algn="ctr">
+                      <a:noFill/>
+                    </a:lnT>
+                    <a:lnB w="0" cap="flat" cmpd="sng" algn="ctr">
+                      <a:noFill/>
+                    </a:lnB>
+                    <a:solidFill>
+                      <a:srgbClr val="FFFFFF"/>
+                    </a:solidFill>
+                  </a:tcPr>
+                </a:tc>
+                <a:tc>
+                  <a:txBody>
+                    <a:bodyPr/>
+                    <a:lstStyle/>
+                    <a:p>
+                      <a:pPr algn="r" indent="0" marL="0">
+                        <a:buNone/>
+                      </a:pPr>
+                      <a:r>
+                        <a:rPr lang="en-US" sz="1000" dirty="0">
+                          <a:solidFill>
+                            <a:srgbClr val="191919"/>
+                          </a:solidFill>
+                          <a:latin typeface="Figtree" pitchFamily="34" charset="0"/>
+                          <a:ea typeface="Figtree" pitchFamily="34" charset="-122"/>
+                          <a:cs typeface="Figtree" pitchFamily="34" charset="-120"/>
+                        </a:rPr>
+                        <a:t>7</a:t>
+                      </a:r>
+                      <a:endParaRPr lang="en-US" sz="1000" dirty="0">
+                        <a:latin typeface="Figtree" charset="0"/>
+                        <a:ea typeface="Figtree" charset="0"/>
+                        <a:cs typeface="Figtree" charset="0"/>
+                      </a:endParaRPr>
+                    </a:p>
+                  </a:txBody>
+                  <a:tcPr marL="91440" marR="91440" marT="45720" marB="45720">
+                    <a:lnL w="0" cap="flat" cmpd="sng" algn="ctr">
+                      <a:noFill/>
+                    </a:lnL>
+                    <a:lnR w="0" cap="flat" cmpd="sng" algn="ctr">
+                      <a:noFill/>
+                    </a:lnR>
+                    <a:lnT w="0" cap="flat" cmpd="sng" algn="ctr">
+                      <a:noFill/>
+                    </a:lnT>
+                    <a:lnB w="0" cap="flat" cmpd="sng" algn="ctr">
+                      <a:noFill/>
+                    </a:lnB>
+                    <a:solidFill>
+                      <a:srgbClr val="FFFFFF"/>
+                    </a:solidFill>
+                  </a:tcPr>
+                </a:tc>
+                <a:tc>
+                  <a:txBody>
+                    <a:bodyPr/>
+                    <a:lstStyle/>
+                    <a:p>
+                      <a:pPr algn="r" indent="0" marL="0">
+                        <a:buNone/>
+                      </a:pPr>
+                      <a:r>
+                        <a:rPr lang="en-US" sz="1000" dirty="0">
+                          <a:solidFill>
+                            <a:srgbClr val="191919"/>
+                          </a:solidFill>
+                          <a:latin typeface="Figtree" pitchFamily="34" charset="0"/>
+                          <a:ea typeface="Figtree" pitchFamily="34" charset="-122"/>
+                          <a:cs typeface="Figtree" pitchFamily="34" charset="-120"/>
+                        </a:rPr>
+                        <a:t>2</a:t>
+                      </a:r>
+                      <a:endParaRPr lang="en-US" sz="1000" dirty="0">
+                        <a:latin typeface="Figtree" charset="0"/>
+                        <a:ea typeface="Figtree" charset="0"/>
+                        <a:cs typeface="Figtree" charset="0"/>
+                      </a:endParaRPr>
+                    </a:p>
+                  </a:txBody>
+                  <a:tcPr marL="91440" marR="91440" marT="45720" marB="45720">
+                    <a:lnL w="0" cap="flat" cmpd="sng" algn="ctr">
+                      <a:noFill/>
+                    </a:lnL>
+                    <a:lnR w="0" cap="flat" cmpd="sng" algn="ctr">
+                      <a:noFill/>
+                    </a:lnR>
+                    <a:lnT w="0" cap="flat" cmpd="sng" algn="ctr">
+                      <a:noFill/>
+                    </a:lnT>
+                    <a:lnB w="0" cap="flat" cmpd="sng" algn="ctr">
+                      <a:noFill/>
+                    </a:lnB>
+                    <a:solidFill>
+                      <a:srgbClr val="FFFFFF"/>
+                    </a:solidFill>
+                  </a:tcPr>
+                </a:tc>
+                <a:tc>
+                  <a:txBody>
+                    <a:bodyPr/>
+                    <a:lstStyle/>
+                    <a:p>
+                      <a:pPr algn="r" indent="0" marL="0">
+                        <a:buNone/>
+                      </a:pPr>
+                      <a:r>
+                        <a:rPr lang="en-US" sz="1000" dirty="0">
+                          <a:solidFill>
+                            <a:srgbClr val="118541"/>
+                          </a:solidFill>
+                          <a:latin typeface="Figtree" pitchFamily="34" charset="0"/>
+                          <a:ea typeface="Figtree" pitchFamily="34" charset="-122"/>
+                          <a:cs typeface="Figtree" pitchFamily="34" charset="-120"/>
+                        </a:rPr>
+                        <a:t>+250,0%</a:t>
+                      </a:r>
+                      <a:endParaRPr lang="en-US" sz="1000" dirty="0">
+                        <a:latin typeface="Figtree" charset="0"/>
+                        <a:ea typeface="Figtree" charset="0"/>
+                        <a:cs typeface="Figtree" charset="0"/>
+                      </a:endParaRPr>
+                    </a:p>
+                  </a:txBody>
+                  <a:tcPr marL="91440" marR="91440" marT="45720" marB="45720">
+                    <a:lnL w="0" cap="flat" cmpd="sng" algn="ctr">
+                      <a:noFill/>
+                    </a:lnL>
+                    <a:lnR w="0" cap="flat" cmpd="sng" algn="ctr">
+                      <a:noFill/>
+                    </a:lnR>
+                    <a:lnT w="0" cap="flat" cmpd="sng" algn="ctr">
+                      <a:noFill/>
+                    </a:lnT>
+                    <a:lnB w="0" cap="flat" cmpd="sng" algn="ctr">
+                      <a:noFill/>
+                    </a:lnB>
+                    <a:solidFill>
+                      <a:srgbClr val="FFFFFF"/>
+                    </a:solidFill>
+                  </a:tcPr>
+                </a:tc>
+              </a:tr>
+              <a:tr h="365760">
+                <a:tc>
+                  <a:txBody>
+                    <a:bodyPr/>
+                    <a:lstStyle/>
+                    <a:p>
+                      <a:pPr algn="l" indent="0" marL="0">
+                        <a:buNone/>
+                      </a:pPr>
+                      <a:r>
+                        <a:rPr lang="en-US" sz="1000" dirty="0">
+                          <a:solidFill>
+                            <a:srgbClr val="191919"/>
+                          </a:solidFill>
+                          <a:latin typeface="Figtree" pitchFamily="34" charset="0"/>
+                          <a:ea typeface="Figtree" pitchFamily="34" charset="-122"/>
+                          <a:cs typeface="Figtree" pitchFamily="34" charset="-120"/>
+                        </a:rPr>
+                        <a:t>Newsletter</a:t>
+                      </a:r>
+                      <a:endParaRPr lang="en-US" sz="1000" dirty="0">
+                        <a:latin typeface="Figtree" charset="0"/>
+                        <a:ea typeface="Figtree" charset="0"/>
+                        <a:cs typeface="Figtree" charset="0"/>
+                      </a:endParaRPr>
+                    </a:p>
+                  </a:txBody>
+                  <a:tcPr marL="91440" marR="91440" marT="45720" marB="45720">
+                    <a:lnL w="0" cap="flat" cmpd="sng" algn="ctr">
+                      <a:noFill/>
+                    </a:lnL>
+                    <a:lnR w="0" cap="flat" cmpd="sng" algn="ctr">
+                      <a:noFill/>
+                    </a:lnR>
+                    <a:lnT w="0" cap="flat" cmpd="sng" algn="ctr">
+                      <a:noFill/>
+                    </a:lnT>
+                    <a:lnB w="0" cap="flat" cmpd="sng" algn="ctr">
+                      <a:noFill/>
+                    </a:lnB>
+                    <a:solidFill>
+                      <a:srgbClr val="F4F5F6"/>
+                    </a:solidFill>
+                  </a:tcPr>
+                </a:tc>
+                <a:tc>
+                  <a:txBody>
+                    <a:bodyPr/>
+                    <a:lstStyle/>
+                    <a:p>
+                      <a:pPr algn="l" indent="0" marL="0">
+                        <a:buNone/>
+                      </a:pPr>
+                      <a:r>
+                        <a:rPr lang="en-US" sz="1000" dirty="0">
+                          <a:solidFill>
+                            <a:srgbClr val="191919"/>
+                          </a:solidFill>
+                          <a:latin typeface="Figtree" pitchFamily="34" charset="0"/>
+                          <a:ea typeface="Figtree" pitchFamily="34" charset="-122"/>
+                          <a:cs typeface="Figtree" pitchFamily="34" charset="-120"/>
+                        </a:rPr>
+                        <a:t>HubSpot</a:t>
+                      </a:r>
+                      <a:endParaRPr lang="en-US" sz="1000" dirty="0">
+                        <a:latin typeface="Figtree" charset="0"/>
+                        <a:ea typeface="Figtree" charset="0"/>
+                        <a:cs typeface="Figtree" charset="0"/>
+                      </a:endParaRPr>
+                    </a:p>
+                  </a:txBody>
+                  <a:tcPr marL="91440" marR="91440" marT="45720" marB="45720">
+                    <a:lnL w="0" cap="flat" cmpd="sng" algn="ctr">
+                      <a:noFill/>
+                    </a:lnL>
+                    <a:lnR w="0" cap="flat" cmpd="sng" algn="ctr">
+                      <a:noFill/>
+                    </a:lnR>
+                    <a:lnT w="0" cap="flat" cmpd="sng" algn="ctr">
+                      <a:noFill/>
+                    </a:lnT>
+                    <a:lnB w="0" cap="flat" cmpd="sng" algn="ctr">
+                      <a:noFill/>
+                    </a:lnB>
+                    <a:solidFill>
+                      <a:srgbClr val="F4F5F6"/>
+                    </a:solidFill>
+                  </a:tcPr>
+                </a:tc>
+                <a:tc>
+                  <a:txBody>
+                    <a:bodyPr/>
+                    <a:lstStyle/>
+                    <a:p>
+                      <a:pPr algn="r" indent="0" marL="0">
+                        <a:buNone/>
+                      </a:pPr>
+                      <a:r>
+                        <a:rPr lang="en-US" sz="1000" dirty="0">
+                          <a:solidFill>
+                            <a:srgbClr val="191919"/>
+                          </a:solidFill>
+                          <a:latin typeface="Figtree" pitchFamily="34" charset="0"/>
+                          <a:ea typeface="Figtree" pitchFamily="34" charset="-122"/>
+                          <a:cs typeface="Figtree" pitchFamily="34" charset="-120"/>
+                        </a:rPr>
+                        <a:t>3</a:t>
+                      </a:r>
+                      <a:endParaRPr lang="en-US" sz="1000" dirty="0">
+                        <a:latin typeface="Figtree" charset="0"/>
+                        <a:ea typeface="Figtree" charset="0"/>
+                        <a:cs typeface="Figtree" charset="0"/>
+                      </a:endParaRPr>
+                    </a:p>
+                  </a:txBody>
+                  <a:tcPr marL="91440" marR="91440" marT="45720" marB="45720">
+                    <a:lnL w="0" cap="flat" cmpd="sng" algn="ctr">
+                      <a:noFill/>
+                    </a:lnL>
+                    <a:lnR w="0" cap="flat" cmpd="sng" algn="ctr">
+                      <a:noFill/>
+                    </a:lnR>
+                    <a:lnT w="0" cap="flat" cmpd="sng" algn="ctr">
+                      <a:noFill/>
+                    </a:lnT>
+                    <a:lnB w="0" cap="flat" cmpd="sng" algn="ctr">
+                      <a:noFill/>
+                    </a:lnB>
+                    <a:solidFill>
+                      <a:srgbClr val="F4F5F6"/>
+                    </a:solidFill>
+                  </a:tcPr>
+                </a:tc>
+                <a:tc>
+                  <a:txBody>
+                    <a:bodyPr/>
+                    <a:lstStyle/>
+                    <a:p>
+                      <a:pPr algn="r" indent="0" marL="0">
+                        <a:buNone/>
+                      </a:pPr>
+                      <a:r>
+                        <a:rPr lang="en-US" sz="1000" dirty="0">
+                          <a:solidFill>
+                            <a:srgbClr val="191919"/>
+                          </a:solidFill>
+                          <a:latin typeface="Figtree" pitchFamily="34" charset="0"/>
+                          <a:ea typeface="Figtree" pitchFamily="34" charset="-122"/>
+                          <a:cs typeface="Figtree" pitchFamily="34" charset="-120"/>
+                        </a:rPr>
+                        <a:t>2</a:t>
+                      </a:r>
+                      <a:endParaRPr lang="en-US" sz="1000" dirty="0">
+                        <a:latin typeface="Figtree" charset="0"/>
+                        <a:ea typeface="Figtree" charset="0"/>
+                        <a:cs typeface="Figtree" charset="0"/>
+                      </a:endParaRPr>
+                    </a:p>
+                  </a:txBody>
+                  <a:tcPr marL="91440" marR="91440" marT="45720" marB="45720">
+                    <a:lnL w="0" cap="flat" cmpd="sng" algn="ctr">
+                      <a:noFill/>
+                    </a:lnL>
+                    <a:lnR w="0" cap="flat" cmpd="sng" algn="ctr">
+                      <a:noFill/>
+                    </a:lnR>
+                    <a:lnT w="0" cap="flat" cmpd="sng" algn="ctr">
+                      <a:noFill/>
+                    </a:lnT>
+                    <a:lnB w="0" cap="flat" cmpd="sng" algn="ctr">
+                      <a:noFill/>
+                    </a:lnB>
+                    <a:solidFill>
+                      <a:srgbClr val="F4F5F6"/>
+                    </a:solidFill>
+                  </a:tcPr>
+                </a:tc>
+                <a:tc>
+                  <a:txBody>
+                    <a:bodyPr/>
+                    <a:lstStyle/>
+                    <a:p>
+                      <a:pPr algn="r" indent="0" marL="0">
+                        <a:buNone/>
+                      </a:pPr>
+                      <a:r>
+                        <a:rPr lang="en-US" sz="1000" dirty="0">
+                          <a:solidFill>
+                            <a:srgbClr val="118541"/>
+                          </a:solidFill>
+                          <a:latin typeface="Figtree" pitchFamily="34" charset="0"/>
+                          <a:ea typeface="Figtree" pitchFamily="34" charset="-122"/>
+                          <a:cs typeface="Figtree" pitchFamily="34" charset="-120"/>
+                        </a:rPr>
+                        <a:t>+50,0%</a:t>
+                      </a:r>
+                      <a:endParaRPr lang="en-US" sz="1000" dirty="0">
+                        <a:latin typeface="Figtree" charset="0"/>
+                        <a:ea typeface="Figtree" charset="0"/>
+                        <a:cs typeface="Figtree" charset="0"/>
+                      </a:endParaRPr>
+                    </a:p>
+                  </a:txBody>
+                  <a:tcPr marL="91440" marR="91440" marT="45720" marB="45720">
+                    <a:lnL w="0" cap="flat" cmpd="sng" algn="ctr">
+                      <a:noFill/>
+                    </a:lnL>
+                    <a:lnR w="0" cap="flat" cmpd="sng" algn="ctr">
+                      <a:noFill/>
+                    </a:lnR>
+                    <a:lnT w="0" cap="flat" cmpd="sng" algn="ctr">
+                      <a:noFill/>
+                    </a:lnT>
+                    <a:lnB w="0" cap="flat" cmpd="sng" algn="ctr">
+                      <a:noFill/>
+                    </a:lnB>
+                    <a:solidFill>
+                      <a:srgbClr val="F4F5F6"/>
                     </a:solidFill>
                   </a:tcPr>
                 </a:tc>
@@ -5947,8 +6522,38 @@
                           <a:ea typeface="Figtree" pitchFamily="34" charset="-122"/>
                           <a:cs typeface="Figtree" pitchFamily="34" charset="-120"/>
                         </a:rPr>
-                        <a:t>Totale eventi lead</a:t>
+                        <a:t>Totale (escl. Preventivo LP)</a:t>
                       </a:r>
+                      <a:endParaRPr lang="en-US" sz="1000" dirty="0">
+                        <a:latin typeface="Figtree" charset="0"/>
+                        <a:ea typeface="Figtree" charset="0"/>
+                        <a:cs typeface="Figtree" charset="0"/>
+                      </a:endParaRPr>
+                    </a:p>
+                  </a:txBody>
+                  <a:tcPr marL="91440" marR="91440" marT="45720" marB="45720">
+                    <a:lnL w="0" cap="flat" cmpd="sng" algn="ctr">
+                      <a:noFill/>
+                    </a:lnL>
+                    <a:lnR w="0" cap="flat" cmpd="sng" algn="ctr">
+                      <a:noFill/>
+                    </a:lnR>
+                    <a:lnT w="0" cap="flat" cmpd="sng" algn="ctr">
+                      <a:noFill/>
+                    </a:lnT>
+                    <a:lnB w="0" cap="flat" cmpd="sng" algn="ctr">
+                      <a:noFill/>
+                    </a:lnB>
+                  </a:tcPr>
+                </a:tc>
+                <a:tc>
+                  <a:txBody>
+                    <a:bodyPr/>
+                    <a:lstStyle/>
+                    <a:p>
+                      <a:pPr indent="0" marL="0">
+                        <a:buNone/>
+                      </a:pPr>
                       <a:endParaRPr lang="en-US" sz="1000" dirty="0">
                         <a:latin typeface="Figtree" charset="0"/>
                         <a:ea typeface="Figtree" charset="0"/>
@@ -5988,7 +6593,7 @@
                           <a:ea typeface="Figtree" pitchFamily="34" charset="-122"/>
                           <a:cs typeface="Figtree" pitchFamily="34" charset="-120"/>
                         </a:rPr>
-                        <a:t>680</a:t>
+                        <a:t>244</a:t>
                       </a:r>
                       <a:endParaRPr lang="en-US" sz="1000" dirty="0">
                         <a:latin typeface="Figtree" charset="0"/>
@@ -6029,7 +6634,7 @@
                           <a:ea typeface="Figtree" pitchFamily="34" charset="-122"/>
                           <a:cs typeface="Figtree" pitchFamily="34" charset="-120"/>
                         </a:rPr>
-                        <a:t>322</a:t>
+                        <a:t>323</a:t>
                       </a:r>
                       <a:endParaRPr lang="en-US" sz="1000" dirty="0">
                         <a:latin typeface="Figtree" charset="0"/>
@@ -6064,13 +6669,13 @@
                       <a:r>
                         <a:rPr lang="en-US" sz="1000" b="1" dirty="0">
                           <a:solidFill>
-                            <a:srgbClr val="118541"/>
+                            <a:srgbClr val="E52217"/>
                           </a:solidFill>
                           <a:latin typeface="Figtree" pitchFamily="34" charset="0"/>
                           <a:ea typeface="Figtree" pitchFamily="34" charset="-122"/>
                           <a:cs typeface="Figtree" pitchFamily="34" charset="-120"/>
                         </a:rPr>
-                        <a:t>+111%</a:t>
+                        <a:t>-24,5%</a:t>
                       </a:r>
                       <a:endParaRPr lang="en-US" sz="1000" dirty="0">
                         <a:latin typeface="Figtree" charset="0"/>
@@ -6095,6 +6700,180 @@
                   </a:tcPr>
                 </a:tc>
               </a:tr>
+              <a:tr h="411480">
+                <a:tc>
+                  <a:txBody>
+                    <a:bodyPr/>
+                    <a:lstStyle/>
+                    <a:p>
+                      <a:pPr indent="0" marL="0">
+                        <a:buNone/>
+                      </a:pPr>
+                      <a:r>
+                        <a:rPr lang="en-US" sz="1000" b="1" dirty="0">
+                          <a:solidFill>
+                            <a:srgbClr val="191919"/>
+                          </a:solidFill>
+                          <a:latin typeface="Figtree" pitchFamily="34" charset="0"/>
+                          <a:ea typeface="Figtree" pitchFamily="34" charset="-122"/>
+                          <a:cs typeface="Figtree" pitchFamily="34" charset="-120"/>
+                        </a:rPr>
+                        <a:t>Totale (incl. Preventivo LP)</a:t>
+                      </a:r>
+                      <a:endParaRPr lang="en-US" sz="1000" dirty="0">
+                        <a:latin typeface="Figtree" charset="0"/>
+                        <a:ea typeface="Figtree" charset="0"/>
+                        <a:cs typeface="Figtree" charset="0"/>
+                      </a:endParaRPr>
+                    </a:p>
+                  </a:txBody>
+                  <a:tcPr marL="91440" marR="91440" marT="45720" marB="45720">
+                    <a:lnL w="0" cap="flat" cmpd="sng" algn="ctr">
+                      <a:noFill/>
+                    </a:lnL>
+                    <a:lnR w="0" cap="flat" cmpd="sng" algn="ctr">
+                      <a:noFill/>
+                    </a:lnR>
+                    <a:lnT w="0" cap="flat" cmpd="sng" algn="ctr">
+                      <a:noFill/>
+                    </a:lnT>
+                    <a:lnB w="0" cap="flat" cmpd="sng" algn="ctr">
+                      <a:noFill/>
+                    </a:lnB>
+                  </a:tcPr>
+                </a:tc>
+                <a:tc>
+                  <a:txBody>
+                    <a:bodyPr/>
+                    <a:lstStyle/>
+                    <a:p>
+                      <a:pPr indent="0" marL="0">
+                        <a:buNone/>
+                      </a:pPr>
+                      <a:endParaRPr lang="en-US" sz="1000" dirty="0">
+                        <a:latin typeface="Figtree" charset="0"/>
+                        <a:ea typeface="Figtree" charset="0"/>
+                        <a:cs typeface="Figtree" charset="0"/>
+                      </a:endParaRPr>
+                    </a:p>
+                  </a:txBody>
+                  <a:tcPr marL="91440" marR="91440" marT="45720" marB="45720">
+                    <a:lnL w="0" cap="flat" cmpd="sng" algn="ctr">
+                      <a:noFill/>
+                    </a:lnL>
+                    <a:lnR w="0" cap="flat" cmpd="sng" algn="ctr">
+                      <a:noFill/>
+                    </a:lnR>
+                    <a:lnT w="0" cap="flat" cmpd="sng" algn="ctr">
+                      <a:noFill/>
+                    </a:lnT>
+                    <a:lnB w="0" cap="flat" cmpd="sng" algn="ctr">
+                      <a:noFill/>
+                    </a:lnB>
+                  </a:tcPr>
+                </a:tc>
+                <a:tc>
+                  <a:txBody>
+                    <a:bodyPr/>
+                    <a:lstStyle/>
+                    <a:p>
+                      <a:pPr algn="r" indent="0" marL="0">
+                        <a:buNone/>
+                      </a:pPr>
+                      <a:r>
+                        <a:rPr lang="en-US" sz="1000" b="1" dirty="0">
+                          <a:solidFill>
+                            <a:srgbClr val="191919"/>
+                          </a:solidFill>
+                          <a:latin typeface="Figtree" pitchFamily="34" charset="0"/>
+                          <a:ea typeface="Figtree" pitchFamily="34" charset="-122"/>
+                          <a:cs typeface="Figtree" pitchFamily="34" charset="-120"/>
+                        </a:rPr>
+                        <a:t>459</a:t>
+                      </a:r>
+                      <a:endParaRPr lang="en-US" sz="1000" dirty="0">
+                        <a:latin typeface="Figtree" charset="0"/>
+                        <a:ea typeface="Figtree" charset="0"/>
+                        <a:cs typeface="Figtree" charset="0"/>
+                      </a:endParaRPr>
+                    </a:p>
+                  </a:txBody>
+                  <a:tcPr marL="91440" marR="91440" marT="45720" marB="45720">
+                    <a:lnL w="0" cap="flat" cmpd="sng" algn="ctr">
+                      <a:noFill/>
+                    </a:lnL>
+                    <a:lnR w="0" cap="flat" cmpd="sng" algn="ctr">
+                      <a:noFill/>
+                    </a:lnR>
+                    <a:lnT w="0" cap="flat" cmpd="sng" algn="ctr">
+                      <a:noFill/>
+                    </a:lnT>
+                    <a:lnB w="0" cap="flat" cmpd="sng" algn="ctr">
+                      <a:noFill/>
+                    </a:lnB>
+                  </a:tcPr>
+                </a:tc>
+                <a:tc>
+                  <a:txBody>
+                    <a:bodyPr/>
+                    <a:lstStyle/>
+                    <a:p>
+                      <a:pPr indent="0" marL="0">
+                        <a:buNone/>
+                      </a:pPr>
+                      <a:endParaRPr lang="en-US" sz="1000" dirty="0">
+                        <a:latin typeface="Figtree" charset="0"/>
+                        <a:ea typeface="Figtree" charset="0"/>
+                        <a:cs typeface="Figtree" charset="0"/>
+                      </a:endParaRPr>
+                    </a:p>
+                  </a:txBody>
+                  <a:tcPr marL="91440" marR="91440" marT="45720" marB="45720">
+                    <a:lnL w="0" cap="flat" cmpd="sng" algn="ctr">
+                      <a:noFill/>
+                    </a:lnL>
+                    <a:lnR w="0" cap="flat" cmpd="sng" algn="ctr">
+                      <a:noFill/>
+                    </a:lnR>
+                    <a:lnT w="0" cap="flat" cmpd="sng" algn="ctr">
+                      <a:noFill/>
+                    </a:lnT>
+                    <a:lnB w="0" cap="flat" cmpd="sng" algn="ctr">
+                      <a:noFill/>
+                    </a:lnB>
+                  </a:tcPr>
+                </a:tc>
+                <a:tc>
+                  <a:txBody>
+                    <a:bodyPr/>
+                    <a:lstStyle/>
+                    <a:p>
+                      <a:pPr indent="0" marL="0">
+                        <a:buNone/>
+                      </a:pPr>
+                      <a:endParaRPr lang="en-US" sz="1000" dirty="0">
+                        <a:latin typeface="Figtree" charset="0"/>
+                        <a:ea typeface="Figtree" charset="0"/>
+                        <a:cs typeface="Figtree" charset="0"/>
+                      </a:endParaRPr>
+                    </a:p>
+                  </a:txBody>
+                  <a:tcPr marL="91440" marR="91440" marT="45720" marB="45720">
+                    <a:lnL w="0" cap="flat" cmpd="sng" algn="ctr">
+                      <a:noFill/>
+                    </a:lnL>
+                    <a:lnR w="0" cap="flat" cmpd="sng" algn="ctr">
+                      <a:noFill/>
+                    </a:lnR>
+                    <a:lnT w="0" cap="flat" cmpd="sng" algn="ctr">
+                      <a:noFill/>
+                    </a:lnT>
+                    <a:lnB w="0" cap="flat" cmpd="sng" algn="ctr">
+                      <a:noFill/>
+                    </a:lnB>
+                  </a:tcPr>
+                </a:tc>
+              </a:tr>
             </a:tbl>
           </a:graphicData>
         </a:graphic>
@@ -6107,8 +6886,8 @@
         </p:nvSpPr>
         <p:spPr>
           <a:xfrm>
-            <a:off x="457200" y="4846320"/>
-            <a:ext cx="5303520" cy="914400"/>
+            <a:off x="457200" y="5394960"/>
+            <a:ext cx="3566160" cy="914400"/>
           </a:xfrm>
           <a:prstGeom prst="roundRect">
             <a:avLst>
@@ -6129,8 +6908,8 @@
         </p:nvSpPr>
         <p:spPr>
           <a:xfrm>
-            <a:off x="640080" y="4892040"/>
-            <a:ext cx="1828800" cy="182880"/>
+            <a:off x="640080" y="5440680"/>
+            <a:ext cx="3200400" cy="182880"/>
           </a:xfrm>
           <a:prstGeom prst="rect">
             <a:avLst/>
@@ -6154,7 +6933,7 @@
                 <a:ea typeface="Figtree" pitchFamily="34" charset="-122"/>
                 <a:cs typeface="Figtree" pitchFamily="34" charset="-120"/>
               </a:rPr>
-              <a:t>LEAD TOTALI</a:t>
+              <a:t>LEAD TOTALI (INCL. LP)</a:t>
             </a:r>
             <a:endParaRPr lang="en-US" sz="800" dirty="0"/>
           </a:p>
@@ -6168,7 +6947,7 @@
         </p:nvSpPr>
         <p:spPr>
           <a:xfrm>
-            <a:off x="640080" y="5074920"/>
+            <a:off x="640080" y="5623560"/>
             <a:ext cx="1371600" cy="365760"/>
           </a:xfrm>
           <a:prstGeom prst="rect">
@@ -6193,7 +6972,7 @@
                 <a:ea typeface="Figtree" pitchFamily="34" charset="-122"/>
                 <a:cs typeface="Figtree" pitchFamily="34" charset="-120"/>
               </a:rPr>
-              <a:t>680</a:t>
+              <a:t>459</a:t>
             </a:r>
             <a:endParaRPr lang="en-US" sz="2600" dirty="0"/>
           </a:p>
@@ -6207,47 +6986,8 @@
         </p:nvSpPr>
         <p:spPr>
           <a:xfrm>
-            <a:off x="2103120" y="5074920"/>
-            <a:ext cx="1097280" cy="365760"/>
-          </a:xfrm>
-          <a:prstGeom prst="rect">
-            <a:avLst/>
-          </a:prstGeom>
-          <a:noFill/>
-          <a:ln/>
-        </p:spPr>
-        <p:txBody>
-          <a:bodyPr wrap="square" lIns="0" tIns="0" rIns="0" bIns="0" rtlCol="0" anchor="ctr"/>
-          <a:lstStyle/>
-          <a:p>
-            <a:pPr indent="0" marL="0">
-              <a:buNone/>
-            </a:pPr>
-            <a:r>
-              <a:rPr lang="en-US" sz="1400" b="1" dirty="0">
-                <a:solidFill>
-                  <a:srgbClr val="118541"/>
-                </a:solidFill>
-                <a:latin typeface="Figtree" pitchFamily="34" charset="0"/>
-                <a:ea typeface="Figtree" pitchFamily="34" charset="-122"/>
-                <a:cs typeface="Figtree" pitchFamily="34" charset="-120"/>
-              </a:rPr>
-              <a:t>+111%</a:t>
-            </a:r>
-            <a:endParaRPr lang="en-US" sz="1400" dirty="0"/>
-          </a:p>
-        </p:txBody>
-      </p:sp>
-      <p:sp>
-        <p:nvSpPr>
-          <p:cNvPr id="9" name="Text 6"/>
-          <p:cNvSpPr txBox="1"/>
-          <p:nvPr/>
-        </p:nvSpPr>
-        <p:spPr>
-          <a:xfrm>
-            <a:off x="3383280" y="5120640"/>
-            <a:ext cx="1828800" cy="274320"/>
+            <a:off x="640080" y="5989320"/>
+            <a:ext cx="2743200" cy="228600"/>
           </a:xfrm>
           <a:prstGeom prst="rect">
             <a:avLst/>
@@ -6271,7 +7011,7 @@
                 <a:ea typeface="Figtree" pitchFamily="34" charset="-122"/>
                 <a:cs typeface="Figtree" pitchFamily="34" charset="-120"/>
               </a:rPr>
-              <a:t>vs 322 set 2025</a:t>
+              <a:t>set 2026</a:t>
             </a:r>
             <a:endParaRPr lang="en-US" sz="800" dirty="0"/>
           </a:p>
@@ -6279,14 +7019,14 @@
       </p:sp>
       <p:sp>
         <p:nvSpPr>
-          <p:cNvPr id="10" name="Shape 7"/>
+          <p:cNvPr id="9" name="Shape 6"/>
           <p:cNvSpPr/>
           <p:nvPr/>
         </p:nvSpPr>
         <p:spPr>
           <a:xfrm>
-            <a:off x="6217920" y="4846320"/>
-            <a:ext cx="5303520" cy="914400"/>
+            <a:off x="4297680" y="5394960"/>
+            <a:ext cx="3566160" cy="914400"/>
           </a:xfrm>
           <a:prstGeom prst="roundRect">
             <a:avLst>
@@ -6301,14 +7041,192 @@
       </p:sp>
       <p:sp>
         <p:nvSpPr>
+          <p:cNvPr id="10" name="Text 7"/>
+          <p:cNvSpPr txBox="1"/>
+          <p:nvPr/>
+        </p:nvSpPr>
+        <p:spPr>
+          <a:xfrm>
+            <a:off x="4480560" y="5440680"/>
+            <a:ext cx="3200400" cy="182880"/>
+          </a:xfrm>
+          <a:prstGeom prst="rect">
+            <a:avLst/>
+          </a:prstGeom>
+          <a:noFill/>
+          <a:ln/>
+        </p:spPr>
+        <p:txBody>
+          <a:bodyPr wrap="square" lIns="0" tIns="0" rIns="0" bIns="0" rtlCol="0" anchor="ctr"/>
+          <a:lstStyle/>
+          <a:p>
+            <a:pPr indent="0" marL="0">
+              <a:buNone/>
+            </a:pPr>
+            <a:r>
+              <a:rPr lang="en-US" sz="800" b="1" dirty="0">
+                <a:solidFill>
+                  <a:srgbClr val="595959"/>
+                </a:solidFill>
+                <a:latin typeface="Figtree" pitchFamily="34" charset="0"/>
+                <a:ea typeface="Figtree" pitchFamily="34" charset="-122"/>
+                <a:cs typeface="Figtree" pitchFamily="34" charset="-120"/>
+              </a:rPr>
+              <a:t>PREVENTIVI LP</a:t>
+            </a:r>
+            <a:endParaRPr lang="en-US" sz="800" dirty="0"/>
+          </a:p>
+        </p:txBody>
+      </p:sp>
+      <p:sp>
+        <p:nvSpPr>
           <p:cNvPr id="11" name="Text 8"/>
           <p:cNvSpPr txBox="1"/>
           <p:nvPr/>
         </p:nvSpPr>
         <p:spPr>
           <a:xfrm>
-            <a:off x="6400800" y="4892040"/>
-            <a:ext cx="1828800" cy="182880"/>
+            <a:off x="4480560" y="5623560"/>
+            <a:ext cx="1371600" cy="365760"/>
+          </a:xfrm>
+          <a:prstGeom prst="rect">
+            <a:avLst/>
+          </a:prstGeom>
+          <a:noFill/>
+          <a:ln/>
+        </p:spPr>
+        <p:txBody>
+          <a:bodyPr wrap="square" lIns="0" tIns="0" rIns="0" bIns="0" rtlCol="0" anchor="ctr"/>
+          <a:lstStyle/>
+          <a:p>
+            <a:pPr indent="0" marL="0">
+              <a:buNone/>
+            </a:pPr>
+            <a:r>
+              <a:rPr lang="en-US" sz="2600" b="1" dirty="0">
+                <a:solidFill>
+                  <a:srgbClr val="191919"/>
+                </a:solidFill>
+                <a:latin typeface="Figtree" pitchFamily="34" charset="0"/>
+                <a:ea typeface="Figtree" pitchFamily="34" charset="-122"/>
+                <a:cs typeface="Figtree" pitchFamily="34" charset="-120"/>
+              </a:rPr>
+              <a:t>215</a:t>
+            </a:r>
+            <a:endParaRPr lang="en-US" sz="2600" dirty="0"/>
+          </a:p>
+        </p:txBody>
+      </p:sp>
+      <p:sp>
+        <p:nvSpPr>
+          <p:cNvPr id="12" name="Text 9"/>
+          <p:cNvSpPr txBox="1"/>
+          <p:nvPr/>
+        </p:nvSpPr>
+        <p:spPr>
+          <a:xfrm>
+            <a:off x="5943600" y="5623560"/>
+            <a:ext cx="1097280" cy="365760"/>
+          </a:xfrm>
+          <a:prstGeom prst="rect">
+            <a:avLst/>
+          </a:prstGeom>
+          <a:noFill/>
+          <a:ln/>
+        </p:spPr>
+        <p:txBody>
+          <a:bodyPr wrap="square" lIns="0" tIns="0" rIns="0" bIns="0" rtlCol="0" anchor="ctr"/>
+          <a:lstStyle/>
+          <a:p>
+            <a:pPr indent="0" marL="0">
+              <a:buNone/>
+            </a:pPr>
+            <a:r>
+              <a:rPr lang="en-US" sz="1400" b="1" dirty="0">
+                <a:solidFill>
+                  <a:srgbClr val="E52217"/>
+                </a:solidFill>
+                <a:latin typeface="Figtree" pitchFamily="34" charset="0"/>
+                <a:ea typeface="Figtree" pitchFamily="34" charset="-122"/>
+                <a:cs typeface="Figtree" pitchFamily="34" charset="-120"/>
+              </a:rPr>
+              <a:t>nuovo</a:t>
+            </a:r>
+            <a:endParaRPr lang="en-US" sz="1400" dirty="0"/>
+          </a:p>
+        </p:txBody>
+      </p:sp>
+      <p:sp>
+        <p:nvSpPr>
+          <p:cNvPr id="13" name="Text 10"/>
+          <p:cNvSpPr txBox="1"/>
+          <p:nvPr/>
+        </p:nvSpPr>
+        <p:spPr>
+          <a:xfrm>
+            <a:off x="4480560" y="5989320"/>
+            <a:ext cx="2743200" cy="228600"/>
+          </a:xfrm>
+          <a:prstGeom prst="rect">
+            <a:avLst/>
+          </a:prstGeom>
+          <a:noFill/>
+          <a:ln/>
+        </p:spPr>
+        <p:txBody>
+          <a:bodyPr wrap="square" lIns="0" tIns="0" rIns="0" bIns="0" rtlCol="0" anchor="ctr"/>
+          <a:lstStyle/>
+          <a:p>
+            <a:pPr indent="0" marL="0">
+              <a:buNone/>
+            </a:pPr>
+            <a:r>
+              <a:rPr lang="en-US" sz="800" dirty="0">
+                <a:solidFill>
+                  <a:srgbClr val="AAAAAA"/>
+                </a:solidFill>
+                <a:latin typeface="Figtree" pitchFamily="34" charset="0"/>
+                <a:ea typeface="Figtree" pitchFamily="34" charset="-122"/>
+                <a:cs typeface="Figtree" pitchFamily="34" charset="-120"/>
+              </a:rPr>
+              <a:t>landing rivenditori</a:t>
+            </a:r>
+            <a:endParaRPr lang="en-US" sz="800" dirty="0"/>
+          </a:p>
+        </p:txBody>
+      </p:sp>
+      <p:sp>
+        <p:nvSpPr>
+          <p:cNvPr id="14" name="Shape 11"/>
+          <p:cNvSpPr/>
+          <p:nvPr/>
+        </p:nvSpPr>
+        <p:spPr>
+          <a:xfrm>
+            <a:off x="8138160" y="5394960"/>
+            <a:ext cx="3566160" cy="914400"/>
+          </a:xfrm>
+          <a:prstGeom prst="roundRect">
+            <a:avLst>
+              <a:gd name="adj" fmla="val 8000"/>
+            </a:avLst>
+          </a:prstGeom>
+          <a:solidFill>
+            <a:srgbClr val="F4F5F6"/>
+          </a:solidFill>
+          <a:ln/>
+        </p:spPr>
+      </p:sp>
+      <p:sp>
+        <p:nvSpPr>
+          <p:cNvPr id="15" name="Text 12"/>
+          <p:cNvSpPr txBox="1"/>
+          <p:nvPr/>
+        </p:nvSpPr>
+        <p:spPr>
+          <a:xfrm>
+            <a:off x="8321040" y="5440680"/>
+            <a:ext cx="3200400" cy="182880"/>
           </a:xfrm>
           <a:prstGeom prst="rect">
             <a:avLst/>
@@ -6332,7 +7250,7 @@
                 <a:ea typeface="Figtree" pitchFamily="34" charset="-122"/>
                 <a:cs typeface="Figtree" pitchFamily="34" charset="-120"/>
               </a:rPr>
-              <a:t>REGISTRAZIONI PRO</a:t>
+              <a:t>LEAD TRADIZIONALI</a:t>
             </a:r>
             <a:endParaRPr lang="en-US" sz="800" dirty="0"/>
           </a:p>
@@ -6340,13 +7258,13 @@
       </p:sp>
       <p:sp>
         <p:nvSpPr>
-          <p:cNvPr id="12" name="Text 9"/>
-          <p:cNvSpPr txBox="1"/>
-          <p:nvPr/>
-        </p:nvSpPr>
-        <p:spPr>
-          <a:xfrm>
-            <a:off x="6400800" y="5074920"/>
+          <p:cNvPr id="16" name="Text 13"/>
+          <p:cNvSpPr txBox="1"/>
+          <p:nvPr/>
+        </p:nvSpPr>
+        <p:spPr>
+          <a:xfrm>
+            <a:off x="8321040" y="5623560"/>
             <a:ext cx="1371600" cy="365760"/>
           </a:xfrm>
           <a:prstGeom prst="rect">
@@ -6371,7 +7289,7 @@
                 <a:ea typeface="Figtree" pitchFamily="34" charset="-122"/>
                 <a:cs typeface="Figtree" pitchFamily="34" charset="-120"/>
               </a:rPr>
-              <a:t>33</a:t>
+              <a:t>244</a:t>
             </a:r>
             <a:endParaRPr lang="en-US" sz="2600" dirty="0"/>
           </a:p>
@@ -6379,13 +7297,13 @@
       </p:sp>
       <p:sp>
         <p:nvSpPr>
-          <p:cNvPr id="13" name="Text 10"/>
-          <p:cNvSpPr txBox="1"/>
-          <p:nvPr/>
-        </p:nvSpPr>
-        <p:spPr>
-          <a:xfrm>
-            <a:off x="7863840" y="5074920"/>
+          <p:cNvPr id="17" name="Text 14"/>
+          <p:cNvSpPr txBox="1"/>
+          <p:nvPr/>
+        </p:nvSpPr>
+        <p:spPr>
+          <a:xfrm>
+            <a:off x="9784080" y="5623560"/>
             <a:ext cx="1097280" cy="365760"/>
           </a:xfrm>
           <a:prstGeom prst="rect">
@@ -6404,13 +7322,13 @@
             <a:r>
               <a:rPr lang="en-US" sz="1400" b="1" dirty="0">
                 <a:solidFill>
-                  <a:srgbClr val="118541"/>
-                </a:solidFill>
-                <a:latin typeface="Figtree" pitchFamily="34" charset="0"/>
-                <a:ea typeface="Figtree" pitchFamily="34" charset="-122"/>
-                <a:cs typeface="Figtree" pitchFamily="34" charset="-120"/>
-              </a:rPr>
-              <a:t>+37,5%</a:t>
+                  <a:srgbClr val="E52217"/>
+                </a:solidFill>
+                <a:latin typeface="Figtree" pitchFamily="34" charset="0"/>
+                <a:ea typeface="Figtree" pitchFamily="34" charset="-122"/>
+                <a:cs typeface="Figtree" pitchFamily="34" charset="-120"/>
+              </a:rPr>
+              <a:t>-24,5%</a:t>
             </a:r>
             <a:endParaRPr lang="en-US" sz="1400" dirty="0"/>
           </a:p>
@@ -6418,14 +7336,14 @@
       </p:sp>
       <p:sp>
         <p:nvSpPr>
-          <p:cNvPr id="14" name="Text 11"/>
-          <p:cNvSpPr txBox="1"/>
-          <p:nvPr/>
-        </p:nvSpPr>
-        <p:spPr>
-          <a:xfrm>
-            <a:off x="9144000" y="5120640"/>
-            <a:ext cx="1828800" cy="274320"/>
+          <p:cNvPr id="18" name="Text 15"/>
+          <p:cNvSpPr txBox="1"/>
+          <p:nvPr/>
+        </p:nvSpPr>
+        <p:spPr>
+          <a:xfrm>
+            <a:off x="8321040" y="5989320"/>
+            <a:ext cx="2743200" cy="228600"/>
           </a:xfrm>
           <a:prstGeom prst="rect">
             <a:avLst/>
@@ -6449,7 +7367,7 @@
                 <a:ea typeface="Figtree" pitchFamily="34" charset="-122"/>
                 <a:cs typeface="Figtree" pitchFamily="34" charset="-120"/>
               </a:rPr>
-              <a:t>vs 24 set 2025</a:t>
+              <a:t>vs 323 set 2025</a:t>
             </a:r>
             <a:endParaRPr lang="en-US" sz="800" dirty="0"/>
           </a:p>
@@ -6457,7 +7375,7 @@
       </p:sp>
       <p:sp>
         <p:nvSpPr>
-          <p:cNvPr id="15" name="Text 12"/>
+          <p:cNvPr id="19" name="Text 16"/>
           <p:cNvSpPr txBox="1"/>
           <p:nvPr/>
         </p:nvSpPr>
@@ -6488,7 +7406,7 @@
                 <a:ea typeface="Figtree" pitchFamily="34" charset="-122"/>
                 <a:cs typeface="Figtree" pitchFamily="34" charset="-120"/>
               </a:rPr>
-              <a:t>Fonte dati: GA4 | Periodo analizzato: set 2026 YoY</a:t>
+              <a:t>Fonte dati: HubSpot, MyArea | Periodo analizzato: set 2026 YoY</a:t>
             </a:r>
             <a:endParaRPr lang="en-US" sz="800" dirty="0"/>
           </a:p>
@@ -6496,7 +7414,7 @@
       </p:sp>
       <p:sp>
         <p:nvSpPr>
-          <p:cNvPr id="16" name="Shape 13"/>
+          <p:cNvPr id="20" name="Shape 17"/>
           <p:cNvSpPr/>
           <p:nvPr/>
         </p:nvSpPr>
@@ -6516,7 +7434,7 @@
       </p:sp>
       <p:sp>
         <p:nvSpPr>
-          <p:cNvPr id="17" name="Text 14"/>
+          <p:cNvPr id="21" name="Text 18"/>
           <p:cNvSpPr txBox="1"/>
           <p:nvPr/>
         </p:nvSpPr>
@@ -6650,7 +7568,7 @@
                 <a:ea typeface="Figtree" pitchFamily="34" charset="-122"/>
                 <a:cs typeface="Figtree" pitchFamily="34" charset="-120"/>
               </a:rPr>
-              <a:t>Le campagne Lead Gen rivenditori generano 155 invii form dalla landing, con Google e Meta come driver principali</a:t>
+              <a:t>La landing rivenditori raccoglie 215 preventivi, con Google Ads e Meta Ads come driver principali del traffico</a:t>
             </a:r>
             <a:endParaRPr lang="en-US" sz="2000" dirty="0"/>
           </a:p>
@@ -6664,12 +7582,12 @@
         </p:nvSpPr>
         <p:spPr>
           <a:xfrm>
-            <a:off x="457200" y="1645920"/>
-            <a:ext cx="5394960" cy="4389120"/>
+            <a:off x="457200" y="1554480"/>
+            <a:ext cx="11247120" cy="1188720"/>
           </a:xfrm>
           <a:prstGeom prst="roundRect">
             <a:avLst>
-              <a:gd name="adj" fmla="val 2083"/>
+              <a:gd name="adj" fmla="val 7692"/>
             </a:avLst>
           </a:prstGeom>
           <a:solidFill>
@@ -6686,24 +7604,63 @@
         </p:nvSpPr>
         <p:spPr>
           <a:xfrm>
-            <a:off x="731520" y="1828800"/>
-            <a:ext cx="3657600" cy="365760"/>
-          </a:xfrm>
-          <a:prstGeom prst="rect">
-            <a:avLst/>
-          </a:prstGeom>
-          <a:noFill/>
-          <a:ln/>
-        </p:spPr>
-        <p:txBody>
-          <a:bodyPr wrap="square" lIns="0" tIns="0" rIns="0" bIns="0" rtlCol="0" anchor="ctr"/>
-          <a:lstStyle/>
-          <a:p>
-            <a:pPr indent="0" marL="0">
-              <a:buNone/>
-            </a:pPr>
-            <a:r>
-              <a:rPr lang="en-US" sz="1600" b="1" dirty="0">
+            <a:off x="731520" y="1645920"/>
+            <a:ext cx="4572000" cy="228600"/>
+          </a:xfrm>
+          <a:prstGeom prst="rect">
+            <a:avLst/>
+          </a:prstGeom>
+          <a:noFill/>
+          <a:ln/>
+        </p:spPr>
+        <p:txBody>
+          <a:bodyPr wrap="square" lIns="0" tIns="0" rIns="0" bIns="0" rtlCol="0" anchor="ctr"/>
+          <a:lstStyle/>
+          <a:p>
+            <a:pPr indent="0" marL="0">
+              <a:buNone/>
+            </a:pPr>
+            <a:r>
+              <a:rPr lang="en-US" sz="900" b="1" dirty="0">
+                <a:solidFill>
+                  <a:srgbClr val="595959"/>
+                </a:solidFill>
+                <a:latin typeface="Figtree" pitchFamily="34" charset="0"/>
+                <a:ea typeface="Figtree" pitchFamily="34" charset="-122"/>
+                <a:cs typeface="Figtree" pitchFamily="34" charset="-120"/>
+              </a:rPr>
+              <a:t>PREVENTIVI LANDING RIVENDITORI</a:t>
+            </a:r>
+            <a:endParaRPr lang="en-US" sz="900" dirty="0"/>
+          </a:p>
+        </p:txBody>
+      </p:sp>
+      <p:sp>
+        <p:nvSpPr>
+          <p:cNvPr id="6" name="Text 4"/>
+          <p:cNvSpPr txBox="1"/>
+          <p:nvPr/>
+        </p:nvSpPr>
+        <p:spPr>
+          <a:xfrm>
+            <a:off x="731520" y="1920240"/>
+            <a:ext cx="1828800" cy="548640"/>
+          </a:xfrm>
+          <a:prstGeom prst="rect">
+            <a:avLst/>
+          </a:prstGeom>
+          <a:noFill/>
+          <a:ln/>
+        </p:spPr>
+        <p:txBody>
+          <a:bodyPr wrap="square" lIns="0" tIns="0" rIns="0" bIns="0" rtlCol="0" anchor="ctr"/>
+          <a:lstStyle/>
+          <a:p>
+            <a:pPr indent="0" marL="0">
+              <a:buNone/>
+            </a:pPr>
+            <a:r>
+              <a:rPr lang="en-US" sz="4200" b="1" dirty="0">
                 <a:solidFill>
                   <a:srgbClr val="191919"/>
                 </a:solidFill>
@@ -6711,21 +7668,21 @@
                 <a:ea typeface="Figtree" pitchFamily="34" charset="-122"/>
                 <a:cs typeface="Figtree" pitchFamily="34" charset="-120"/>
               </a:rPr>
-              <a:t>Risultati Google</a:t>
-            </a:r>
-            <a:endParaRPr lang="en-US" sz="1600" dirty="0"/>
-          </a:p>
-        </p:txBody>
-      </p:sp>
-      <p:sp>
-        <p:nvSpPr>
-          <p:cNvPr id="6" name="Text 4"/>
-          <p:cNvSpPr txBox="1"/>
-          <p:nvPr/>
-        </p:nvSpPr>
-        <p:spPr>
-          <a:xfrm>
-            <a:off x="731520" y="2194560"/>
+              <a:t>215</a:t>
+            </a:r>
+            <a:endParaRPr lang="en-US" sz="4200" dirty="0"/>
+          </a:p>
+        </p:txBody>
+      </p:sp>
+      <p:sp>
+        <p:nvSpPr>
+          <p:cNvPr id="7" name="Text 5"/>
+          <p:cNvSpPr txBox="1"/>
+          <p:nvPr/>
+        </p:nvSpPr>
+        <p:spPr>
+          <a:xfrm>
+            <a:off x="2743200" y="2103120"/>
             <a:ext cx="4572000" cy="274320"/>
           </a:xfrm>
           <a:prstGeom prst="rect">
@@ -6742,7 +7699,7 @@
               <a:buNone/>
             </a:pPr>
             <a:r>
-              <a:rPr lang="en-US" sz="1000" dirty="0">
+              <a:rPr lang="en-US" sz="1200" dirty="0">
                 <a:solidFill>
                   <a:srgbClr val="595959"/>
                 </a:solidFill>
@@ -6750,48 +7707,9 @@
                 <a:ea typeface="Figtree" pitchFamily="34" charset="-122"/>
                 <a:cs typeface="Figtree" pitchFamily="34" charset="-120"/>
               </a:rPr>
-              <a:t>Campagna DG Conversion Lead Gen</a:t>
-            </a:r>
-            <a:endParaRPr lang="en-US" sz="1000" dirty="0"/>
-          </a:p>
-        </p:txBody>
-      </p:sp>
-      <p:sp>
-        <p:nvSpPr>
-          <p:cNvPr id="7" name="Text 5"/>
-          <p:cNvSpPr txBox="1"/>
-          <p:nvPr/>
-        </p:nvSpPr>
-        <p:spPr>
-          <a:xfrm>
-            <a:off x="731520" y="2743200"/>
-            <a:ext cx="1645920" cy="182880"/>
-          </a:xfrm>
-          <a:prstGeom prst="rect">
-            <a:avLst/>
-          </a:prstGeom>
-          <a:noFill/>
-          <a:ln/>
-        </p:spPr>
-        <p:txBody>
-          <a:bodyPr wrap="square" lIns="0" tIns="0" rIns="0" bIns="0" rtlCol="0" anchor="ctr"/>
-          <a:lstStyle/>
-          <a:p>
-            <a:pPr indent="0" marL="0">
-              <a:buNone/>
-            </a:pPr>
-            <a:r>
-              <a:rPr lang="en-US" sz="800" b="1" dirty="0">
-                <a:solidFill>
-                  <a:srgbClr val="595959"/>
-                </a:solidFill>
-                <a:latin typeface="Figtree" pitchFamily="34" charset="0"/>
-                <a:ea typeface="Figtree" pitchFamily="34" charset="-122"/>
-                <a:cs typeface="Figtree" pitchFamily="34" charset="-120"/>
-              </a:rPr>
-              <a:t>CONVERSIONI</a:t>
-            </a:r>
-            <a:endParaRPr lang="en-US" sz="800" dirty="0"/>
+              <a:t>preventivi compilati (fonte: HubSpot)</a:t>
+            </a:r>
+            <a:endParaRPr lang="en-US" sz="1200" dirty="0"/>
           </a:p>
         </p:txBody>
       </p:sp>
@@ -6803,363 +7721,51 @@
         </p:nvSpPr>
         <p:spPr>
           <a:xfrm>
-            <a:off x="731520" y="2926080"/>
-            <a:ext cx="2286000" cy="274320"/>
-          </a:xfrm>
-          <a:prstGeom prst="rect">
-            <a:avLst/>
-          </a:prstGeom>
-          <a:noFill/>
-          <a:ln/>
-        </p:spPr>
-        <p:txBody>
-          <a:bodyPr wrap="square" lIns="0" tIns="0" rIns="0" bIns="0" rtlCol="0" anchor="ctr"/>
-          <a:lstStyle/>
-          <a:p>
-            <a:pPr indent="0" marL="0">
-              <a:buNone/>
-            </a:pPr>
-            <a:r>
-              <a:rPr lang="en-US" sz="1600" b="1" dirty="0">
-                <a:solidFill>
-                  <a:srgbClr val="191919"/>
-                </a:solidFill>
-                <a:latin typeface="Figtree" pitchFamily="34" charset="0"/>
-                <a:ea typeface="Figtree" pitchFamily="34" charset="-122"/>
-                <a:cs typeface="Figtree" pitchFamily="34" charset="-120"/>
-              </a:rPr>
-              <a:t>~21</a:t>
-            </a:r>
-            <a:endParaRPr lang="en-US" sz="1600" dirty="0"/>
-          </a:p>
-        </p:txBody>
-      </p:sp>
-      <p:sp>
-        <p:nvSpPr>
-          <p:cNvPr id="9" name="Text 7"/>
-          <p:cNvSpPr txBox="1"/>
-          <p:nvPr/>
-        </p:nvSpPr>
-        <p:spPr>
-          <a:xfrm>
-            <a:off x="731520" y="3337560"/>
-            <a:ext cx="1645920" cy="182880"/>
-          </a:xfrm>
-          <a:prstGeom prst="rect">
-            <a:avLst/>
-          </a:prstGeom>
-          <a:noFill/>
-          <a:ln/>
-        </p:spPr>
-        <p:txBody>
-          <a:bodyPr wrap="square" lIns="0" tIns="0" rIns="0" bIns="0" rtlCol="0" anchor="ctr"/>
-          <a:lstStyle/>
-          <a:p>
-            <a:pPr indent="0" marL="0">
-              <a:buNone/>
-            </a:pPr>
-            <a:r>
-              <a:rPr lang="en-US" sz="800" b="1" dirty="0">
-                <a:solidFill>
-                  <a:srgbClr val="595959"/>
-                </a:solidFill>
-                <a:latin typeface="Figtree" pitchFamily="34" charset="0"/>
-                <a:ea typeface="Figtree" pitchFamily="34" charset="-122"/>
-                <a:cs typeface="Figtree" pitchFamily="34" charset="-120"/>
-              </a:rPr>
-              <a:t>CPL</a:t>
-            </a:r>
-            <a:endParaRPr lang="en-US" sz="800" dirty="0"/>
-          </a:p>
-        </p:txBody>
-      </p:sp>
-      <p:sp>
-        <p:nvSpPr>
-          <p:cNvPr id="10" name="Text 8"/>
-          <p:cNvSpPr txBox="1"/>
-          <p:nvPr/>
-        </p:nvSpPr>
-        <p:spPr>
-          <a:xfrm>
-            <a:off x="731520" y="3520440"/>
-            <a:ext cx="2286000" cy="274320"/>
-          </a:xfrm>
-          <a:prstGeom prst="rect">
-            <a:avLst/>
-          </a:prstGeom>
-          <a:noFill/>
-          <a:ln/>
-        </p:spPr>
-        <p:txBody>
-          <a:bodyPr wrap="square" lIns="0" tIns="0" rIns="0" bIns="0" rtlCol="0" anchor="ctr"/>
-          <a:lstStyle/>
-          <a:p>
-            <a:pPr indent="0" marL="0">
-              <a:buNone/>
-            </a:pPr>
-            <a:r>
-              <a:rPr lang="en-US" sz="1600" b="1" dirty="0">
-                <a:solidFill>
-                  <a:srgbClr val="191919"/>
-                </a:solidFill>
-                <a:latin typeface="Figtree" pitchFamily="34" charset="0"/>
-                <a:ea typeface="Figtree" pitchFamily="34" charset="-122"/>
-                <a:cs typeface="Figtree" pitchFamily="34" charset="-120"/>
-              </a:rPr>
-              <a:t>~30 €</a:t>
-            </a:r>
-            <a:endParaRPr lang="en-US" sz="1600" dirty="0"/>
-          </a:p>
-        </p:txBody>
-      </p:sp>
-      <p:sp>
-        <p:nvSpPr>
-          <p:cNvPr id="11" name="Text 9"/>
-          <p:cNvSpPr txBox="1"/>
-          <p:nvPr/>
-        </p:nvSpPr>
-        <p:spPr>
-          <a:xfrm>
-            <a:off x="731520" y="3931920"/>
-            <a:ext cx="1645920" cy="182880"/>
-          </a:xfrm>
-          <a:prstGeom prst="rect">
-            <a:avLst/>
-          </a:prstGeom>
-          <a:noFill/>
-          <a:ln/>
-        </p:spPr>
-        <p:txBody>
-          <a:bodyPr wrap="square" lIns="0" tIns="0" rIns="0" bIns="0" rtlCol="0" anchor="ctr"/>
-          <a:lstStyle/>
-          <a:p>
-            <a:pPr indent="0" marL="0">
-              <a:buNone/>
-            </a:pPr>
-            <a:r>
-              <a:rPr lang="en-US" sz="800" b="1" dirty="0">
-                <a:solidFill>
-                  <a:srgbClr val="595959"/>
-                </a:solidFill>
-                <a:latin typeface="Figtree" pitchFamily="34" charset="0"/>
-                <a:ea typeface="Figtree" pitchFamily="34" charset="-122"/>
-                <a:cs typeface="Figtree" pitchFamily="34" charset="-120"/>
-              </a:rPr>
-              <a:t>IMPRESSION</a:t>
-            </a:r>
-            <a:endParaRPr lang="en-US" sz="800" dirty="0"/>
-          </a:p>
-        </p:txBody>
-      </p:sp>
-      <p:sp>
-        <p:nvSpPr>
-          <p:cNvPr id="12" name="Text 10"/>
-          <p:cNvSpPr txBox="1"/>
-          <p:nvPr/>
-        </p:nvSpPr>
-        <p:spPr>
-          <a:xfrm>
-            <a:off x="731520" y="4114800"/>
-            <a:ext cx="2286000" cy="274320"/>
-          </a:xfrm>
-          <a:prstGeom prst="rect">
-            <a:avLst/>
-          </a:prstGeom>
-          <a:noFill/>
-          <a:ln/>
-        </p:spPr>
-        <p:txBody>
-          <a:bodyPr wrap="square" lIns="0" tIns="0" rIns="0" bIns="0" rtlCol="0" anchor="ctr"/>
-          <a:lstStyle/>
-          <a:p>
-            <a:pPr indent="0" marL="0">
-              <a:buNone/>
-            </a:pPr>
-            <a:r>
-              <a:rPr lang="en-US" sz="1600" b="1" dirty="0">
-                <a:solidFill>
-                  <a:srgbClr val="191919"/>
-                </a:solidFill>
-                <a:latin typeface="Figtree" pitchFamily="34" charset="0"/>
-                <a:ea typeface="Figtree" pitchFamily="34" charset="-122"/>
-                <a:cs typeface="Figtree" pitchFamily="34" charset="-120"/>
-              </a:rPr>
-              <a:t>64.777</a:t>
-            </a:r>
-            <a:endParaRPr lang="en-US" sz="1600" dirty="0"/>
-          </a:p>
-        </p:txBody>
-      </p:sp>
-      <p:sp>
-        <p:nvSpPr>
-          <p:cNvPr id="13" name="Text 11"/>
-          <p:cNvSpPr txBox="1"/>
-          <p:nvPr/>
-        </p:nvSpPr>
-        <p:spPr>
-          <a:xfrm>
-            <a:off x="731520" y="4526280"/>
-            <a:ext cx="1645920" cy="182880"/>
-          </a:xfrm>
-          <a:prstGeom prst="rect">
-            <a:avLst/>
-          </a:prstGeom>
-          <a:noFill/>
-          <a:ln/>
-        </p:spPr>
-        <p:txBody>
-          <a:bodyPr wrap="square" lIns="0" tIns="0" rIns="0" bIns="0" rtlCol="0" anchor="ctr"/>
-          <a:lstStyle/>
-          <a:p>
-            <a:pPr indent="0" marL="0">
-              <a:buNone/>
-            </a:pPr>
-            <a:r>
-              <a:rPr lang="en-US" sz="800" b="1" dirty="0">
-                <a:solidFill>
-                  <a:srgbClr val="595959"/>
-                </a:solidFill>
-                <a:latin typeface="Figtree" pitchFamily="34" charset="0"/>
-                <a:ea typeface="Figtree" pitchFamily="34" charset="-122"/>
-                <a:cs typeface="Figtree" pitchFamily="34" charset="-120"/>
-              </a:rPr>
-              <a:t>CLIC</a:t>
-            </a:r>
-            <a:endParaRPr lang="en-US" sz="800" dirty="0"/>
-          </a:p>
-        </p:txBody>
-      </p:sp>
-      <p:sp>
-        <p:nvSpPr>
-          <p:cNvPr id="14" name="Text 12"/>
-          <p:cNvSpPr txBox="1"/>
-          <p:nvPr/>
-        </p:nvSpPr>
-        <p:spPr>
-          <a:xfrm>
-            <a:off x="731520" y="4709160"/>
-            <a:ext cx="2286000" cy="274320"/>
-          </a:xfrm>
-          <a:prstGeom prst="rect">
-            <a:avLst/>
-          </a:prstGeom>
-          <a:noFill/>
-          <a:ln/>
-        </p:spPr>
-        <p:txBody>
-          <a:bodyPr wrap="square" lIns="0" tIns="0" rIns="0" bIns="0" rtlCol="0" anchor="ctr"/>
-          <a:lstStyle/>
-          <a:p>
-            <a:pPr indent="0" marL="0">
-              <a:buNone/>
-            </a:pPr>
-            <a:r>
-              <a:rPr lang="en-US" sz="1600" b="1" dirty="0">
-                <a:solidFill>
-                  <a:srgbClr val="191919"/>
-                </a:solidFill>
-                <a:latin typeface="Figtree" pitchFamily="34" charset="0"/>
-                <a:ea typeface="Figtree" pitchFamily="34" charset="-122"/>
-                <a:cs typeface="Figtree" pitchFamily="34" charset="-120"/>
-              </a:rPr>
-              <a:t>2.288</a:t>
-            </a:r>
-            <a:endParaRPr lang="en-US" sz="1600" dirty="0"/>
-          </a:p>
-        </p:txBody>
-      </p:sp>
-      <p:sp>
-        <p:nvSpPr>
-          <p:cNvPr id="15" name="Text 13"/>
-          <p:cNvSpPr txBox="1"/>
-          <p:nvPr/>
-        </p:nvSpPr>
-        <p:spPr>
-          <a:xfrm>
-            <a:off x="731520" y="5120640"/>
-            <a:ext cx="1645920" cy="182880"/>
-          </a:xfrm>
-          <a:prstGeom prst="rect">
-            <a:avLst/>
-          </a:prstGeom>
-          <a:noFill/>
-          <a:ln/>
-        </p:spPr>
-        <p:txBody>
-          <a:bodyPr wrap="square" lIns="0" tIns="0" rIns="0" bIns="0" rtlCol="0" anchor="ctr"/>
-          <a:lstStyle/>
-          <a:p>
-            <a:pPr indent="0" marL="0">
-              <a:buNone/>
-            </a:pPr>
-            <a:r>
-              <a:rPr lang="en-US" sz="800" b="1" dirty="0">
-                <a:solidFill>
-                  <a:srgbClr val="595959"/>
-                </a:solidFill>
-                <a:latin typeface="Figtree" pitchFamily="34" charset="0"/>
-                <a:ea typeface="Figtree" pitchFamily="34" charset="-122"/>
-                <a:cs typeface="Figtree" pitchFamily="34" charset="-120"/>
-              </a:rPr>
-              <a:t>INVESTIMENTO</a:t>
-            </a:r>
-            <a:endParaRPr lang="en-US" sz="800" dirty="0"/>
-          </a:p>
-        </p:txBody>
-      </p:sp>
-      <p:sp>
-        <p:nvSpPr>
-          <p:cNvPr id="16" name="Text 14"/>
-          <p:cNvSpPr txBox="1"/>
-          <p:nvPr/>
-        </p:nvSpPr>
-        <p:spPr>
-          <a:xfrm>
-            <a:off x="731520" y="5303520"/>
-            <a:ext cx="2286000" cy="274320"/>
-          </a:xfrm>
-          <a:prstGeom prst="rect">
-            <a:avLst/>
-          </a:prstGeom>
-          <a:noFill/>
-          <a:ln/>
-        </p:spPr>
-        <p:txBody>
-          <a:bodyPr wrap="square" lIns="0" tIns="0" rIns="0" bIns="0" rtlCol="0" anchor="ctr"/>
-          <a:lstStyle/>
-          <a:p>
-            <a:pPr indent="0" marL="0">
-              <a:buNone/>
-            </a:pPr>
-            <a:r>
-              <a:rPr lang="en-US" sz="1600" b="1" dirty="0">
-                <a:solidFill>
-                  <a:srgbClr val="191919"/>
-                </a:solidFill>
-                <a:latin typeface="Figtree" pitchFamily="34" charset="0"/>
-                <a:ea typeface="Figtree" pitchFamily="34" charset="-122"/>
-                <a:cs typeface="Figtree" pitchFamily="34" charset="-120"/>
-              </a:rPr>
-              <a:t>636 €</a:t>
-            </a:r>
-            <a:endParaRPr lang="en-US" sz="1600" dirty="0"/>
-          </a:p>
-        </p:txBody>
-      </p:sp>
-      <p:sp>
-        <p:nvSpPr>
-          <p:cNvPr id="17" name="Shape 15"/>
+            <a:off x="9601200" y="1920240"/>
+            <a:ext cx="1828800" cy="548640"/>
+          </a:xfrm>
+          <a:prstGeom prst="rect">
+            <a:avLst/>
+          </a:prstGeom>
+          <a:noFill/>
+          <a:ln/>
+        </p:spPr>
+        <p:txBody>
+          <a:bodyPr wrap="square" lIns="0" tIns="0" rIns="0" bIns="0" rtlCol="0" anchor="ctr"/>
+          <a:lstStyle/>
+          <a:p>
+            <a:pPr indent="0" marL="0">
+              <a:buNone/>
+            </a:pPr>
+            <a:r>
+              <a:rPr lang="en-US" sz="1800" b="1" dirty="0">
+                <a:solidFill>
+                  <a:srgbClr val="E52217"/>
+                </a:solidFill>
+                <a:latin typeface="Figtree" pitchFamily="34" charset="0"/>
+                <a:ea typeface="Figtree" pitchFamily="34" charset="-122"/>
+                <a:cs typeface="Figtree" pitchFamily="34" charset="-120"/>
+              </a:rPr>
+              <a:t>nuovo canale</a:t>
+            </a:r>
+            <a:endParaRPr lang="en-US" sz="1800" dirty="0"/>
+          </a:p>
+        </p:txBody>
+      </p:sp>
+      <p:sp>
+        <p:nvSpPr>
+          <p:cNvPr id="9" name="Shape 7"/>
           <p:cNvSpPr/>
           <p:nvPr/>
         </p:nvSpPr>
         <p:spPr>
           <a:xfrm>
-            <a:off x="6217920" y="1645920"/>
-            <a:ext cx="5394960" cy="4389120"/>
+            <a:off x="457200" y="3017520"/>
+            <a:ext cx="5394960" cy="3017520"/>
           </a:xfrm>
           <a:prstGeom prst="roundRect">
             <a:avLst>
-              <a:gd name="adj" fmla="val 2083"/>
+              <a:gd name="adj" fmla="val 3030"/>
             </a:avLst>
           </a:prstGeom>
           <a:solidFill>
@@ -7170,13 +7776,425 @@
       </p:sp>
       <p:sp>
         <p:nvSpPr>
+          <p:cNvPr id="10" name="Text 8"/>
+          <p:cNvSpPr txBox="1"/>
+          <p:nvPr/>
+        </p:nvSpPr>
+        <p:spPr>
+          <a:xfrm>
+            <a:off x="731520" y="3200400"/>
+            <a:ext cx="3657600" cy="365760"/>
+          </a:xfrm>
+          <a:prstGeom prst="rect">
+            <a:avLst/>
+          </a:prstGeom>
+          <a:noFill/>
+          <a:ln/>
+        </p:spPr>
+        <p:txBody>
+          <a:bodyPr wrap="square" lIns="0" tIns="0" rIns="0" bIns="0" rtlCol="0" anchor="ctr"/>
+          <a:lstStyle/>
+          <a:p>
+            <a:pPr indent="0" marL="0">
+              <a:buNone/>
+            </a:pPr>
+            <a:r>
+              <a:rPr lang="en-US" sz="1600" b="1" dirty="0">
+                <a:solidFill>
+                  <a:srgbClr val="191919"/>
+                </a:solidFill>
+                <a:latin typeface="Figtree" pitchFamily="34" charset="0"/>
+                <a:ea typeface="Figtree" pitchFamily="34" charset="-122"/>
+                <a:cs typeface="Figtree" pitchFamily="34" charset="-120"/>
+              </a:rPr>
+              <a:t>Campagna Google Ads</a:t>
+            </a:r>
+            <a:endParaRPr lang="en-US" sz="1600" dirty="0"/>
+          </a:p>
+        </p:txBody>
+      </p:sp>
+      <p:sp>
+        <p:nvSpPr>
+          <p:cNvPr id="11" name="Text 9"/>
+          <p:cNvSpPr txBox="1"/>
+          <p:nvPr/>
+        </p:nvSpPr>
+        <p:spPr>
+          <a:xfrm>
+            <a:off x="731520" y="3566160"/>
+            <a:ext cx="4572000" cy="274320"/>
+          </a:xfrm>
+          <a:prstGeom prst="rect">
+            <a:avLst/>
+          </a:prstGeom>
+          <a:noFill/>
+          <a:ln/>
+        </p:spPr>
+        <p:txBody>
+          <a:bodyPr wrap="square" lIns="0" tIns="0" rIns="0" bIns="0" rtlCol="0" anchor="ctr"/>
+          <a:lstStyle/>
+          <a:p>
+            <a:pPr indent="0" marL="0">
+              <a:buNone/>
+            </a:pPr>
+            <a:r>
+              <a:rPr lang="en-US" sz="1000" dirty="0">
+                <a:solidFill>
+                  <a:srgbClr val="595959"/>
+                </a:solidFill>
+                <a:latin typeface="Figtree" pitchFamily="34" charset="0"/>
+                <a:ea typeface="Figtree" pitchFamily="34" charset="-122"/>
+                <a:cs typeface="Figtree" pitchFamily="34" charset="-120"/>
+              </a:rPr>
+              <a:t>DG Conversion Lead Gen</a:t>
+            </a:r>
+            <a:endParaRPr lang="en-US" sz="1000" dirty="0"/>
+          </a:p>
+        </p:txBody>
+      </p:sp>
+      <p:sp>
+        <p:nvSpPr>
+          <p:cNvPr id="12" name="Text 10"/>
+          <p:cNvSpPr txBox="1"/>
+          <p:nvPr/>
+        </p:nvSpPr>
+        <p:spPr>
+          <a:xfrm>
+            <a:off x="731520" y="4114800"/>
+            <a:ext cx="1645920" cy="182880"/>
+          </a:xfrm>
+          <a:prstGeom prst="rect">
+            <a:avLst/>
+          </a:prstGeom>
+          <a:noFill/>
+          <a:ln/>
+        </p:spPr>
+        <p:txBody>
+          <a:bodyPr wrap="square" lIns="0" tIns="0" rIns="0" bIns="0" rtlCol="0" anchor="ctr"/>
+          <a:lstStyle/>
+          <a:p>
+            <a:pPr indent="0" marL="0">
+              <a:buNone/>
+            </a:pPr>
+            <a:r>
+              <a:rPr lang="en-US" sz="800" b="1" dirty="0">
+                <a:solidFill>
+                  <a:srgbClr val="595959"/>
+                </a:solidFill>
+                <a:latin typeface="Figtree" pitchFamily="34" charset="0"/>
+                <a:ea typeface="Figtree" pitchFamily="34" charset="-122"/>
+                <a:cs typeface="Figtree" pitchFamily="34" charset="-120"/>
+              </a:rPr>
+              <a:t>IMPRESSION</a:t>
+            </a:r>
+            <a:endParaRPr lang="en-US" sz="800" dirty="0"/>
+          </a:p>
+        </p:txBody>
+      </p:sp>
+      <p:sp>
+        <p:nvSpPr>
+          <p:cNvPr id="13" name="Text 11"/>
+          <p:cNvSpPr txBox="1"/>
+          <p:nvPr/>
+        </p:nvSpPr>
+        <p:spPr>
+          <a:xfrm>
+            <a:off x="2560320" y="4114800"/>
+            <a:ext cx="2286000" cy="228600"/>
+          </a:xfrm>
+          <a:prstGeom prst="rect">
+            <a:avLst/>
+          </a:prstGeom>
+          <a:noFill/>
+          <a:ln/>
+        </p:spPr>
+        <p:txBody>
+          <a:bodyPr wrap="square" lIns="0" tIns="0" rIns="0" bIns="0" rtlCol="0" anchor="ctr"/>
+          <a:lstStyle/>
+          <a:p>
+            <a:pPr indent="0" marL="0">
+              <a:buNone/>
+            </a:pPr>
+            <a:r>
+              <a:rPr lang="en-US" sz="1400" b="1" dirty="0">
+                <a:solidFill>
+                  <a:srgbClr val="191919"/>
+                </a:solidFill>
+                <a:latin typeface="Figtree" pitchFamily="34" charset="0"/>
+                <a:ea typeface="Figtree" pitchFamily="34" charset="-122"/>
+                <a:cs typeface="Figtree" pitchFamily="34" charset="-120"/>
+              </a:rPr>
+              <a:t>64.777</a:t>
+            </a:r>
+            <a:endParaRPr lang="en-US" sz="1400" dirty="0"/>
+          </a:p>
+        </p:txBody>
+      </p:sp>
+      <p:sp>
+        <p:nvSpPr>
+          <p:cNvPr id="14" name="Text 12"/>
+          <p:cNvSpPr txBox="1"/>
+          <p:nvPr/>
+        </p:nvSpPr>
+        <p:spPr>
+          <a:xfrm>
+            <a:off x="731520" y="4572000"/>
+            <a:ext cx="1645920" cy="182880"/>
+          </a:xfrm>
+          <a:prstGeom prst="rect">
+            <a:avLst/>
+          </a:prstGeom>
+          <a:noFill/>
+          <a:ln/>
+        </p:spPr>
+        <p:txBody>
+          <a:bodyPr wrap="square" lIns="0" tIns="0" rIns="0" bIns="0" rtlCol="0" anchor="ctr"/>
+          <a:lstStyle/>
+          <a:p>
+            <a:pPr indent="0" marL="0">
+              <a:buNone/>
+            </a:pPr>
+            <a:r>
+              <a:rPr lang="en-US" sz="800" b="1" dirty="0">
+                <a:solidFill>
+                  <a:srgbClr val="595959"/>
+                </a:solidFill>
+                <a:latin typeface="Figtree" pitchFamily="34" charset="0"/>
+                <a:ea typeface="Figtree" pitchFamily="34" charset="-122"/>
+                <a:cs typeface="Figtree" pitchFamily="34" charset="-120"/>
+              </a:rPr>
+              <a:t>CLIC</a:t>
+            </a:r>
+            <a:endParaRPr lang="en-US" sz="800" dirty="0"/>
+          </a:p>
+        </p:txBody>
+      </p:sp>
+      <p:sp>
+        <p:nvSpPr>
+          <p:cNvPr id="15" name="Text 13"/>
+          <p:cNvSpPr txBox="1"/>
+          <p:nvPr/>
+        </p:nvSpPr>
+        <p:spPr>
+          <a:xfrm>
+            <a:off x="2560320" y="4572000"/>
+            <a:ext cx="2286000" cy="228600"/>
+          </a:xfrm>
+          <a:prstGeom prst="rect">
+            <a:avLst/>
+          </a:prstGeom>
+          <a:noFill/>
+          <a:ln/>
+        </p:spPr>
+        <p:txBody>
+          <a:bodyPr wrap="square" lIns="0" tIns="0" rIns="0" bIns="0" rtlCol="0" anchor="ctr"/>
+          <a:lstStyle/>
+          <a:p>
+            <a:pPr indent="0" marL="0">
+              <a:buNone/>
+            </a:pPr>
+            <a:r>
+              <a:rPr lang="en-US" sz="1400" b="1" dirty="0">
+                <a:solidFill>
+                  <a:srgbClr val="191919"/>
+                </a:solidFill>
+                <a:latin typeface="Figtree" pitchFamily="34" charset="0"/>
+                <a:ea typeface="Figtree" pitchFamily="34" charset="-122"/>
+                <a:cs typeface="Figtree" pitchFamily="34" charset="-120"/>
+              </a:rPr>
+              <a:t>2.288</a:t>
+            </a:r>
+            <a:endParaRPr lang="en-US" sz="1400" dirty="0"/>
+          </a:p>
+        </p:txBody>
+      </p:sp>
+      <p:sp>
+        <p:nvSpPr>
+          <p:cNvPr id="16" name="Text 14"/>
+          <p:cNvSpPr txBox="1"/>
+          <p:nvPr/>
+        </p:nvSpPr>
+        <p:spPr>
+          <a:xfrm>
+            <a:off x="731520" y="5029200"/>
+            <a:ext cx="1645920" cy="182880"/>
+          </a:xfrm>
+          <a:prstGeom prst="rect">
+            <a:avLst/>
+          </a:prstGeom>
+          <a:noFill/>
+          <a:ln/>
+        </p:spPr>
+        <p:txBody>
+          <a:bodyPr wrap="square" lIns="0" tIns="0" rIns="0" bIns="0" rtlCol="0" anchor="ctr"/>
+          <a:lstStyle/>
+          <a:p>
+            <a:pPr indent="0" marL="0">
+              <a:buNone/>
+            </a:pPr>
+            <a:r>
+              <a:rPr lang="en-US" sz="800" b="1" dirty="0">
+                <a:solidFill>
+                  <a:srgbClr val="595959"/>
+                </a:solidFill>
+                <a:latin typeface="Figtree" pitchFamily="34" charset="0"/>
+                <a:ea typeface="Figtree" pitchFamily="34" charset="-122"/>
+                <a:cs typeface="Figtree" pitchFamily="34" charset="-120"/>
+              </a:rPr>
+              <a:t>INVESTIMENTO</a:t>
+            </a:r>
+            <a:endParaRPr lang="en-US" sz="800" dirty="0"/>
+          </a:p>
+        </p:txBody>
+      </p:sp>
+      <p:sp>
+        <p:nvSpPr>
+          <p:cNvPr id="17" name="Text 15"/>
+          <p:cNvSpPr txBox="1"/>
+          <p:nvPr/>
+        </p:nvSpPr>
+        <p:spPr>
+          <a:xfrm>
+            <a:off x="2560320" y="5029200"/>
+            <a:ext cx="2286000" cy="228600"/>
+          </a:xfrm>
+          <a:prstGeom prst="rect">
+            <a:avLst/>
+          </a:prstGeom>
+          <a:noFill/>
+          <a:ln/>
+        </p:spPr>
+        <p:txBody>
+          <a:bodyPr wrap="square" lIns="0" tIns="0" rIns="0" bIns="0" rtlCol="0" anchor="ctr"/>
+          <a:lstStyle/>
+          <a:p>
+            <a:pPr indent="0" marL="0">
+              <a:buNone/>
+            </a:pPr>
+            <a:r>
+              <a:rPr lang="en-US" sz="1400" b="1" dirty="0">
+                <a:solidFill>
+                  <a:srgbClr val="191919"/>
+                </a:solidFill>
+                <a:latin typeface="Figtree" pitchFamily="34" charset="0"/>
+                <a:ea typeface="Figtree" pitchFamily="34" charset="-122"/>
+                <a:cs typeface="Figtree" pitchFamily="34" charset="-120"/>
+              </a:rPr>
+              <a:t>636 €</a:t>
+            </a:r>
+            <a:endParaRPr lang="en-US" sz="1400" dirty="0"/>
+          </a:p>
+        </p:txBody>
+      </p:sp>
+      <p:sp>
+        <p:nvSpPr>
           <p:cNvPr id="18" name="Text 16"/>
           <p:cNvSpPr txBox="1"/>
           <p:nvPr/>
         </p:nvSpPr>
         <p:spPr>
           <a:xfrm>
-            <a:off x="6492240" y="1828800"/>
+            <a:off x="731520" y="5486400"/>
+            <a:ext cx="1645920" cy="182880"/>
+          </a:xfrm>
+          <a:prstGeom prst="rect">
+            <a:avLst/>
+          </a:prstGeom>
+          <a:noFill/>
+          <a:ln/>
+        </p:spPr>
+        <p:txBody>
+          <a:bodyPr wrap="square" lIns="0" tIns="0" rIns="0" bIns="0" rtlCol="0" anchor="ctr"/>
+          <a:lstStyle/>
+          <a:p>
+            <a:pPr indent="0" marL="0">
+              <a:buNone/>
+            </a:pPr>
+            <a:r>
+              <a:rPr lang="en-US" sz="800" b="1" dirty="0">
+                <a:solidFill>
+                  <a:srgbClr val="595959"/>
+                </a:solidFill>
+                <a:latin typeface="Figtree" pitchFamily="34" charset="0"/>
+                <a:ea typeface="Figtree" pitchFamily="34" charset="-122"/>
+                <a:cs typeface="Figtree" pitchFamily="34" charset="-120"/>
+              </a:rPr>
+              <a:t>CPC</a:t>
+            </a:r>
+            <a:endParaRPr lang="en-US" sz="800" dirty="0"/>
+          </a:p>
+        </p:txBody>
+      </p:sp>
+      <p:sp>
+        <p:nvSpPr>
+          <p:cNvPr id="19" name="Text 17"/>
+          <p:cNvSpPr txBox="1"/>
+          <p:nvPr/>
+        </p:nvSpPr>
+        <p:spPr>
+          <a:xfrm>
+            <a:off x="2560320" y="5486400"/>
+            <a:ext cx="2286000" cy="228600"/>
+          </a:xfrm>
+          <a:prstGeom prst="rect">
+            <a:avLst/>
+          </a:prstGeom>
+          <a:noFill/>
+          <a:ln/>
+        </p:spPr>
+        <p:txBody>
+          <a:bodyPr wrap="square" lIns="0" tIns="0" rIns="0" bIns="0" rtlCol="0" anchor="ctr"/>
+          <a:lstStyle/>
+          <a:p>
+            <a:pPr indent="0" marL="0">
+              <a:buNone/>
+            </a:pPr>
+            <a:r>
+              <a:rPr lang="en-US" sz="1400" b="1" dirty="0">
+                <a:solidFill>
+                  <a:srgbClr val="191919"/>
+                </a:solidFill>
+                <a:latin typeface="Figtree" pitchFamily="34" charset="0"/>
+                <a:ea typeface="Figtree" pitchFamily="34" charset="-122"/>
+                <a:cs typeface="Figtree" pitchFamily="34" charset="-120"/>
+              </a:rPr>
+              <a:t>0,28 €</a:t>
+            </a:r>
+            <a:endParaRPr lang="en-US" sz="1400" dirty="0"/>
+          </a:p>
+        </p:txBody>
+      </p:sp>
+      <p:sp>
+        <p:nvSpPr>
+          <p:cNvPr id="20" name="Shape 18"/>
+          <p:cNvSpPr/>
+          <p:nvPr/>
+        </p:nvSpPr>
+        <p:spPr>
+          <a:xfrm>
+            <a:off x="6217920" y="3017520"/>
+            <a:ext cx="5394960" cy="3017520"/>
+          </a:xfrm>
+          <a:prstGeom prst="roundRect">
+            <a:avLst>
+              <a:gd name="adj" fmla="val 3030"/>
+            </a:avLst>
+          </a:prstGeom>
+          <a:solidFill>
+            <a:srgbClr val="F4F5F6"/>
+          </a:solidFill>
+          <a:ln/>
+        </p:spPr>
+      </p:sp>
+      <p:sp>
+        <p:nvSpPr>
+          <p:cNvPr id="21" name="Text 19"/>
+          <p:cNvSpPr txBox="1"/>
+          <p:nvPr/>
+        </p:nvSpPr>
+        <p:spPr>
+          <a:xfrm>
+            <a:off x="6492240" y="3200400"/>
             <a:ext cx="3657600" cy="365760"/>
           </a:xfrm>
           <a:prstGeom prst="rect">
@@ -7201,7 +8219,7 @@
                 <a:ea typeface="Figtree" pitchFamily="34" charset="-122"/>
                 <a:cs typeface="Figtree" pitchFamily="34" charset="-120"/>
               </a:rPr>
-              <a:t>Risultati Meta</a:t>
+              <a:t>Campagna Meta Ads</a:t>
             </a:r>
             <a:endParaRPr lang="en-US" sz="1600" dirty="0"/>
           </a:p>
@@ -7209,13 +8227,13 @@
       </p:sp>
       <p:sp>
         <p:nvSpPr>
-          <p:cNvPr id="19" name="Text 17"/>
-          <p:cNvSpPr txBox="1"/>
-          <p:nvPr/>
-        </p:nvSpPr>
-        <p:spPr>
-          <a:xfrm>
-            <a:off x="6492240" y="2194560"/>
+          <p:cNvPr id="22" name="Text 20"/>
+          <p:cNvSpPr txBox="1"/>
+          <p:nvPr/>
+        </p:nvSpPr>
+        <p:spPr>
+          <a:xfrm>
+            <a:off x="6492240" y="3566160"/>
             <a:ext cx="4572000" cy="274320"/>
           </a:xfrm>
           <a:prstGeom prst="rect">
@@ -7240,7 +8258,7 @@
                 <a:ea typeface="Figtree" pitchFamily="34" charset="-122"/>
                 <a:cs typeface="Figtree" pitchFamily="34" charset="-120"/>
               </a:rPr>
-              <a:t>Campagna Lead Gen Rivenditori DEF</a:t>
+              <a:t>Lead Gen Rivenditori DEF</a:t>
             </a:r>
             <a:endParaRPr lang="en-US" sz="1000" dirty="0"/>
           </a:p>
@@ -7248,13 +8266,13 @@
       </p:sp>
       <p:sp>
         <p:nvSpPr>
-          <p:cNvPr id="20" name="Text 18"/>
-          <p:cNvSpPr txBox="1"/>
-          <p:nvPr/>
-        </p:nvSpPr>
-        <p:spPr>
-          <a:xfrm>
-            <a:off x="6492240" y="2743200"/>
+          <p:cNvPr id="23" name="Text 21"/>
+          <p:cNvSpPr txBox="1"/>
+          <p:nvPr/>
+        </p:nvSpPr>
+        <p:spPr>
+          <a:xfrm>
+            <a:off x="6492240" y="4114800"/>
             <a:ext cx="1645920" cy="182880"/>
           </a:xfrm>
           <a:prstGeom prst="rect">
@@ -7279,7 +8297,7 @@
                 <a:ea typeface="Figtree" pitchFamily="34" charset="-122"/>
                 <a:cs typeface="Figtree" pitchFamily="34" charset="-120"/>
               </a:rPr>
-              <a:t>INVII FORM LP</a:t>
+              <a:t>REACH</a:t>
             </a:r>
             <a:endParaRPr lang="en-US" sz="800" dirty="0"/>
           </a:p>
@@ -7287,30 +8305,30 @@
       </p:sp>
       <p:sp>
         <p:nvSpPr>
-          <p:cNvPr id="21" name="Text 19"/>
-          <p:cNvSpPr txBox="1"/>
-          <p:nvPr/>
-        </p:nvSpPr>
-        <p:spPr>
-          <a:xfrm>
-            <a:off x="6492240" y="2926080"/>
-            <a:ext cx="2286000" cy="274320"/>
-          </a:xfrm>
-          <a:prstGeom prst="rect">
-            <a:avLst/>
-          </a:prstGeom>
-          <a:noFill/>
-          <a:ln/>
-        </p:spPr>
-        <p:txBody>
-          <a:bodyPr wrap="square" lIns="0" tIns="0" rIns="0" bIns="0" rtlCol="0" anchor="ctr"/>
-          <a:lstStyle/>
-          <a:p>
-            <a:pPr indent="0" marL="0">
-              <a:buNone/>
-            </a:pPr>
-            <a:r>
-              <a:rPr lang="en-US" sz="1600" b="1" dirty="0">
+          <p:cNvPr id="24" name="Text 22"/>
+          <p:cNvSpPr txBox="1"/>
+          <p:nvPr/>
+        </p:nvSpPr>
+        <p:spPr>
+          <a:xfrm>
+            <a:off x="8321040" y="4114800"/>
+            <a:ext cx="2286000" cy="228600"/>
+          </a:xfrm>
+          <a:prstGeom prst="rect">
+            <a:avLst/>
+          </a:prstGeom>
+          <a:noFill/>
+          <a:ln/>
+        </p:spPr>
+        <p:txBody>
+          <a:bodyPr wrap="square" lIns="0" tIns="0" rIns="0" bIns="0" rtlCol="0" anchor="ctr"/>
+          <a:lstStyle/>
+          <a:p>
+            <a:pPr indent="0" marL="0">
+              <a:buNone/>
+            </a:pPr>
+            <a:r>
+              <a:rPr lang="en-US" sz="1400" b="1" dirty="0">
                 <a:solidFill>
                   <a:srgbClr val="191919"/>
                 </a:solidFill>
@@ -7318,46 +8336,46 @@
                 <a:ea typeface="Figtree" pitchFamily="34" charset="-122"/>
                 <a:cs typeface="Figtree" pitchFamily="34" charset="-120"/>
               </a:rPr>
-              <a:t>155</a:t>
-            </a:r>
-            <a:endParaRPr lang="en-US" sz="1600" dirty="0"/>
-          </a:p>
-        </p:txBody>
-      </p:sp>
-      <p:sp>
-        <p:nvSpPr>
-          <p:cNvPr id="22" name="Text 20"/>
-          <p:cNvSpPr txBox="1"/>
-          <p:nvPr/>
-        </p:nvSpPr>
-        <p:spPr>
-          <a:xfrm>
-            <a:off x="8686800" y="2926080"/>
-            <a:ext cx="1828800" cy="274320"/>
-          </a:xfrm>
-          <a:prstGeom prst="rect">
-            <a:avLst/>
-          </a:prstGeom>
-          <a:noFill/>
-          <a:ln/>
-        </p:spPr>
-        <p:txBody>
-          <a:bodyPr wrap="square" lIns="0" tIns="0" rIns="0" bIns="0" rtlCol="0" anchor="ctr"/>
-          <a:lstStyle/>
-          <a:p>
-            <a:pPr indent="0" marL="0">
-              <a:buNone/>
-            </a:pPr>
-            <a:r>
-              <a:rPr lang="en-US" sz="800" dirty="0">
-                <a:solidFill>
-                  <a:srgbClr val="AAAAAA"/>
-                </a:solidFill>
-                <a:latin typeface="Figtree" pitchFamily="34" charset="0"/>
-                <a:ea typeface="Figtree" pitchFamily="34" charset="-122"/>
-                <a:cs typeface="Figtree" pitchFamily="34" charset="-120"/>
-              </a:rPr>
-              <a:t>(da tutte le sorgenti)</a:t>
+              <a:t>36.082</a:t>
+            </a:r>
+            <a:endParaRPr lang="en-US" sz="1400" dirty="0"/>
+          </a:p>
+        </p:txBody>
+      </p:sp>
+      <p:sp>
+        <p:nvSpPr>
+          <p:cNvPr id="25" name="Text 23"/>
+          <p:cNvSpPr txBox="1"/>
+          <p:nvPr/>
+        </p:nvSpPr>
+        <p:spPr>
+          <a:xfrm>
+            <a:off x="6492240" y="4572000"/>
+            <a:ext cx="1645920" cy="182880"/>
+          </a:xfrm>
+          <a:prstGeom prst="rect">
+            <a:avLst/>
+          </a:prstGeom>
+          <a:noFill/>
+          <a:ln/>
+        </p:spPr>
+        <p:txBody>
+          <a:bodyPr wrap="square" lIns="0" tIns="0" rIns="0" bIns="0" rtlCol="0" anchor="ctr"/>
+          <a:lstStyle/>
+          <a:p>
+            <a:pPr indent="0" marL="0">
+              <a:buNone/>
+            </a:pPr>
+            <a:r>
+              <a:rPr lang="en-US" sz="800" b="1" dirty="0">
+                <a:solidFill>
+                  <a:srgbClr val="595959"/>
+                </a:solidFill>
+                <a:latin typeface="Figtree" pitchFamily="34" charset="0"/>
+                <a:ea typeface="Figtree" pitchFamily="34" charset="-122"/>
+                <a:cs typeface="Figtree" pitchFamily="34" charset="-120"/>
+              </a:rPr>
+              <a:t>LINK CLIC</a:t>
             </a:r>
             <a:endParaRPr lang="en-US" sz="800" dirty="0"/>
           </a:p>
@@ -7365,13 +8383,52 @@
       </p:sp>
       <p:sp>
         <p:nvSpPr>
-          <p:cNvPr id="23" name="Text 21"/>
-          <p:cNvSpPr txBox="1"/>
-          <p:nvPr/>
-        </p:nvSpPr>
-        <p:spPr>
-          <a:xfrm>
-            <a:off x="6492240" y="3337560"/>
+          <p:cNvPr id="26" name="Text 24"/>
+          <p:cNvSpPr txBox="1"/>
+          <p:nvPr/>
+        </p:nvSpPr>
+        <p:spPr>
+          <a:xfrm>
+            <a:off x="8321040" y="4572000"/>
+            <a:ext cx="2286000" cy="228600"/>
+          </a:xfrm>
+          <a:prstGeom prst="rect">
+            <a:avLst/>
+          </a:prstGeom>
+          <a:noFill/>
+          <a:ln/>
+        </p:spPr>
+        <p:txBody>
+          <a:bodyPr wrap="square" lIns="0" tIns="0" rIns="0" bIns="0" rtlCol="0" anchor="ctr"/>
+          <a:lstStyle/>
+          <a:p>
+            <a:pPr indent="0" marL="0">
+              <a:buNone/>
+            </a:pPr>
+            <a:r>
+              <a:rPr lang="en-US" sz="1400" b="1" dirty="0">
+                <a:solidFill>
+                  <a:srgbClr val="191919"/>
+                </a:solidFill>
+                <a:latin typeface="Figtree" pitchFamily="34" charset="0"/>
+                <a:ea typeface="Figtree" pitchFamily="34" charset="-122"/>
+                <a:cs typeface="Figtree" pitchFamily="34" charset="-120"/>
+              </a:rPr>
+              <a:t>2.308</a:t>
+            </a:r>
+            <a:endParaRPr lang="en-US" sz="1400" dirty="0"/>
+          </a:p>
+        </p:txBody>
+      </p:sp>
+      <p:sp>
+        <p:nvSpPr>
+          <p:cNvPr id="27" name="Text 25"/>
+          <p:cNvSpPr txBox="1"/>
+          <p:nvPr/>
+        </p:nvSpPr>
+        <p:spPr>
+          <a:xfrm>
+            <a:off x="6492240" y="5029200"/>
             <a:ext cx="1645920" cy="182880"/>
           </a:xfrm>
           <a:prstGeom prst="rect">
@@ -7396,7 +8453,7 @@
                 <a:ea typeface="Figtree" pitchFamily="34" charset="-122"/>
                 <a:cs typeface="Figtree" pitchFamily="34" charset="-120"/>
               </a:rPr>
-              <a:t>REACH</a:t>
+              <a:t>INVESTIMENTO</a:t>
             </a:r>
             <a:endParaRPr lang="en-US" sz="800" dirty="0"/>
           </a:p>
@@ -7404,30 +8461,30 @@
       </p:sp>
       <p:sp>
         <p:nvSpPr>
-          <p:cNvPr id="24" name="Text 22"/>
-          <p:cNvSpPr txBox="1"/>
-          <p:nvPr/>
-        </p:nvSpPr>
-        <p:spPr>
-          <a:xfrm>
-            <a:off x="6492240" y="3520440"/>
-            <a:ext cx="2286000" cy="274320"/>
-          </a:xfrm>
-          <a:prstGeom prst="rect">
-            <a:avLst/>
-          </a:prstGeom>
-          <a:noFill/>
-          <a:ln/>
-        </p:spPr>
-        <p:txBody>
-          <a:bodyPr wrap="square" lIns="0" tIns="0" rIns="0" bIns="0" rtlCol="0" anchor="ctr"/>
-          <a:lstStyle/>
-          <a:p>
-            <a:pPr indent="0" marL="0">
-              <a:buNone/>
-            </a:pPr>
-            <a:r>
-              <a:rPr lang="en-US" sz="1600" b="1" dirty="0">
+          <p:cNvPr id="28" name="Text 26"/>
+          <p:cNvSpPr txBox="1"/>
+          <p:nvPr/>
+        </p:nvSpPr>
+        <p:spPr>
+          <a:xfrm>
+            <a:off x="8321040" y="5029200"/>
+            <a:ext cx="2286000" cy="228600"/>
+          </a:xfrm>
+          <a:prstGeom prst="rect">
+            <a:avLst/>
+          </a:prstGeom>
+          <a:noFill/>
+          <a:ln/>
+        </p:spPr>
+        <p:txBody>
+          <a:bodyPr wrap="square" lIns="0" tIns="0" rIns="0" bIns="0" rtlCol="0" anchor="ctr"/>
+          <a:lstStyle/>
+          <a:p>
+            <a:pPr indent="0" marL="0">
+              <a:buNone/>
+            </a:pPr>
+            <a:r>
+              <a:rPr lang="en-US" sz="1400" b="1" dirty="0">
                 <a:solidFill>
                   <a:srgbClr val="191919"/>
                 </a:solidFill>
@@ -7435,21 +8492,21 @@
                 <a:ea typeface="Figtree" pitchFamily="34" charset="-122"/>
                 <a:cs typeface="Figtree" pitchFamily="34" charset="-120"/>
               </a:rPr>
-              <a:t>36.082</a:t>
-            </a:r>
-            <a:endParaRPr lang="en-US" sz="1600" dirty="0"/>
-          </a:p>
-        </p:txBody>
-      </p:sp>
-      <p:sp>
-        <p:nvSpPr>
-          <p:cNvPr id="25" name="Text 23"/>
-          <p:cNvSpPr txBox="1"/>
-          <p:nvPr/>
-        </p:nvSpPr>
-        <p:spPr>
-          <a:xfrm>
-            <a:off x="6492240" y="3931920"/>
+              <a:t>1.108 €</a:t>
+            </a:r>
+            <a:endParaRPr lang="en-US" sz="1400" dirty="0"/>
+          </a:p>
+        </p:txBody>
+      </p:sp>
+      <p:sp>
+        <p:nvSpPr>
+          <p:cNvPr id="29" name="Text 27"/>
+          <p:cNvSpPr txBox="1"/>
+          <p:nvPr/>
+        </p:nvSpPr>
+        <p:spPr>
+          <a:xfrm>
+            <a:off x="6492240" y="5486400"/>
             <a:ext cx="1645920" cy="182880"/>
           </a:xfrm>
           <a:prstGeom prst="rect">
@@ -7474,7 +8531,7 @@
                 <a:ea typeface="Figtree" pitchFamily="34" charset="-122"/>
                 <a:cs typeface="Figtree" pitchFamily="34" charset="-120"/>
               </a:rPr>
-              <a:t>LINK CLIC</a:t>
+              <a:t>CTR</a:t>
             </a:r>
             <a:endParaRPr lang="en-US" sz="800" dirty="0"/>
           </a:p>
@@ -7482,30 +8539,30 @@
       </p:sp>
       <p:sp>
         <p:nvSpPr>
-          <p:cNvPr id="26" name="Text 24"/>
-          <p:cNvSpPr txBox="1"/>
-          <p:nvPr/>
-        </p:nvSpPr>
-        <p:spPr>
-          <a:xfrm>
-            <a:off x="6492240" y="4114800"/>
-            <a:ext cx="2286000" cy="274320"/>
-          </a:xfrm>
-          <a:prstGeom prst="rect">
-            <a:avLst/>
-          </a:prstGeom>
-          <a:noFill/>
-          <a:ln/>
-        </p:spPr>
-        <p:txBody>
-          <a:bodyPr wrap="square" lIns="0" tIns="0" rIns="0" bIns="0" rtlCol="0" anchor="ctr"/>
-          <a:lstStyle/>
-          <a:p>
-            <a:pPr indent="0" marL="0">
-              <a:buNone/>
-            </a:pPr>
-            <a:r>
-              <a:rPr lang="en-US" sz="1600" b="1" dirty="0">
+          <p:cNvPr id="30" name="Text 28"/>
+          <p:cNvSpPr txBox="1"/>
+          <p:nvPr/>
+        </p:nvSpPr>
+        <p:spPr>
+          <a:xfrm>
+            <a:off x="8321040" y="5486400"/>
+            <a:ext cx="2286000" cy="228600"/>
+          </a:xfrm>
+          <a:prstGeom prst="rect">
+            <a:avLst/>
+          </a:prstGeom>
+          <a:noFill/>
+          <a:ln/>
+        </p:spPr>
+        <p:txBody>
+          <a:bodyPr wrap="square" lIns="0" tIns="0" rIns="0" bIns="0" rtlCol="0" anchor="ctr"/>
+          <a:lstStyle/>
+          <a:p>
+            <a:pPr indent="0" marL="0">
+              <a:buNone/>
+            </a:pPr>
+            <a:r>
+              <a:rPr lang="en-US" sz="1400" b="1" dirty="0">
                 <a:solidFill>
                   <a:srgbClr val="191919"/>
                 </a:solidFill>
@@ -7513,165 +8570,9 @@
                 <a:ea typeface="Figtree" pitchFamily="34" charset="-122"/>
                 <a:cs typeface="Figtree" pitchFamily="34" charset="-120"/>
               </a:rPr>
-              <a:t>2.308</a:t>
-            </a:r>
-            <a:endParaRPr lang="en-US" sz="1600" dirty="0"/>
-          </a:p>
-        </p:txBody>
-      </p:sp>
-      <p:sp>
-        <p:nvSpPr>
-          <p:cNvPr id="27" name="Text 25"/>
-          <p:cNvSpPr txBox="1"/>
-          <p:nvPr/>
-        </p:nvSpPr>
-        <p:spPr>
-          <a:xfrm>
-            <a:off x="6492240" y="4526280"/>
-            <a:ext cx="1645920" cy="182880"/>
-          </a:xfrm>
-          <a:prstGeom prst="rect">
-            <a:avLst/>
-          </a:prstGeom>
-          <a:noFill/>
-          <a:ln/>
-        </p:spPr>
-        <p:txBody>
-          <a:bodyPr wrap="square" lIns="0" tIns="0" rIns="0" bIns="0" rtlCol="0" anchor="ctr"/>
-          <a:lstStyle/>
-          <a:p>
-            <a:pPr indent="0" marL="0">
-              <a:buNone/>
-            </a:pPr>
-            <a:r>
-              <a:rPr lang="en-US" sz="800" b="1" dirty="0">
-                <a:solidFill>
-                  <a:srgbClr val="595959"/>
-                </a:solidFill>
-                <a:latin typeface="Figtree" pitchFamily="34" charset="0"/>
-                <a:ea typeface="Figtree" pitchFamily="34" charset="-122"/>
-                <a:cs typeface="Figtree" pitchFamily="34" charset="-120"/>
-              </a:rPr>
-              <a:t>CTR</a:t>
-            </a:r>
-            <a:endParaRPr lang="en-US" sz="800" dirty="0"/>
-          </a:p>
-        </p:txBody>
-      </p:sp>
-      <p:sp>
-        <p:nvSpPr>
-          <p:cNvPr id="28" name="Text 26"/>
-          <p:cNvSpPr txBox="1"/>
-          <p:nvPr/>
-        </p:nvSpPr>
-        <p:spPr>
-          <a:xfrm>
-            <a:off x="6492240" y="4709160"/>
-            <a:ext cx="2286000" cy="274320"/>
-          </a:xfrm>
-          <a:prstGeom prst="rect">
-            <a:avLst/>
-          </a:prstGeom>
-          <a:noFill/>
-          <a:ln/>
-        </p:spPr>
-        <p:txBody>
-          <a:bodyPr wrap="square" lIns="0" tIns="0" rIns="0" bIns="0" rtlCol="0" anchor="ctr"/>
-          <a:lstStyle/>
-          <a:p>
-            <a:pPr indent="0" marL="0">
-              <a:buNone/>
-            </a:pPr>
-            <a:r>
-              <a:rPr lang="en-US" sz="1600" b="1" dirty="0">
-                <a:solidFill>
-                  <a:srgbClr val="191919"/>
-                </a:solidFill>
-                <a:latin typeface="Figtree" pitchFamily="34" charset="0"/>
-                <a:ea typeface="Figtree" pitchFamily="34" charset="-122"/>
-                <a:cs typeface="Figtree" pitchFamily="34" charset="-120"/>
-              </a:rPr>
               <a:t>1,92%</a:t>
             </a:r>
-            <a:endParaRPr lang="en-US" sz="1600" dirty="0"/>
-          </a:p>
-        </p:txBody>
-      </p:sp>
-      <p:sp>
-        <p:nvSpPr>
-          <p:cNvPr id="29" name="Text 27"/>
-          <p:cNvSpPr txBox="1"/>
-          <p:nvPr/>
-        </p:nvSpPr>
-        <p:spPr>
-          <a:xfrm>
-            <a:off x="6492240" y="5120640"/>
-            <a:ext cx="1645920" cy="182880"/>
-          </a:xfrm>
-          <a:prstGeom prst="rect">
-            <a:avLst/>
-          </a:prstGeom>
-          <a:noFill/>
-          <a:ln/>
-        </p:spPr>
-        <p:txBody>
-          <a:bodyPr wrap="square" lIns="0" tIns="0" rIns="0" bIns="0" rtlCol="0" anchor="ctr"/>
-          <a:lstStyle/>
-          <a:p>
-            <a:pPr indent="0" marL="0">
-              <a:buNone/>
-            </a:pPr>
-            <a:r>
-              <a:rPr lang="en-US" sz="800" b="1" dirty="0">
-                <a:solidFill>
-                  <a:srgbClr val="595959"/>
-                </a:solidFill>
-                <a:latin typeface="Figtree" pitchFamily="34" charset="0"/>
-                <a:ea typeface="Figtree" pitchFamily="34" charset="-122"/>
-                <a:cs typeface="Figtree" pitchFamily="34" charset="-120"/>
-              </a:rPr>
-              <a:t>INVESTIMENTO</a:t>
-            </a:r>
-            <a:endParaRPr lang="en-US" sz="800" dirty="0"/>
-          </a:p>
-        </p:txBody>
-      </p:sp>
-      <p:sp>
-        <p:nvSpPr>
-          <p:cNvPr id="30" name="Text 28"/>
-          <p:cNvSpPr txBox="1"/>
-          <p:nvPr/>
-        </p:nvSpPr>
-        <p:spPr>
-          <a:xfrm>
-            <a:off x="6492240" y="5303520"/>
-            <a:ext cx="2286000" cy="274320"/>
-          </a:xfrm>
-          <a:prstGeom prst="rect">
-            <a:avLst/>
-          </a:prstGeom>
-          <a:noFill/>
-          <a:ln/>
-        </p:spPr>
-        <p:txBody>
-          <a:bodyPr wrap="square" lIns="0" tIns="0" rIns="0" bIns="0" rtlCol="0" anchor="ctr"/>
-          <a:lstStyle/>
-          <a:p>
-            <a:pPr indent="0" marL="0">
-              <a:buNone/>
-            </a:pPr>
-            <a:r>
-              <a:rPr lang="en-US" sz="1600" b="1" dirty="0">
-                <a:solidFill>
-                  <a:srgbClr val="191919"/>
-                </a:solidFill>
-                <a:latin typeface="Figtree" pitchFamily="34" charset="0"/>
-                <a:ea typeface="Figtree" pitchFamily="34" charset="-122"/>
-                <a:cs typeface="Figtree" pitchFamily="34" charset="-120"/>
-              </a:rPr>
-              <a:t>1.108 €</a:t>
-            </a:r>
-            <a:endParaRPr lang="en-US" sz="1600" dirty="0"/>
+            <a:endParaRPr lang="en-US" sz="1400" dirty="0"/>
           </a:p>
         </p:txBody>
       </p:sp>
@@ -7708,7 +8609,7 @@
                 <a:ea typeface="Figtree" pitchFamily="34" charset="-122"/>
                 <a:cs typeface="Figtree" pitchFamily="34" charset="-120"/>
               </a:rPr>
-              <a:t>Fonte dati: Google Ads, Meta Ads, GA4 | Periodo analizzato: set 2026</a:t>
+              <a:t>Fonte dati: HubSpot, Google Ads, Meta Ads | Periodo analizzato: set 2026</a:t>
             </a:r>
             <a:endParaRPr lang="en-US" sz="800" dirty="0"/>
           </a:p>
@@ -10763,7 +11664,7 @@
                 <a:ea typeface="Figtree" pitchFamily="34" charset="-122"/>
                 <a:cs typeface="Figtree" pitchFamily="34" charset="-120"/>
               </a:rPr>
-              <a:t>Le lead totali raddoppiano: 680 eventi lead vs 322 del 2025 (+111%). La campagna Lead Gen Rivenditori genera 155 invii form, con Google e Meta come driver principali. Le registrazioni Area Pro crescono del 37,5% (33 vs 24).</a:t>
+              <a:t>La nuova landing rivenditori porta 215 preventivi (nuovo canale). Le lead tradizionali calano del 24,5% (244 vs 323), in particolare FEEL5 (-45,5%) e info prodotto (-39%). Registrazioni area stabili (+1,8%). Totale lead incl. LP: 459.</a:t>
             </a:r>
             <a:endParaRPr lang="en-US" sz="900" dirty="0"/>
           </a:p>

</xml_diff>

<commit_message>
Riprogetta slide paid: rimuovi Pinterest, diversifica grafici da tabelle
- Slide Focus Advertising: solo Google Ads e Meta Ads a 2 colonne,
  rimosso Pinterest (canale organico)
- Slide Google Ads dettaglio: grafico clic per campagna al posto
  dell'investimento (evita doppia visualizzazione stessa metrica)
- Slide Meta Ads dettaglio: grafico CPC per campagna, evidenzia
  lo spread di efficienza 10x tra le campagne

Co-Authored-By: Claude Opus 4.6 <noreply@anthropic.com>
Claude-Session: https://claude.ai/code/session_01Nok6HhGnvhEchJRhgCetML
</commit_message>
<xml_diff>
--- a/FerreroLegnoReport_settembre_2026.pptx
+++ b/FerreroLegnoReport_settembre_2026.pptx
@@ -129,12 +129,12 @@
   <p:extLst>
     <p:ext uri="{521415D9-36F7-43E2-AB2F-B90AF26B5E84}">
       <p14:sectionLst xmlns:p14="http://schemas.microsoft.com/office/powerpoint/2010/main">
-        <p14:section name="Cover" id="{1435933a-63c6-1193-6bc9-08d0c2207d3b}">
+        <p14:section name="Cover" id="{f92ba46d-d72c-bacf-2d4f-495a71a4fa42}">
           <p14:sldIdLst>
             <p14:sldId id="256"/>
           </p14:sldIdLst>
         </p14:section>
-        <p14:section name="Andamento e risultati" id="{36846d76-74d9-0f41-6ab4-c70aaea304a2}">
+        <p14:section name="Andamento e risultati" id="{0442d78d-a681-bc8b-9a99-7c2694691d88}">
           <p14:sldIdLst>
             <p14:sldId id="257"/>
             <p14:sldId id="258"/>
@@ -148,7 +148,7 @@
             <p14:sldId id="266"/>
           </p14:sldIdLst>
         </p14:section>
-        <p14:section name="Lead Generation" id="{6fdfd4b0-1e7b-575e-754d-2bbfce1fd16a}">
+        <p14:section name="Lead Generation" id="{f24579c0-b193-275b-16bb-876aa95ed2ea}">
           <p14:sldIdLst>
             <p14:sldId id="267"/>
             <p14:sldId id="268"/>
@@ -157,7 +157,7 @@
             <p14:sldId id="271"/>
           </p14:sldIdLst>
         </p14:section>
-        <p14:section name="Focus Magazine" id="{12e6eb69-ee00-a6fe-ed86-f87460077417}">
+        <p14:section name="Focus Magazine" id="{ae7b677c-473f-3c39-7404-47793ac30f14}">
           <p14:sldIdLst>
             <p14:sldId id="272"/>
             <p14:sldId id="273"/>
@@ -165,7 +165,7 @@
             <p14:sldId id="275"/>
           </p14:sldIdLst>
         </p14:section>
-        <p14:section name="In chiusura" id="{863de84c-fbd6-4d1c-5667-a767112fb386}">
+        <p14:section name="In chiusura" id="{0447de36-0e05-085d-102f-8f4c553c16a3}">
           <p14:sldIdLst>
             <p14:sldId id="276"/>
             <p14:sldId id="277"/>
@@ -2468,7 +2468,7 @@
     <c:plotArea>
       <c:layout/>
       <c:barChart>
-        <c:barDir val="col"/>
+        <c:barDir val="bar"/>
         <c:grouping val="clustered"/>
         <c:varyColors val="0"/>
         <c:ser>
@@ -2480,7 +2480,7 @@
               <c:strCache>
                 <c:ptCount val="1"/>
                 <c:pt idx="0">
-                  <c:v>Investimento (€)</c:v>
+                  <c:v>Clic</c:v>
                 </c:pt>
               </c:strCache>
             </c:strRef>
@@ -2523,19 +2523,19 @@
                 <c:ptCount val="5"/>
                 <c:lvl>
                   <c:pt idx="0">
+                    <c:v>DG Traffico</c:v>
+                  </c:pt>
+                  <c:pt idx="1">
                     <c:v>Search Generic</c:v>
                   </c:pt>
-                  <c:pt idx="1">
-                    <c:v>DG Traffico</c:v>
+                  <c:pt idx="2">
+                    <c:v>Brand Prot.</c:v>
                   </c:pt>
-                  <c:pt idx="2">
+                  <c:pt idx="3">
                     <c:v>DG Lead Gen</c:v>
                   </c:pt>
-                  <c:pt idx="3">
+                  <c:pt idx="4">
                     <c:v>Brand Product</c:v>
-                  </c:pt>
-                  <c:pt idx="4">
-                    <c:v>Brand Prot.</c:v>
                   </c:pt>
                 </c:lvl>
               </c:multiLvlStrCache>
@@ -2548,19 +2548,19 @@
                 <c:formatCode>General</c:formatCode>
                 <c:ptCount val="5"/>
                 <c:pt idx="0">
-                  <c:v>2827</c:v>
+                  <c:v>19737</c:v>
                 </c:pt>
                 <c:pt idx="1">
-                  <c:v>1251</c:v>
+                  <c:v>17384</c:v>
                 </c:pt>
                 <c:pt idx="2">
-                  <c:v>636</c:v>
+                  <c:v>2911</c:v>
                 </c:pt>
                 <c:pt idx="3">
-                  <c:v>240</c:v>
+                  <c:v>2288</c:v>
                 </c:pt>
                 <c:pt idx="4">
-                  <c:v>239</c:v>
+                  <c:v>1911</c:v>
                 </c:pt>
               </c:numCache>
             </c:numRef>
@@ -2599,14 +2599,14 @@
       <c:catAx>
         <c:axId val="2094734554"/>
         <c:scaling>
-          <c:orientation val="minMax"/>
+          <c:orientation val="maxMin"/>
         </c:scaling>
         <c:delete val="0"/>
-        <c:axPos val="b"/>
+        <c:axPos val="l"/>
         <c:numFmt formatCode="General" sourceLinked="1"/>
         <c:majorTickMark val="out"/>
         <c:minorTickMark val="none"/>
-        <c:tickLblPos val="low"/>
+        <c:tickLblPos val="nextTo"/>
         <c:spPr>
           <a:ln w="12700" cap="flat">
             <a:solidFill>
@@ -2643,11 +2643,11 @@
           <c:orientation val="minMax"/>
         </c:scaling>
         <c:delete val="1"/>
-        <c:axPos val="l"/>
+        <c:axPos val="b"/>
         <c:numFmt formatCode="General" sourceLinked="0"/>
         <c:majorTickMark val="out"/>
         <c:minorTickMark val="none"/>
-        <c:tickLblPos val="nextTo"/>
+        <c:tickLblPos val="low"/>
         <c:spPr>
           <a:ln w="12700" cap="flat">
             <a:solidFill>
@@ -2721,7 +2721,7 @@
               <c:strCache>
                 <c:ptCount val="1"/>
                 <c:pt idx="0">
-                  <c:v>Investimento (€)</c:v>
+                  <c:v>CPC</c:v>
                 </c:pt>
               </c:strCache>
             </c:strRef>
@@ -2740,7 +2740,7 @@
               <a:lstStyle/>
               <a:p>
                 <a:pPr>
-                  <a:defRPr b="0" i="0" strike="noStrike" sz="800" u="none">
+                  <a:defRPr b="0" i="0" strike="noStrike" sz="900" u="none">
                     <a:solidFill>
                       <a:srgbClr val="191919"/>
                     </a:solidFill>
@@ -2764,22 +2764,22 @@
                 <c:ptCount val="6"/>
                 <c:lvl>
                   <c:pt idx="0">
-                    <c:v>Lead Gen Riv.</c:v>
+                    <c:v>Store Locator</c:v>
                   </c:pt>
                   <c:pt idx="1">
                     <c:v>Blog Consid.</c:v>
                   </c:pt>
                   <c:pt idx="2">
+                    <c:v>Lead Gen Riv.</c:v>
+                  </c:pt>
+                  <c:pt idx="3">
+                    <c:v>Promo PED</c:v>
+                  </c:pt>
+                  <c:pt idx="4">
                     <c:v>FEEL5 B2B</c:v>
                   </c:pt>
-                  <c:pt idx="3">
+                  <c:pt idx="5">
                     <c:v>Area Pro B2B</c:v>
-                  </c:pt>
-                  <c:pt idx="4">
-                    <c:v>Promo PED</c:v>
-                  </c:pt>
-                  <c:pt idx="5">
-                    <c:v>Store Locator</c:v>
                   </c:pt>
                 </c:lvl>
               </c:multiLvlStrCache>
@@ -2792,22 +2792,22 @@
                 <c:formatCode>General</c:formatCode>
                 <c:ptCount val="6"/>
                 <c:pt idx="0">
-                  <c:v>1108</c:v>
+                  <c:v>0.11</c:v>
                 </c:pt>
                 <c:pt idx="1">
-                  <c:v>1061</c:v>
+                  <c:v>0.15</c:v>
                 </c:pt>
                 <c:pt idx="2">
-                  <c:v>572</c:v>
+                  <c:v>0.48</c:v>
                 </c:pt>
                 <c:pt idx="3">
-                  <c:v>556</c:v>
+                  <c:v>0.68</c:v>
                 </c:pt>
                 <c:pt idx="4">
-                  <c:v>292</c:v>
+                  <c:v>0.99</c:v>
                 </c:pt>
                 <c:pt idx="5">
-                  <c:v>237</c:v>
+                  <c:v>1.13</c:v>
                 </c:pt>
               </c:numCache>
             </c:numRef>
@@ -2820,7 +2820,7 @@
             <a:lstStyle/>
             <a:p>
               <a:pPr>
-                <a:defRPr b="0" i="0" strike="noStrike" sz="800" u="none">
+                <a:defRPr b="0" i="0" strike="noStrike" sz="900" u="none">
                   <a:solidFill>
                     <a:srgbClr val="191919"/>
                   </a:solidFill>
@@ -2846,7 +2846,7 @@
       <c:catAx>
         <c:axId val="2094734554"/>
         <c:scaling>
-          <c:orientation val="maxMin"/>
+          <c:orientation val="minMax"/>
         </c:scaling>
         <c:delete val="0"/>
         <c:axPos val="l"/>
@@ -8789,14 +8789,53 @@
           </a:graphicData>
         </a:graphic>
       </p:graphicFrame>
+      <p:sp>
+        <p:nvSpPr>
+          <p:cNvPr id="8" name="Text 5"/>
+          <p:cNvSpPr txBox="1"/>
+          <p:nvPr/>
+        </p:nvSpPr>
+        <p:spPr>
+          <a:xfrm>
+            <a:off x="457200" y="4023360"/>
+            <a:ext cx="4572000" cy="228600"/>
+          </a:xfrm>
+          <a:prstGeom prst="rect">
+            <a:avLst/>
+          </a:prstGeom>
+          <a:noFill/>
+          <a:ln/>
+        </p:spPr>
+        <p:txBody>
+          <a:bodyPr wrap="square" lIns="0" tIns="0" rIns="0" bIns="0" rtlCol="0" anchor="ctr"/>
+          <a:lstStyle/>
+          <a:p>
+            <a:pPr indent="0" marL="0">
+              <a:buNone/>
+            </a:pPr>
+            <a:r>
+              <a:rPr lang="en-US" sz="900" b="1" dirty="0">
+                <a:solidFill>
+                  <a:srgbClr val="5781FF"/>
+                </a:solidFill>
+                <a:latin typeface="Figtree" pitchFamily="34" charset="0"/>
+                <a:ea typeface="Figtree" pitchFamily="34" charset="-122"/>
+                <a:cs typeface="Figtree" pitchFamily="34" charset="-120"/>
+              </a:rPr>
+              <a:t>CPC PER CAMPAGNA (€)</a:t>
+            </a:r>
+            <a:endParaRPr lang="en-US" sz="900" dirty="0"/>
+          </a:p>
+        </p:txBody>
+      </p:sp>
       <p:graphicFrame>
         <p:nvGraphicFramePr>
-          <p:cNvPr id="8" name="Chart 0" descr=""/>
+          <p:cNvPr id="9" name="Chart 0" descr=""/>
           <p:cNvGraphicFramePr/>
           <p:nvPr/>
         </p:nvGraphicFramePr>
         <p:xfrm>
-          <a:off x="457200" y="4114800"/>
+          <a:off x="457200" y="4251960"/>
           <a:ext cx="6858000" cy="1828800"/>
         </p:xfrm>
         <a:graphic xmlns:a="http://schemas.openxmlformats.org/drawingml/2006/main">
@@ -8807,18 +8846,18 @@
       </p:graphicFrame>
       <p:sp>
         <p:nvSpPr>
-          <p:cNvPr id="9" name="Shape 5"/>
+          <p:cNvPr id="10" name="Shape 6"/>
           <p:cNvSpPr/>
           <p:nvPr/>
         </p:nvSpPr>
         <p:spPr>
           <a:xfrm>
-            <a:off x="7772400" y="4114800"/>
-            <a:ext cx="3931920" cy="1828800"/>
+            <a:off x="7772400" y="4023360"/>
+            <a:ext cx="3931920" cy="2011680"/>
           </a:xfrm>
           <a:prstGeom prst="roundRect">
             <a:avLst>
-              <a:gd name="adj" fmla="val 4000"/>
+              <a:gd name="adj" fmla="val 3636"/>
             </a:avLst>
           </a:prstGeom>
           <a:solidFill>
@@ -8829,13 +8868,13 @@
       </p:sp>
       <p:sp>
         <p:nvSpPr>
-          <p:cNvPr id="10" name="Text 6"/>
+          <p:cNvPr id="11" name="Text 7"/>
           <p:cNvSpPr txBox="1"/>
           <p:nvPr/>
         </p:nvSpPr>
         <p:spPr>
           <a:xfrm>
-            <a:off x="7955280" y="4206240"/>
+            <a:off x="7955280" y="4114800"/>
             <a:ext cx="3200400" cy="274320"/>
           </a:xfrm>
           <a:prstGeom prst="rect">
@@ -8868,14 +8907,14 @@
       </p:sp>
       <p:sp>
         <p:nvSpPr>
-          <p:cNvPr id="11" name="Text 7"/>
+          <p:cNvPr id="12" name="Text 8"/>
           <p:cNvSpPr txBox="1"/>
           <p:nvPr/>
         </p:nvSpPr>
         <p:spPr>
           <a:xfrm>
-            <a:off x="7955280" y="4480560"/>
-            <a:ext cx="3566160" cy="1371600"/>
+            <a:off x="7955280" y="4434840"/>
+            <a:ext cx="3566160" cy="1463040"/>
           </a:xfrm>
           <a:prstGeom prst="rect">
             <a:avLst/>
@@ -8902,7 +8941,7 @@
                 <a:ea typeface="Figtree" pitchFamily="34" charset="-122"/>
                 <a:cs typeface="Figtree" pitchFamily="34" charset="-120"/>
               </a:rPr>
-              <a:t>Blog Consideration</a:t>
+              <a:t>CPC: spread 10x tra le campagne</a:t>
             </a:r>
             <a:endParaRPr lang="en-US" sz="1100" dirty="0"/>
           </a:p>
@@ -8922,7 +8961,7 @@
                 <a:ea typeface="Figtree" pitchFamily="34" charset="-122"/>
                 <a:cs typeface="Figtree" pitchFamily="34" charset="-120"/>
               </a:rPr>
-              <a:t>Porta il volume maggiore (7.059 clic) con CPC 0,15 €</a:t>
+              <a:t>Store Locator (0,11 €) e Blog (0,15 €) sono i piu efficienti per clic</a:t>
             </a:r>
             <a:endParaRPr lang="en-US" sz="1100" dirty="0"/>
           </a:p>
@@ -8951,7 +8990,7 @@
                 <a:ea typeface="Figtree" pitchFamily="34" charset="-122"/>
                 <a:cs typeface="Figtree" pitchFamily="34" charset="-120"/>
               </a:rPr>
-              <a:t>Store Locator B2C</a:t>
+              <a:t>Lead Gen e B2B hanno CPC piu alti</a:t>
             </a:r>
             <a:endParaRPr lang="en-US" sz="1100" dirty="0"/>
           </a:p>
@@ -8971,7 +9010,7 @@
                 <a:ea typeface="Figtree" pitchFamily="34" charset="-122"/>
                 <a:cs typeface="Figtree" pitchFamily="34" charset="-120"/>
               </a:rPr>
-              <a:t>Il CPC più efficiente in assoluto: 0,11 €</a:t>
+              <a:t>ma portano conversioni dirette (lead, registrazioni)</a:t>
             </a:r>
             <a:endParaRPr lang="en-US" sz="1100" dirty="0"/>
           </a:p>
@@ -8979,7 +9018,7 @@
       </p:sp>
       <p:sp>
         <p:nvSpPr>
-          <p:cNvPr id="12" name="Text 8"/>
+          <p:cNvPr id="13" name="Text 9"/>
           <p:cNvSpPr txBox="1"/>
           <p:nvPr/>
         </p:nvSpPr>
@@ -26292,7 +26331,7 @@
                 <a:ea typeface="Figtree" pitchFamily="34" charset="-122"/>
                 <a:cs typeface="Figtree" pitchFamily="34" charset="-120"/>
               </a:rPr>
-              <a:t>Google consolida la crescita, Meta mantiene i volumi, Pinterest cresce del 22%</a:t>
+              <a:t>Google quadruplica i clic (+465%), Meta mantiene i volumi con CPC stabile</a:t>
             </a:r>
             <a:endParaRPr lang="en-US" sz="2000" dirty="0"/>
           </a:p>
@@ -26307,11 +26346,11 @@
         <p:spPr>
           <a:xfrm>
             <a:off x="457200" y="1554480"/>
-            <a:ext cx="3566160" cy="502920"/>
+            <a:ext cx="5394960" cy="548640"/>
           </a:xfrm>
           <a:prstGeom prst="roundRect">
             <a:avLst>
-              <a:gd name="adj" fmla="val 14545"/>
+              <a:gd name="adj" fmla="val 13333"/>
             </a:avLst>
           </a:prstGeom>
           <a:solidFill>
@@ -26328,8 +26367,8 @@
         </p:nvSpPr>
         <p:spPr>
           <a:xfrm>
-            <a:off x="594360" y="1600200"/>
-            <a:ext cx="3200400" cy="365760"/>
+            <a:off x="640080" y="1600200"/>
+            <a:ext cx="4572000" cy="457200"/>
           </a:xfrm>
           <a:prstGeom prst="rect">
             <a:avLst/>
@@ -26345,7 +26384,7 @@
               <a:buNone/>
             </a:pPr>
             <a:r>
-              <a:rPr lang="en-US" sz="1400" b="1" dirty="0">
+              <a:rPr lang="en-US" sz="1600" b="1" dirty="0">
                 <a:solidFill>
                   <a:srgbClr val="FFFFFF"/>
                 </a:solidFill>
@@ -26355,7 +26394,7 @@
               </a:rPr>
               <a:t>GOOGLE ADS</a:t>
             </a:r>
-            <a:endParaRPr lang="en-US" sz="1400" dirty="0"/>
+            <a:endParaRPr lang="en-US" sz="1600" dirty="0"/>
           </a:p>
         </p:txBody>
       </p:sp>
@@ -26367,12 +26406,12 @@
         </p:nvSpPr>
         <p:spPr>
           <a:xfrm>
-            <a:off x="457200" y="2103120"/>
-            <a:ext cx="3566160" cy="3474720"/>
+            <a:off x="457200" y="2148840"/>
+            <a:ext cx="5394960" cy="3429000"/>
           </a:xfrm>
           <a:prstGeom prst="roundRect">
             <a:avLst>
-              <a:gd name="adj" fmla="val 2105"/>
+              <a:gd name="adj" fmla="val 2133"/>
             </a:avLst>
           </a:prstGeom>
           <a:solidFill>
@@ -26389,7 +26428,7 @@
         </p:nvSpPr>
         <p:spPr>
           <a:xfrm>
-            <a:off x="640080" y="2286000"/>
+            <a:off x="685800" y="2331720"/>
             <a:ext cx="2743200" cy="182880"/>
           </a:xfrm>
           <a:prstGeom prst="rect">
@@ -26428,8 +26467,8 @@
         </p:nvSpPr>
         <p:spPr>
           <a:xfrm>
-            <a:off x="640080" y="2468880"/>
-            <a:ext cx="1828800" cy="365760"/>
+            <a:off x="685800" y="2514600"/>
+            <a:ext cx="2286000" cy="365760"/>
           </a:xfrm>
           <a:prstGeom prst="rect">
             <a:avLst/>
@@ -26445,7 +26484,7 @@
               <a:buNone/>
             </a:pPr>
             <a:r>
-              <a:rPr lang="en-US" sz="2000" b="1" dirty="0">
+              <a:rPr lang="en-US" sz="2200" b="1" dirty="0">
                 <a:solidFill>
                   <a:srgbClr val="191919"/>
                 </a:solidFill>
@@ -26455,7 +26494,7 @@
               </a:rPr>
               <a:t>44.231</a:t>
             </a:r>
-            <a:endParaRPr lang="en-US" sz="2000" dirty="0"/>
+            <a:endParaRPr lang="en-US" sz="2200" dirty="0"/>
           </a:p>
         </p:txBody>
       </p:sp>
@@ -26467,8 +26506,8 @@
         </p:nvSpPr>
         <p:spPr>
           <a:xfrm>
-            <a:off x="2560320" y="2468880"/>
-            <a:ext cx="1188720" cy="365760"/>
+            <a:off x="3383280" y="2514600"/>
+            <a:ext cx="2011680" cy="365760"/>
           </a:xfrm>
           <a:prstGeom prst="rect">
             <a:avLst/>
@@ -26484,7 +26523,7 @@
               <a:buNone/>
             </a:pPr>
             <a:r>
-              <a:rPr lang="en-US" sz="1300" b="1" dirty="0">
+              <a:rPr lang="en-US" sz="1400" b="1" dirty="0">
                 <a:solidFill>
                   <a:srgbClr val="118541"/>
                 </a:solidFill>
@@ -26494,7 +26533,7 @@
               </a:rPr>
               <a:t>+465%</a:t>
             </a:r>
-            <a:endParaRPr lang="en-US" sz="1300" dirty="0"/>
+            <a:endParaRPr lang="en-US" sz="1400" dirty="0"/>
           </a:p>
         </p:txBody>
       </p:sp>
@@ -26506,7 +26545,7 @@
         </p:nvSpPr>
         <p:spPr>
           <a:xfrm>
-            <a:off x="640080" y="3108960"/>
+            <a:off x="685800" y="2990088"/>
             <a:ext cx="2743200" cy="182880"/>
           </a:xfrm>
           <a:prstGeom prst="rect">
@@ -26545,8 +26584,8 @@
         </p:nvSpPr>
         <p:spPr>
           <a:xfrm>
-            <a:off x="640080" y="3291840"/>
-            <a:ext cx="1828800" cy="365760"/>
+            <a:off x="685800" y="3172968"/>
+            <a:ext cx="2286000" cy="365760"/>
           </a:xfrm>
           <a:prstGeom prst="rect">
             <a:avLst/>
@@ -26562,7 +26601,7 @@
               <a:buNone/>
             </a:pPr>
             <a:r>
-              <a:rPr lang="en-US" sz="2000" b="1" dirty="0">
+              <a:rPr lang="en-US" sz="2200" b="1" dirty="0">
                 <a:solidFill>
                   <a:srgbClr val="191919"/>
                 </a:solidFill>
@@ -26572,7 +26611,7 @@
               </a:rPr>
               <a:t>465.037</a:t>
             </a:r>
-            <a:endParaRPr lang="en-US" sz="2000" dirty="0"/>
+            <a:endParaRPr lang="en-US" sz="2200" dirty="0"/>
           </a:p>
         </p:txBody>
       </p:sp>
@@ -26584,8 +26623,8 @@
         </p:nvSpPr>
         <p:spPr>
           <a:xfrm>
-            <a:off x="2560320" y="3291840"/>
-            <a:ext cx="1188720" cy="365760"/>
+            <a:off x="3383280" y="3172968"/>
+            <a:ext cx="2011680" cy="365760"/>
           </a:xfrm>
           <a:prstGeom prst="rect">
             <a:avLst/>
@@ -26601,7 +26640,7 @@
               <a:buNone/>
             </a:pPr>
             <a:r>
-              <a:rPr lang="en-US" sz="1300" b="1" dirty="0">
+              <a:rPr lang="en-US" sz="1400" b="1" dirty="0">
                 <a:solidFill>
                   <a:srgbClr val="118541"/>
                 </a:solidFill>
@@ -26611,7 +26650,7 @@
               </a:rPr>
               <a:t>+552%</a:t>
             </a:r>
-            <a:endParaRPr lang="en-US" sz="1300" dirty="0"/>
+            <a:endParaRPr lang="en-US" sz="1400" dirty="0"/>
           </a:p>
         </p:txBody>
       </p:sp>
@@ -26623,7 +26662,7 @@
         </p:nvSpPr>
         <p:spPr>
           <a:xfrm>
-            <a:off x="640080" y="3931920"/>
+            <a:off x="685800" y="3648456"/>
             <a:ext cx="2743200" cy="182880"/>
           </a:xfrm>
           <a:prstGeom prst="rect">
@@ -26662,8 +26701,8 @@
         </p:nvSpPr>
         <p:spPr>
           <a:xfrm>
-            <a:off x="640080" y="4114800"/>
-            <a:ext cx="1828800" cy="365760"/>
+            <a:off x="685800" y="3831336"/>
+            <a:ext cx="2286000" cy="365760"/>
           </a:xfrm>
           <a:prstGeom prst="rect">
             <a:avLst/>
@@ -26679,7 +26718,7 @@
               <a:buNone/>
             </a:pPr>
             <a:r>
-              <a:rPr lang="en-US" sz="2000" b="1" dirty="0">
+              <a:rPr lang="en-US" sz="2200" b="1" dirty="0">
                 <a:solidFill>
                   <a:srgbClr val="191919"/>
                 </a:solidFill>
@@ -26689,7 +26728,7 @@
               </a:rPr>
               <a:t>5.193 €</a:t>
             </a:r>
-            <a:endParaRPr lang="en-US" sz="2000" dirty="0"/>
+            <a:endParaRPr lang="en-US" sz="2200" dirty="0"/>
           </a:p>
         </p:txBody>
       </p:sp>
@@ -26701,8 +26740,8 @@
         </p:nvSpPr>
         <p:spPr>
           <a:xfrm>
-            <a:off x="2560320" y="4114800"/>
-            <a:ext cx="1188720" cy="365760"/>
+            <a:off x="3383280" y="3831336"/>
+            <a:ext cx="2011680" cy="365760"/>
           </a:xfrm>
           <a:prstGeom prst="rect">
             <a:avLst/>
@@ -26718,7 +26757,7 @@
               <a:buNone/>
             </a:pPr>
             <a:r>
-              <a:rPr lang="en-US" sz="1300" b="1" dirty="0">
+              <a:rPr lang="en-US" sz="1400" b="1" dirty="0">
                 <a:solidFill>
                   <a:srgbClr val="118541"/>
                 </a:solidFill>
@@ -26728,7 +26767,7 @@
               </a:rPr>
               <a:t>+102%</a:t>
             </a:r>
-            <a:endParaRPr lang="en-US" sz="1300" dirty="0"/>
+            <a:endParaRPr lang="en-US" sz="1400" dirty="0"/>
           </a:p>
         </p:txBody>
       </p:sp>
@@ -26740,7 +26779,7 @@
         </p:nvSpPr>
         <p:spPr>
           <a:xfrm>
-            <a:off x="640080" y="4754880"/>
+            <a:off x="685800" y="4306824"/>
             <a:ext cx="2743200" cy="182880"/>
           </a:xfrm>
           <a:prstGeom prst="rect">
@@ -26779,8 +26818,8 @@
         </p:nvSpPr>
         <p:spPr>
           <a:xfrm>
-            <a:off x="640080" y="4937760"/>
-            <a:ext cx="1828800" cy="365760"/>
+            <a:off x="685800" y="4489704"/>
+            <a:ext cx="2286000" cy="365760"/>
           </a:xfrm>
           <a:prstGeom prst="rect">
             <a:avLst/>
@@ -26796,7 +26835,7 @@
               <a:buNone/>
             </a:pPr>
             <a:r>
-              <a:rPr lang="en-US" sz="2000" b="1" dirty="0">
+              <a:rPr lang="en-US" sz="2200" b="1" dirty="0">
                 <a:solidFill>
                   <a:srgbClr val="191919"/>
                 </a:solidFill>
@@ -26806,7 +26845,7 @@
               </a:rPr>
               <a:t>0,12 €</a:t>
             </a:r>
-            <a:endParaRPr lang="en-US" sz="2000" dirty="0"/>
+            <a:endParaRPr lang="en-US" sz="2200" dirty="0"/>
           </a:p>
         </p:txBody>
       </p:sp>
@@ -26818,8 +26857,8 @@
         </p:nvSpPr>
         <p:spPr>
           <a:xfrm>
-            <a:off x="2560320" y="4937760"/>
-            <a:ext cx="1188720" cy="365760"/>
+            <a:off x="3383280" y="4489704"/>
+            <a:ext cx="2011680" cy="365760"/>
           </a:xfrm>
           <a:prstGeom prst="rect">
             <a:avLst/>
@@ -26835,7 +26874,7 @@
               <a:buNone/>
             </a:pPr>
             <a:r>
-              <a:rPr lang="en-US" sz="1300" b="1" dirty="0">
+              <a:rPr lang="en-US" sz="1400" b="1" dirty="0">
                 <a:solidFill>
                   <a:srgbClr val="118541"/>
                 </a:solidFill>
@@ -26845,24 +26884,102 @@
               </a:rPr>
               <a:t>-64%</a:t>
             </a:r>
-            <a:endParaRPr lang="en-US" sz="1300" dirty="0"/>
-          </a:p>
-        </p:txBody>
-      </p:sp>
-      <p:sp>
-        <p:nvSpPr>
-          <p:cNvPr id="22" name="Shape 20"/>
+            <a:endParaRPr lang="en-US" sz="1400" dirty="0"/>
+          </a:p>
+        </p:txBody>
+      </p:sp>
+      <p:sp>
+        <p:nvSpPr>
+          <p:cNvPr id="22" name="Text 20"/>
+          <p:cNvSpPr txBox="1"/>
+          <p:nvPr/>
+        </p:nvSpPr>
+        <p:spPr>
+          <a:xfrm>
+            <a:off x="685800" y="4965192"/>
+            <a:ext cx="2743200" cy="182880"/>
+          </a:xfrm>
+          <a:prstGeom prst="rect">
+            <a:avLst/>
+          </a:prstGeom>
+          <a:noFill/>
+          <a:ln/>
+        </p:spPr>
+        <p:txBody>
+          <a:bodyPr wrap="square" lIns="0" tIns="0" rIns="0" bIns="0" rtlCol="0" anchor="ctr"/>
+          <a:lstStyle/>
+          <a:p>
+            <a:pPr indent="0" marL="0">
+              <a:buNone/>
+            </a:pPr>
+            <a:r>
+              <a:rPr lang="en-US" sz="800" b="1" dirty="0">
+                <a:solidFill>
+                  <a:srgbClr val="595959"/>
+                </a:solidFill>
+                <a:latin typeface="Figtree" pitchFamily="34" charset="0"/>
+                <a:ea typeface="Figtree" pitchFamily="34" charset="-122"/>
+                <a:cs typeface="Figtree" pitchFamily="34" charset="-120"/>
+              </a:rPr>
+              <a:t>QUOTA TRAFFICO PAID</a:t>
+            </a:r>
+            <a:endParaRPr lang="en-US" sz="800" dirty="0"/>
+          </a:p>
+        </p:txBody>
+      </p:sp>
+      <p:sp>
+        <p:nvSpPr>
+          <p:cNvPr id="23" name="Text 21"/>
+          <p:cNvSpPr txBox="1"/>
+          <p:nvPr/>
+        </p:nvSpPr>
+        <p:spPr>
+          <a:xfrm>
+            <a:off x="685800" y="5148072"/>
+            <a:ext cx="2286000" cy="365760"/>
+          </a:xfrm>
+          <a:prstGeom prst="rect">
+            <a:avLst/>
+          </a:prstGeom>
+          <a:noFill/>
+          <a:ln/>
+        </p:spPr>
+        <p:txBody>
+          <a:bodyPr wrap="square" lIns="0" tIns="0" rIns="0" bIns="0" rtlCol="0" anchor="ctr"/>
+          <a:lstStyle/>
+          <a:p>
+            <a:pPr indent="0" marL="0">
+              <a:buNone/>
+            </a:pPr>
+            <a:r>
+              <a:rPr lang="en-US" sz="2200" b="1" dirty="0">
+                <a:solidFill>
+                  <a:srgbClr val="191919"/>
+                </a:solidFill>
+                <a:latin typeface="Figtree" pitchFamily="34" charset="0"/>
+                <a:ea typeface="Figtree" pitchFamily="34" charset="-122"/>
+                <a:cs typeface="Figtree" pitchFamily="34" charset="-120"/>
+              </a:rPr>
+              <a:t>57,6%</a:t>
+            </a:r>
+            <a:endParaRPr lang="en-US" sz="2200" dirty="0"/>
+          </a:p>
+        </p:txBody>
+      </p:sp>
+      <p:sp>
+        <p:nvSpPr>
+          <p:cNvPr id="24" name="Shape 22"/>
           <p:cNvSpPr/>
           <p:nvPr/>
         </p:nvSpPr>
         <p:spPr>
           <a:xfrm>
-            <a:off x="4297680" y="1554480"/>
-            <a:ext cx="3566160" cy="502920"/>
+            <a:off x="6217920" y="1554480"/>
+            <a:ext cx="5394960" cy="548640"/>
           </a:xfrm>
           <a:prstGeom prst="roundRect">
             <a:avLst>
-              <a:gd name="adj" fmla="val 14545"/>
+              <a:gd name="adj" fmla="val 13333"/>
             </a:avLst>
           </a:prstGeom>
           <a:solidFill>
@@ -26873,14 +26990,14 @@
       </p:sp>
       <p:sp>
         <p:nvSpPr>
-          <p:cNvPr id="23" name="Text 21"/>
+          <p:cNvPr id="25" name="Text 23"/>
           <p:cNvSpPr txBox="1"/>
           <p:nvPr/>
         </p:nvSpPr>
         <p:spPr>
           <a:xfrm>
-            <a:off x="4434840" y="1600200"/>
-            <a:ext cx="3200400" cy="365760"/>
+            <a:off x="6400800" y="1600200"/>
+            <a:ext cx="4572000" cy="457200"/>
           </a:xfrm>
           <a:prstGeom prst="rect">
             <a:avLst/>
@@ -26896,7 +27013,7 @@
               <a:buNone/>
             </a:pPr>
             <a:r>
-              <a:rPr lang="en-US" sz="1400" b="1" dirty="0">
+              <a:rPr lang="en-US" sz="1600" b="1" dirty="0">
                 <a:solidFill>
                   <a:srgbClr val="FFFFFF"/>
                 </a:solidFill>
@@ -26906,24 +27023,24 @@
               </a:rPr>
               <a:t>META ADS</a:t>
             </a:r>
-            <a:endParaRPr lang="en-US" sz="1400" dirty="0"/>
-          </a:p>
-        </p:txBody>
-      </p:sp>
-      <p:sp>
-        <p:nvSpPr>
-          <p:cNvPr id="24" name="Shape 22"/>
+            <a:endParaRPr lang="en-US" sz="1600" dirty="0"/>
+          </a:p>
+        </p:txBody>
+      </p:sp>
+      <p:sp>
+        <p:nvSpPr>
+          <p:cNvPr id="26" name="Shape 24"/>
           <p:cNvSpPr/>
           <p:nvPr/>
         </p:nvSpPr>
         <p:spPr>
           <a:xfrm>
-            <a:off x="4297680" y="2103120"/>
-            <a:ext cx="3566160" cy="3474720"/>
+            <a:off x="6217920" y="2148840"/>
+            <a:ext cx="5394960" cy="3429000"/>
           </a:xfrm>
           <a:prstGeom prst="roundRect">
             <a:avLst>
-              <a:gd name="adj" fmla="val 2105"/>
+              <a:gd name="adj" fmla="val 2133"/>
             </a:avLst>
           </a:prstGeom>
           <a:solidFill>
@@ -26934,13 +27051,13 @@
       </p:sp>
       <p:sp>
         <p:nvSpPr>
-          <p:cNvPr id="25" name="Text 23"/>
+          <p:cNvPr id="27" name="Text 25"/>
           <p:cNvSpPr txBox="1"/>
           <p:nvPr/>
         </p:nvSpPr>
         <p:spPr>
           <a:xfrm>
-            <a:off x="4480560" y="2286000"/>
+            <a:off x="6446520" y="2331720"/>
             <a:ext cx="2743200" cy="182880"/>
           </a:xfrm>
           <a:prstGeom prst="rect">
@@ -26973,14 +27090,14 @@
       </p:sp>
       <p:sp>
         <p:nvSpPr>
-          <p:cNvPr id="26" name="Text 24"/>
+          <p:cNvPr id="28" name="Text 26"/>
           <p:cNvSpPr txBox="1"/>
           <p:nvPr/>
         </p:nvSpPr>
         <p:spPr>
           <a:xfrm>
-            <a:off x="4480560" y="2468880"/>
-            <a:ext cx="1828800" cy="365760"/>
+            <a:off x="6446520" y="2514600"/>
+            <a:ext cx="2286000" cy="365760"/>
           </a:xfrm>
           <a:prstGeom prst="rect">
             <a:avLst/>
@@ -26996,7 +27113,7 @@
               <a:buNone/>
             </a:pPr>
             <a:r>
-              <a:rPr lang="en-US" sz="2000" b="1" dirty="0">
+              <a:rPr lang="en-US" sz="2200" b="1" dirty="0">
                 <a:solidFill>
                   <a:srgbClr val="191919"/>
                 </a:solidFill>
@@ -27006,20 +27123,20 @@
               </a:rPr>
               <a:t>12.970</a:t>
             </a:r>
-            <a:endParaRPr lang="en-US" sz="2000" dirty="0"/>
-          </a:p>
-        </p:txBody>
-      </p:sp>
-      <p:sp>
-        <p:nvSpPr>
-          <p:cNvPr id="27" name="Text 25"/>
+            <a:endParaRPr lang="en-US" sz="2200" dirty="0"/>
+          </a:p>
+        </p:txBody>
+      </p:sp>
+      <p:sp>
+        <p:nvSpPr>
+          <p:cNvPr id="29" name="Text 27"/>
           <p:cNvSpPr txBox="1"/>
           <p:nvPr/>
         </p:nvSpPr>
         <p:spPr>
           <a:xfrm>
-            <a:off x="6400800" y="2468880"/>
-            <a:ext cx="1188720" cy="365760"/>
+            <a:off x="9144000" y="2514600"/>
+            <a:ext cx="2011680" cy="365760"/>
           </a:xfrm>
           <a:prstGeom prst="rect">
             <a:avLst/>
@@ -27035,7 +27152,7 @@
               <a:buNone/>
             </a:pPr>
             <a:r>
-              <a:rPr lang="en-US" sz="1300" b="1" dirty="0">
+              <a:rPr lang="en-US" sz="1400" b="1" dirty="0">
                 <a:solidFill>
                   <a:srgbClr val="E52217"/>
                 </a:solidFill>
@@ -27045,19 +27162,19 @@
               </a:rPr>
               <a:t>-6,7%</a:t>
             </a:r>
-            <a:endParaRPr lang="en-US" sz="1300" dirty="0"/>
-          </a:p>
-        </p:txBody>
-      </p:sp>
-      <p:sp>
-        <p:nvSpPr>
-          <p:cNvPr id="28" name="Text 26"/>
+            <a:endParaRPr lang="en-US" sz="1400" dirty="0"/>
+          </a:p>
+        </p:txBody>
+      </p:sp>
+      <p:sp>
+        <p:nvSpPr>
+          <p:cNvPr id="30" name="Text 28"/>
           <p:cNvSpPr txBox="1"/>
           <p:nvPr/>
         </p:nvSpPr>
         <p:spPr>
           <a:xfrm>
-            <a:off x="4480560" y="3108960"/>
+            <a:off x="6446520" y="2990088"/>
             <a:ext cx="2743200" cy="182880"/>
           </a:xfrm>
           <a:prstGeom prst="rect">
@@ -27090,14 +27207,14 @@
       </p:sp>
       <p:sp>
         <p:nvSpPr>
-          <p:cNvPr id="29" name="Text 27"/>
+          <p:cNvPr id="31" name="Text 29"/>
           <p:cNvSpPr txBox="1"/>
           <p:nvPr/>
         </p:nvSpPr>
         <p:spPr>
           <a:xfrm>
-            <a:off x="4480560" y="3291840"/>
-            <a:ext cx="1828800" cy="365760"/>
+            <a:off x="6446520" y="3172968"/>
+            <a:ext cx="2286000" cy="365760"/>
           </a:xfrm>
           <a:prstGeom prst="rect">
             <a:avLst/>
@@ -27113,7 +27230,7 @@
               <a:buNone/>
             </a:pPr>
             <a:r>
-              <a:rPr lang="en-US" sz="2000" b="1" dirty="0">
+              <a:rPr lang="en-US" sz="2200" b="1" dirty="0">
                 <a:solidFill>
                   <a:srgbClr val="191919"/>
                 </a:solidFill>
@@ -27123,20 +27240,20 @@
               </a:rPr>
               <a:t>663.579</a:t>
             </a:r>
-            <a:endParaRPr lang="en-US" sz="2000" dirty="0"/>
-          </a:p>
-        </p:txBody>
-      </p:sp>
-      <p:sp>
-        <p:nvSpPr>
-          <p:cNvPr id="30" name="Text 28"/>
+            <a:endParaRPr lang="en-US" sz="2200" dirty="0"/>
+          </a:p>
+        </p:txBody>
+      </p:sp>
+      <p:sp>
+        <p:nvSpPr>
+          <p:cNvPr id="32" name="Text 30"/>
           <p:cNvSpPr txBox="1"/>
           <p:nvPr/>
         </p:nvSpPr>
         <p:spPr>
           <a:xfrm>
-            <a:off x="6400800" y="3291840"/>
-            <a:ext cx="1188720" cy="365760"/>
+            <a:off x="9144000" y="3172968"/>
+            <a:ext cx="2011680" cy="365760"/>
           </a:xfrm>
           <a:prstGeom prst="rect">
             <a:avLst/>
@@ -27152,7 +27269,7 @@
               <a:buNone/>
             </a:pPr>
             <a:r>
-              <a:rPr lang="en-US" sz="1300" b="1" dirty="0">
+              <a:rPr lang="en-US" sz="1400" b="1" dirty="0">
                 <a:solidFill>
                   <a:srgbClr val="E52217"/>
                 </a:solidFill>
@@ -27162,19 +27279,19 @@
               </a:rPr>
               <a:t>-8,0%</a:t>
             </a:r>
-            <a:endParaRPr lang="en-US" sz="1300" dirty="0"/>
-          </a:p>
-        </p:txBody>
-      </p:sp>
-      <p:sp>
-        <p:nvSpPr>
-          <p:cNvPr id="31" name="Text 29"/>
+            <a:endParaRPr lang="en-US" sz="1400" dirty="0"/>
+          </a:p>
+        </p:txBody>
+      </p:sp>
+      <p:sp>
+        <p:nvSpPr>
+          <p:cNvPr id="33" name="Text 31"/>
           <p:cNvSpPr txBox="1"/>
           <p:nvPr/>
         </p:nvSpPr>
         <p:spPr>
           <a:xfrm>
-            <a:off x="4480560" y="3931920"/>
+            <a:off x="6446520" y="3648456"/>
             <a:ext cx="2743200" cy="182880"/>
           </a:xfrm>
           <a:prstGeom prst="rect">
@@ -27207,14 +27324,14 @@
       </p:sp>
       <p:sp>
         <p:nvSpPr>
-          <p:cNvPr id="32" name="Text 30"/>
+          <p:cNvPr id="34" name="Text 32"/>
           <p:cNvSpPr txBox="1"/>
           <p:nvPr/>
         </p:nvSpPr>
         <p:spPr>
           <a:xfrm>
-            <a:off x="4480560" y="4114800"/>
-            <a:ext cx="1828800" cy="365760"/>
+            <a:off x="6446520" y="3831336"/>
+            <a:ext cx="2286000" cy="365760"/>
           </a:xfrm>
           <a:prstGeom prst="rect">
             <a:avLst/>
@@ -27230,7 +27347,7 @@
               <a:buNone/>
             </a:pPr>
             <a:r>
-              <a:rPr lang="en-US" sz="2000" b="1" dirty="0">
+              <a:rPr lang="en-US" sz="2200" b="1" dirty="0">
                 <a:solidFill>
                   <a:srgbClr val="191919"/>
                 </a:solidFill>
@@ -27240,20 +27357,20 @@
               </a:rPr>
               <a:t>3.826 €</a:t>
             </a:r>
-            <a:endParaRPr lang="en-US" sz="2000" dirty="0"/>
-          </a:p>
-        </p:txBody>
-      </p:sp>
-      <p:sp>
-        <p:nvSpPr>
-          <p:cNvPr id="33" name="Text 31"/>
+            <a:endParaRPr lang="en-US" sz="2200" dirty="0"/>
+          </a:p>
+        </p:txBody>
+      </p:sp>
+      <p:sp>
+        <p:nvSpPr>
+          <p:cNvPr id="35" name="Text 33"/>
           <p:cNvSpPr txBox="1"/>
           <p:nvPr/>
         </p:nvSpPr>
         <p:spPr>
           <a:xfrm>
-            <a:off x="6400800" y="4114800"/>
-            <a:ext cx="1188720" cy="365760"/>
+            <a:off x="9144000" y="3831336"/>
+            <a:ext cx="2011680" cy="365760"/>
           </a:xfrm>
           <a:prstGeom prst="rect">
             <a:avLst/>
@@ -27269,7 +27386,7 @@
               <a:buNone/>
             </a:pPr>
             <a:r>
-              <a:rPr lang="en-US" sz="1300" b="1" dirty="0">
+              <a:rPr lang="en-US" sz="1400" b="1" dirty="0">
                 <a:solidFill>
                   <a:srgbClr val="118541"/>
                 </a:solidFill>
@@ -27279,19 +27396,19 @@
               </a:rPr>
               <a:t>+10,6%</a:t>
             </a:r>
-            <a:endParaRPr lang="en-US" sz="1300" dirty="0"/>
-          </a:p>
-        </p:txBody>
-      </p:sp>
-      <p:sp>
-        <p:nvSpPr>
-          <p:cNvPr id="34" name="Text 32"/>
+            <a:endParaRPr lang="en-US" sz="1400" dirty="0"/>
+          </a:p>
+        </p:txBody>
+      </p:sp>
+      <p:sp>
+        <p:nvSpPr>
+          <p:cNvPr id="36" name="Text 34"/>
           <p:cNvSpPr txBox="1"/>
           <p:nvPr/>
         </p:nvSpPr>
         <p:spPr>
           <a:xfrm>
-            <a:off x="4480560" y="4754880"/>
+            <a:off x="6446520" y="4306824"/>
             <a:ext cx="2743200" cy="182880"/>
           </a:xfrm>
           <a:prstGeom prst="rect">
@@ -27324,14 +27441,14 @@
       </p:sp>
       <p:sp>
         <p:nvSpPr>
-          <p:cNvPr id="35" name="Text 33"/>
+          <p:cNvPr id="37" name="Text 35"/>
           <p:cNvSpPr txBox="1"/>
           <p:nvPr/>
         </p:nvSpPr>
         <p:spPr>
           <a:xfrm>
-            <a:off x="4480560" y="4937760"/>
-            <a:ext cx="1828800" cy="365760"/>
+            <a:off x="6446520" y="4489704"/>
+            <a:ext cx="2286000" cy="365760"/>
           </a:xfrm>
           <a:prstGeom prst="rect">
             <a:avLst/>
@@ -27347,7 +27464,7 @@
               <a:buNone/>
             </a:pPr>
             <a:r>
-              <a:rPr lang="en-US" sz="2000" b="1" dirty="0">
+              <a:rPr lang="en-US" sz="2200" b="1" dirty="0">
                 <a:solidFill>
                   <a:srgbClr val="191919"/>
                 </a:solidFill>
@@ -27357,20 +27474,20 @@
               </a:rPr>
               <a:t>0,30 €</a:t>
             </a:r>
-            <a:endParaRPr lang="en-US" sz="2000" dirty="0"/>
-          </a:p>
-        </p:txBody>
-      </p:sp>
-      <p:sp>
-        <p:nvSpPr>
-          <p:cNvPr id="36" name="Text 34"/>
+            <a:endParaRPr lang="en-US" sz="2200" dirty="0"/>
+          </a:p>
+        </p:txBody>
+      </p:sp>
+      <p:sp>
+        <p:nvSpPr>
+          <p:cNvPr id="38" name="Text 36"/>
           <p:cNvSpPr txBox="1"/>
           <p:nvPr/>
         </p:nvSpPr>
         <p:spPr>
           <a:xfrm>
-            <a:off x="6400800" y="4937760"/>
-            <a:ext cx="1188720" cy="365760"/>
+            <a:off x="9144000" y="4489704"/>
+            <a:ext cx="2011680" cy="365760"/>
           </a:xfrm>
           <a:prstGeom prst="rect">
             <a:avLst/>
@@ -27386,7 +27503,7 @@
               <a:buNone/>
             </a:pPr>
             <a:r>
-              <a:rPr lang="en-US" sz="1300" b="1" dirty="0">
+              <a:rPr lang="en-US" sz="1400" b="1" dirty="0">
                 <a:solidFill>
                   <a:srgbClr val="E52217"/>
                 </a:solidFill>
@@ -27396,42 +27513,20 @@
               </a:rPr>
               <a:t>+18,5%</a:t>
             </a:r>
-            <a:endParaRPr lang="en-US" sz="1300" dirty="0"/>
-          </a:p>
-        </p:txBody>
-      </p:sp>
-      <p:sp>
-        <p:nvSpPr>
-          <p:cNvPr id="37" name="Shape 35"/>
-          <p:cNvSpPr/>
-          <p:nvPr/>
-        </p:nvSpPr>
-        <p:spPr>
-          <a:xfrm>
-            <a:off x="8138160" y="1554480"/>
-            <a:ext cx="3566160" cy="502920"/>
-          </a:xfrm>
-          <a:prstGeom prst="roundRect">
-            <a:avLst>
-              <a:gd name="adj" fmla="val 14545"/>
-            </a:avLst>
-          </a:prstGeom>
-          <a:solidFill>
-            <a:srgbClr val="CE2A59"/>
-          </a:solidFill>
-          <a:ln/>
-        </p:spPr>
-      </p:sp>
-      <p:sp>
-        <p:nvSpPr>
-          <p:cNvPr id="38" name="Text 36"/>
+            <a:endParaRPr lang="en-US" sz="1400" dirty="0"/>
+          </a:p>
+        </p:txBody>
+      </p:sp>
+      <p:sp>
+        <p:nvSpPr>
+          <p:cNvPr id="39" name="Text 37"/>
           <p:cNvSpPr txBox="1"/>
           <p:nvPr/>
         </p:nvSpPr>
         <p:spPr>
           <a:xfrm>
-            <a:off x="8275320" y="1600200"/>
-            <a:ext cx="3200400" cy="365760"/>
+            <a:off x="6446520" y="4965192"/>
+            <a:ext cx="2743200" cy="182880"/>
           </a:xfrm>
           <a:prstGeom prst="rect">
             <a:avLst/>
@@ -27447,41 +27542,19 @@
               <a:buNone/>
             </a:pPr>
             <a:r>
-              <a:rPr lang="en-US" sz="1400" b="1" dirty="0">
-                <a:solidFill>
-                  <a:srgbClr val="FFFFFF"/>
+              <a:rPr lang="en-US" sz="800" b="1" dirty="0">
+                <a:solidFill>
+                  <a:srgbClr val="595959"/>
                 </a:solidFill>
                 <a:latin typeface="Figtree" pitchFamily="34" charset="0"/>
                 <a:ea typeface="Figtree" pitchFamily="34" charset="-122"/>
                 <a:cs typeface="Figtree" pitchFamily="34" charset="-120"/>
               </a:rPr>
-              <a:t>PINTEREST</a:t>
-            </a:r>
-            <a:endParaRPr lang="en-US" sz="1400" dirty="0"/>
-          </a:p>
-        </p:txBody>
-      </p:sp>
-      <p:sp>
-        <p:nvSpPr>
-          <p:cNvPr id="39" name="Shape 37"/>
-          <p:cNvSpPr/>
-          <p:nvPr/>
-        </p:nvSpPr>
-        <p:spPr>
-          <a:xfrm>
-            <a:off x="8138160" y="2103120"/>
-            <a:ext cx="3566160" cy="3474720"/>
-          </a:xfrm>
-          <a:prstGeom prst="roundRect">
-            <a:avLst>
-              <a:gd name="adj" fmla="val 2105"/>
-            </a:avLst>
-          </a:prstGeom>
-          <a:solidFill>
-            <a:srgbClr val="F4F5F6"/>
-          </a:solidFill>
-          <a:ln/>
-        </p:spPr>
+              <a:t>QUOTA TRAFFICO PAID</a:t>
+            </a:r>
+            <a:endParaRPr lang="en-US" sz="800" dirty="0"/>
+          </a:p>
+        </p:txBody>
       </p:sp>
       <p:sp>
         <p:nvSpPr>
@@ -27491,8 +27564,8 @@
         </p:nvSpPr>
         <p:spPr>
           <a:xfrm>
-            <a:off x="8321040" y="2286000"/>
-            <a:ext cx="2743200" cy="182880"/>
+            <a:off x="6446520" y="5148072"/>
+            <a:ext cx="2286000" cy="365760"/>
           </a:xfrm>
           <a:prstGeom prst="rect">
             <a:avLst/>
@@ -27508,17 +27581,17 @@
               <a:buNone/>
             </a:pPr>
             <a:r>
-              <a:rPr lang="en-US" sz="800" b="1" dirty="0">
-                <a:solidFill>
-                  <a:srgbClr val="595959"/>
+              <a:rPr lang="en-US" sz="2200" b="1" dirty="0">
+                <a:solidFill>
+                  <a:srgbClr val="191919"/>
                 </a:solidFill>
                 <a:latin typeface="Figtree" pitchFamily="34" charset="0"/>
                 <a:ea typeface="Figtree" pitchFamily="34" charset="-122"/>
                 <a:cs typeface="Figtree" pitchFamily="34" charset="-120"/>
               </a:rPr>
-              <a:t>SESSIONI</a:t>
-            </a:r>
-            <a:endParaRPr lang="en-US" sz="800" dirty="0"/>
+              <a:t>42,4%</a:t>
+            </a:r>
+            <a:endParaRPr lang="en-US" sz="2200" dirty="0"/>
           </a:p>
         </p:txBody>
       </p:sp>
@@ -27530,8 +27603,8 @@
         </p:nvSpPr>
         <p:spPr>
           <a:xfrm>
-            <a:off x="8321040" y="2468880"/>
-            <a:ext cx="1828800" cy="365760"/>
+            <a:off x="457200" y="5760720"/>
+            <a:ext cx="10972800" cy="365760"/>
           </a:xfrm>
           <a:prstGeom prst="rect">
             <a:avLst/>
@@ -27547,7 +27620,7 @@
               <a:buNone/>
             </a:pPr>
             <a:r>
-              <a:rPr lang="en-US" sz="2000" b="1" dirty="0">
+              <a:rPr lang="en-US" sz="1100" b="1" dirty="0">
                 <a:solidFill>
                   <a:srgbClr val="191919"/>
                 </a:solidFill>
@@ -27555,9 +27628,9 @@
                 <a:ea typeface="Figtree" pitchFamily="34" charset="-122"/>
                 <a:cs typeface="Figtree" pitchFamily="34" charset="-120"/>
               </a:rPr>
-              <a:t>1.653</a:t>
-            </a:r>
-            <a:endParaRPr lang="en-US" sz="2000" dirty="0"/>
+              <a:t>Investimento totale settembre 2026: 9.019 € (Google 57,6% + Meta 42,4%)</a:t>
+            </a:r>
+            <a:endParaRPr lang="en-US" sz="1100" dirty="0"/>
           </a:p>
         </p:txBody>
       </p:sp>
@@ -27569,8 +27642,8 @@
         </p:nvSpPr>
         <p:spPr>
           <a:xfrm>
-            <a:off x="10241280" y="2468880"/>
-            <a:ext cx="1188720" cy="365760"/>
+            <a:off x="457200" y="6446520"/>
+            <a:ext cx="8229600" cy="228600"/>
           </a:xfrm>
           <a:prstGeom prst="rect">
             <a:avLst/>
@@ -27582,331 +27655,19 @@
           <a:bodyPr wrap="square" lIns="0" tIns="0" rIns="0" bIns="0" rtlCol="0" anchor="ctr"/>
           <a:lstStyle/>
           <a:p>
-            <a:pPr algn="r" indent="0" marL="0">
+            <a:pPr indent="0" marL="0">
               <a:buNone/>
             </a:pPr>
             <a:r>
-              <a:rPr lang="en-US" sz="1300" b="1" dirty="0">
-                <a:solidFill>
-                  <a:srgbClr val="118541"/>
+              <a:rPr lang="en-US" sz="700" dirty="0">
+                <a:solidFill>
+                  <a:srgbClr val="AAAAAA"/>
                 </a:solidFill>
                 <a:latin typeface="Figtree" pitchFamily="34" charset="0"/>
                 <a:ea typeface="Figtree" pitchFamily="34" charset="-122"/>
                 <a:cs typeface="Figtree" pitchFamily="34" charset="-120"/>
               </a:rPr>
-              <a:t>+22,1%</a:t>
-            </a:r>
-            <a:endParaRPr lang="en-US" sz="1300" dirty="0"/>
-          </a:p>
-        </p:txBody>
-      </p:sp>
-      <p:sp>
-        <p:nvSpPr>
-          <p:cNvPr id="43" name="Text 41"/>
-          <p:cNvSpPr txBox="1"/>
-          <p:nvPr/>
-        </p:nvSpPr>
-        <p:spPr>
-          <a:xfrm>
-            <a:off x="8321040" y="3108960"/>
-            <a:ext cx="2743200" cy="182880"/>
-          </a:xfrm>
-          <a:prstGeom prst="rect">
-            <a:avLst/>
-          </a:prstGeom>
-          <a:noFill/>
-          <a:ln/>
-        </p:spPr>
-        <p:txBody>
-          <a:bodyPr wrap="square" lIns="0" tIns="0" rIns="0" bIns="0" rtlCol="0" anchor="ctr"/>
-          <a:lstStyle/>
-          <a:p>
-            <a:pPr indent="0" marL="0">
-              <a:buNone/>
-            </a:pPr>
-            <a:r>
-              <a:rPr lang="en-US" sz="800" b="1" dirty="0">
-                <a:solidFill>
-                  <a:srgbClr val="595959"/>
-                </a:solidFill>
-                <a:latin typeface="Figtree" pitchFamily="34" charset="0"/>
-                <a:ea typeface="Figtree" pitchFamily="34" charset="-122"/>
-                <a:cs typeface="Figtree" pitchFamily="34" charset="-120"/>
-              </a:rPr>
-              <a:t>SESSIONI 2025</a:t>
-            </a:r>
-            <a:endParaRPr lang="en-US" sz="800" dirty="0"/>
-          </a:p>
-        </p:txBody>
-      </p:sp>
-      <p:sp>
-        <p:nvSpPr>
-          <p:cNvPr id="44" name="Text 42"/>
-          <p:cNvSpPr txBox="1"/>
-          <p:nvPr/>
-        </p:nvSpPr>
-        <p:spPr>
-          <a:xfrm>
-            <a:off x="8321040" y="3291840"/>
-            <a:ext cx="1828800" cy="365760"/>
-          </a:xfrm>
-          <a:prstGeom prst="rect">
-            <a:avLst/>
-          </a:prstGeom>
-          <a:noFill/>
-          <a:ln/>
-        </p:spPr>
-        <p:txBody>
-          <a:bodyPr wrap="square" lIns="0" tIns="0" rIns="0" bIns="0" rtlCol="0" anchor="ctr"/>
-          <a:lstStyle/>
-          <a:p>
-            <a:pPr indent="0" marL="0">
-              <a:buNone/>
-            </a:pPr>
-            <a:r>
-              <a:rPr lang="en-US" sz="2000" b="1" dirty="0">
-                <a:solidFill>
-                  <a:srgbClr val="191919"/>
-                </a:solidFill>
-                <a:latin typeface="Figtree" pitchFamily="34" charset="0"/>
-                <a:ea typeface="Figtree" pitchFamily="34" charset="-122"/>
-                <a:cs typeface="Figtree" pitchFamily="34" charset="-120"/>
-              </a:rPr>
-              <a:t>1.354</a:t>
-            </a:r>
-            <a:endParaRPr lang="en-US" sz="2000" dirty="0"/>
-          </a:p>
-        </p:txBody>
-      </p:sp>
-      <p:sp>
-        <p:nvSpPr>
-          <p:cNvPr id="45" name="Text 43"/>
-          <p:cNvSpPr txBox="1"/>
-          <p:nvPr/>
-        </p:nvSpPr>
-        <p:spPr>
-          <a:xfrm>
-            <a:off x="8321040" y="3931920"/>
-            <a:ext cx="2743200" cy="182880"/>
-          </a:xfrm>
-          <a:prstGeom prst="rect">
-            <a:avLst/>
-          </a:prstGeom>
-          <a:noFill/>
-          <a:ln/>
-        </p:spPr>
-        <p:txBody>
-          <a:bodyPr wrap="square" lIns="0" tIns="0" rIns="0" bIns="0" rtlCol="0" anchor="ctr"/>
-          <a:lstStyle/>
-          <a:p>
-            <a:pPr indent="0" marL="0">
-              <a:buNone/>
-            </a:pPr>
-            <a:r>
-              <a:rPr lang="en-US" sz="800" b="1" dirty="0">
-                <a:solidFill>
-                  <a:srgbClr val="595959"/>
-                </a:solidFill>
-                <a:latin typeface="Figtree" pitchFamily="34" charset="0"/>
-                <a:ea typeface="Figtree" pitchFamily="34" charset="-122"/>
-                <a:cs typeface="Figtree" pitchFamily="34" charset="-120"/>
-              </a:rPr>
-              <a:t>CANALE</a:t>
-            </a:r>
-            <a:endParaRPr lang="en-US" sz="800" dirty="0"/>
-          </a:p>
-        </p:txBody>
-      </p:sp>
-      <p:sp>
-        <p:nvSpPr>
-          <p:cNvPr id="46" name="Text 44"/>
-          <p:cNvSpPr txBox="1"/>
-          <p:nvPr/>
-        </p:nvSpPr>
-        <p:spPr>
-          <a:xfrm>
-            <a:off x="8321040" y="4114800"/>
-            <a:ext cx="1828800" cy="365760"/>
-          </a:xfrm>
-          <a:prstGeom prst="rect">
-            <a:avLst/>
-          </a:prstGeom>
-          <a:noFill/>
-          <a:ln/>
-        </p:spPr>
-        <p:txBody>
-          <a:bodyPr wrap="square" lIns="0" tIns="0" rIns="0" bIns="0" rtlCol="0" anchor="ctr"/>
-          <a:lstStyle/>
-          <a:p>
-            <a:pPr indent="0" marL="0">
-              <a:buNone/>
-            </a:pPr>
-            <a:r>
-              <a:rPr lang="en-US" sz="2000" b="1" dirty="0">
-                <a:solidFill>
-                  <a:srgbClr val="191919"/>
-                </a:solidFill>
-                <a:latin typeface="Figtree" pitchFamily="34" charset="0"/>
-                <a:ea typeface="Figtree" pitchFamily="34" charset="-122"/>
-                <a:cs typeface="Figtree" pitchFamily="34" charset="-120"/>
-              </a:rPr>
-              <a:t>Organico</a:t>
-            </a:r>
-            <a:endParaRPr lang="en-US" sz="2000" dirty="0"/>
-          </a:p>
-        </p:txBody>
-      </p:sp>
-      <p:sp>
-        <p:nvSpPr>
-          <p:cNvPr id="47" name="Text 45"/>
-          <p:cNvSpPr txBox="1"/>
-          <p:nvPr/>
-        </p:nvSpPr>
-        <p:spPr>
-          <a:xfrm>
-            <a:off x="8321040" y="4754880"/>
-            <a:ext cx="2743200" cy="182880"/>
-          </a:xfrm>
-          <a:prstGeom prst="rect">
-            <a:avLst/>
-          </a:prstGeom>
-          <a:noFill/>
-          <a:ln/>
-        </p:spPr>
-        <p:txBody>
-          <a:bodyPr wrap="square" lIns="0" tIns="0" rIns="0" bIns="0" rtlCol="0" anchor="ctr"/>
-          <a:lstStyle/>
-          <a:p>
-            <a:pPr indent="0" marL="0">
-              <a:buNone/>
-            </a:pPr>
-            <a:r>
-              <a:rPr lang="en-US" sz="800" b="1" dirty="0">
-                <a:solidFill>
-                  <a:srgbClr val="595959"/>
-                </a:solidFill>
-                <a:latin typeface="Figtree" pitchFamily="34" charset="0"/>
-                <a:ea typeface="Figtree" pitchFamily="34" charset="-122"/>
-                <a:cs typeface="Figtree" pitchFamily="34" charset="-120"/>
-              </a:rPr>
-              <a:t>QUOTA TRAFFICO</a:t>
-            </a:r>
-            <a:endParaRPr lang="en-US" sz="800" dirty="0"/>
-          </a:p>
-        </p:txBody>
-      </p:sp>
-      <p:sp>
-        <p:nvSpPr>
-          <p:cNvPr id="48" name="Text 46"/>
-          <p:cNvSpPr txBox="1"/>
-          <p:nvPr/>
-        </p:nvSpPr>
-        <p:spPr>
-          <a:xfrm>
-            <a:off x="8321040" y="4937760"/>
-            <a:ext cx="1828800" cy="365760"/>
-          </a:xfrm>
-          <a:prstGeom prst="rect">
-            <a:avLst/>
-          </a:prstGeom>
-          <a:noFill/>
-          <a:ln/>
-        </p:spPr>
-        <p:txBody>
-          <a:bodyPr wrap="square" lIns="0" tIns="0" rIns="0" bIns="0" rtlCol="0" anchor="ctr"/>
-          <a:lstStyle/>
-          <a:p>
-            <a:pPr indent="0" marL="0">
-              <a:buNone/>
-            </a:pPr>
-            <a:r>
-              <a:rPr lang="en-US" sz="2000" b="1" dirty="0">
-                <a:solidFill>
-                  <a:srgbClr val="191919"/>
-                </a:solidFill>
-                <a:latin typeface="Figtree" pitchFamily="34" charset="0"/>
-                <a:ea typeface="Figtree" pitchFamily="34" charset="-122"/>
-                <a:cs typeface="Figtree" pitchFamily="34" charset="-120"/>
-              </a:rPr>
-              <a:t>6,4%</a:t>
-            </a:r>
-            <a:endParaRPr lang="en-US" sz="2000" dirty="0"/>
-          </a:p>
-        </p:txBody>
-      </p:sp>
-      <p:sp>
-        <p:nvSpPr>
-          <p:cNvPr id="49" name="Text 47"/>
-          <p:cNvSpPr txBox="1"/>
-          <p:nvPr/>
-        </p:nvSpPr>
-        <p:spPr>
-          <a:xfrm>
-            <a:off x="457200" y="5760720"/>
-            <a:ext cx="10972800" cy="365760"/>
-          </a:xfrm>
-          <a:prstGeom prst="rect">
-            <a:avLst/>
-          </a:prstGeom>
-          <a:noFill/>
-          <a:ln/>
-        </p:spPr>
-        <p:txBody>
-          <a:bodyPr wrap="square" lIns="0" tIns="0" rIns="0" bIns="0" rtlCol="0" anchor="ctr"/>
-          <a:lstStyle/>
-          <a:p>
-            <a:pPr indent="0" marL="0">
-              <a:buNone/>
-            </a:pPr>
-            <a:r>
-              <a:rPr lang="en-US" sz="1100" b="1" dirty="0">
-                <a:solidFill>
-                  <a:srgbClr val="191919"/>
-                </a:solidFill>
-                <a:latin typeface="Figtree" pitchFamily="34" charset="0"/>
-                <a:ea typeface="Figtree" pitchFamily="34" charset="-122"/>
-                <a:cs typeface="Figtree" pitchFamily="34" charset="-120"/>
-              </a:rPr>
-              <a:t>Investimento totale settembre 2026: 9.019 € (Google 5.193 € + Meta 3.826 €)</a:t>
-            </a:r>
-            <a:endParaRPr lang="en-US" sz="1100" dirty="0"/>
-          </a:p>
-        </p:txBody>
-      </p:sp>
-      <p:sp>
-        <p:nvSpPr>
-          <p:cNvPr id="50" name="Text 48"/>
-          <p:cNvSpPr txBox="1"/>
-          <p:nvPr/>
-        </p:nvSpPr>
-        <p:spPr>
-          <a:xfrm>
-            <a:off x="457200" y="6446520"/>
-            <a:ext cx="8229600" cy="228600"/>
-          </a:xfrm>
-          <a:prstGeom prst="rect">
-            <a:avLst/>
-          </a:prstGeom>
-          <a:noFill/>
-          <a:ln/>
-        </p:spPr>
-        <p:txBody>
-          <a:bodyPr wrap="square" lIns="0" tIns="0" rIns="0" bIns="0" rtlCol="0" anchor="ctr"/>
-          <a:lstStyle/>
-          <a:p>
-            <a:pPr indent="0" marL="0">
-              <a:buNone/>
-            </a:pPr>
-            <a:r>
-              <a:rPr lang="en-US" sz="700" dirty="0">
-                <a:solidFill>
-                  <a:srgbClr val="AAAAAA"/>
-                </a:solidFill>
-                <a:latin typeface="Figtree" pitchFamily="34" charset="0"/>
-                <a:ea typeface="Figtree" pitchFamily="34" charset="-122"/>
-                <a:cs typeface="Figtree" pitchFamily="34" charset="-120"/>
-              </a:rPr>
-              <a:t>Fonte dati: Google Ads, Meta Ads, GA4 | Periodo: set 2026 vs set 2025</a:t>
+              <a:t>Fonte dati: Google Ads, Meta Ads | Periodo: set 2026 vs set 2025</a:t>
             </a:r>
             <a:endParaRPr lang="en-US" sz="700" dirty="0"/>
           </a:p>
@@ -29990,15 +29751,54 @@
           </a:graphicData>
         </a:graphic>
       </p:graphicFrame>
+      <p:sp>
+        <p:nvSpPr>
+          <p:cNvPr id="8" name="Text 5"/>
+          <p:cNvSpPr txBox="1"/>
+          <p:nvPr/>
+        </p:nvSpPr>
+        <p:spPr>
+          <a:xfrm>
+            <a:off x="457200" y="4114800"/>
+            <a:ext cx="4572000" cy="228600"/>
+          </a:xfrm>
+          <a:prstGeom prst="rect">
+            <a:avLst/>
+          </a:prstGeom>
+          <a:noFill/>
+          <a:ln/>
+        </p:spPr>
+        <p:txBody>
+          <a:bodyPr wrap="square" lIns="0" tIns="0" rIns="0" bIns="0" rtlCol="0" anchor="ctr"/>
+          <a:lstStyle/>
+          <a:p>
+            <a:pPr indent="0" marL="0">
+              <a:buNone/>
+            </a:pPr>
+            <a:r>
+              <a:rPr lang="en-US" sz="900" b="1" dirty="0">
+                <a:solidFill>
+                  <a:srgbClr val="E52217"/>
+                </a:solidFill>
+                <a:latin typeface="Figtree" pitchFamily="34" charset="0"/>
+                <a:ea typeface="Figtree" pitchFamily="34" charset="-122"/>
+                <a:cs typeface="Figtree" pitchFamily="34" charset="-120"/>
+              </a:rPr>
+              <a:t>DISTRIBUZIONE CLIC PER CAMPAGNA</a:t>
+            </a:r>
+            <a:endParaRPr lang="en-US" sz="900" dirty="0"/>
+          </a:p>
+        </p:txBody>
+      </p:sp>
       <p:graphicFrame>
         <p:nvGraphicFramePr>
-          <p:cNvPr id="8" name="Chart 0" descr=""/>
+          <p:cNvPr id="9" name="Chart 0" descr=""/>
           <p:cNvGraphicFramePr/>
           <p:nvPr/>
         </p:nvGraphicFramePr>
         <p:xfrm>
-          <a:off x="457200" y="4206240"/>
-          <a:ext cx="6858000" cy="1828800"/>
+          <a:off x="457200" y="4343400"/>
+          <a:ext cx="6858000" cy="1645920"/>
         </p:xfrm>
         <a:graphic xmlns:a="http://schemas.openxmlformats.org/drawingml/2006/main">
           <a:graphicData uri="http://schemas.openxmlformats.org/drawingml/2006/chart">
@@ -30008,18 +29808,18 @@
       </p:graphicFrame>
       <p:sp>
         <p:nvSpPr>
-          <p:cNvPr id="9" name="Shape 5"/>
+          <p:cNvPr id="10" name="Shape 6"/>
           <p:cNvSpPr/>
           <p:nvPr/>
         </p:nvSpPr>
         <p:spPr>
           <a:xfrm>
-            <a:off x="7772400" y="4206240"/>
-            <a:ext cx="3931920" cy="1828800"/>
+            <a:off x="7772400" y="4114800"/>
+            <a:ext cx="3931920" cy="1920240"/>
           </a:xfrm>
           <a:prstGeom prst="roundRect">
             <a:avLst>
-              <a:gd name="adj" fmla="val 4000"/>
+              <a:gd name="adj" fmla="val 3810"/>
             </a:avLst>
           </a:prstGeom>
           <a:solidFill>
@@ -30030,13 +29830,13 @@
       </p:sp>
       <p:sp>
         <p:nvSpPr>
-          <p:cNvPr id="10" name="Text 6"/>
+          <p:cNvPr id="11" name="Text 7"/>
           <p:cNvSpPr txBox="1"/>
           <p:nvPr/>
         </p:nvSpPr>
         <p:spPr>
           <a:xfrm>
-            <a:off x="7955280" y="4297680"/>
+            <a:off x="7955280" y="4206240"/>
             <a:ext cx="3200400" cy="274320"/>
           </a:xfrm>
           <a:prstGeom prst="rect">
@@ -30069,13 +29869,13 @@
       </p:sp>
       <p:sp>
         <p:nvSpPr>
-          <p:cNvPr id="11" name="Text 7"/>
+          <p:cNvPr id="12" name="Text 8"/>
           <p:cNvSpPr txBox="1"/>
           <p:nvPr/>
         </p:nvSpPr>
         <p:spPr>
           <a:xfrm>
-            <a:off x="7955280" y="4617720"/>
+            <a:off x="7955280" y="4526280"/>
             <a:ext cx="3566160" cy="1371600"/>
           </a:xfrm>
           <a:prstGeom prst="rect">
@@ -30171,7 +29971,7 @@
       </p:sp>
       <p:sp>
         <p:nvSpPr>
-          <p:cNvPr id="12" name="Text 8"/>
+          <p:cNvPr id="13" name="Text 9"/>
           <p:cNvSpPr txBox="1"/>
           <p:nvPr/>
         </p:nvSpPr>

</xml_diff>

<commit_message>
Rimuovi sfondo grigio dai grafici a barre e temporali
Aggiunto fill: 'FFFFFF' a tutti i 9 grafici LINE e BAR per rendere
lo sfondo bianco e coerente con il layout delle slide.

Co-Authored-By: Claude Opus 4.6 <noreply@anthropic.com>
Claude-Session: https://claude.ai/code/session_01Nok6HhGnvhEchJRhgCetML
</commit_message>
<xml_diff>
--- a/FerreroLegnoReport_settembre_2026.pptx
+++ b/FerreroLegnoReport_settembre_2026.pptx
@@ -132,12 +132,12 @@
   <p:extLst>
     <p:ext uri="{521415D9-36F7-43E2-AB2F-B90AF26B5E84}">
       <p14:sectionLst xmlns:p14="http://schemas.microsoft.com/office/powerpoint/2010/main">
-        <p14:section name="Cover" id="{dd6de579-e6a8-360c-d970-f98302ac750e}">
+        <p14:section name="Cover" id="{2279b85c-a12b-bb36-a42b-4a07355849de}">
           <p14:sldIdLst>
             <p14:sldId id="256"/>
           </p14:sldIdLst>
         </p14:section>
-        <p14:section name="Andamento e risultati" id="{228325bd-83c0-ff25-4640-54696aab0b54}">
+        <p14:section name="Andamento e risultati" id="{b0d5c331-3ada-6cf7-5cbc-dc6acaea4190}">
           <p14:sldIdLst>
             <p14:sldId id="257"/>
             <p14:sldId id="258"/>
@@ -153,7 +153,7 @@
             <p14:sldId id="268"/>
           </p14:sldIdLst>
         </p14:section>
-        <p14:section name="Lead Generation" id="{594fa67a-beac-93d4-c592-e36a82e9ddad}">
+        <p14:section name="Lead Generation" id="{b102dd0b-8ccf-1294-75b4-20717faa22a9}">
           <p14:sldIdLst>
             <p14:sldId id="269"/>
             <p14:sldId id="270"/>
@@ -162,7 +162,7 @@
             <p14:sldId id="273"/>
           </p14:sldIdLst>
         </p14:section>
-        <p14:section name="Focus Magazine" id="{0a116215-94e1-282b-4ce5-7702566441bb}">
+        <p14:section name="Focus Magazine" id="{3b59999e-b964-ec34-c70b-548e48a66685}">
           <p14:sldIdLst>
             <p14:sldId id="274"/>
             <p14:sldId id="275"/>
@@ -171,7 +171,7 @@
             <p14:sldId id="278"/>
           </p14:sldIdLst>
         </p14:section>
-        <p14:section name="In chiusura" id="{16aa3054-aced-7965-0f53-8997c67dc729}">
+        <p14:section name="In chiusura" id="{8c980cea-b8b1-9304-ed0c-4c6be0424148}">
           <p14:sldIdLst>
             <p14:sldId id="279"/>
             <p14:sldId id="280"/>
@@ -858,7 +858,9 @@
         <c:crossBetween val="between"/>
       </c:valAx>
       <c:spPr>
-        <a:noFill/>
+        <a:solidFill>
+          <a:srgbClr val="FFFFFF"/>
+        </a:solidFill>
         <a:ln>
           <a:noFill/>
         </a:ln>
@@ -1113,7 +1115,9 @@
         <c:crossBetween val="between"/>
       </c:valAx>
       <c:spPr>
-        <a:noFill/>
+        <a:solidFill>
+          <a:srgbClr val="FFFFFF"/>
+        </a:solidFill>
         <a:ln>
           <a:noFill/>
         </a:ln>
@@ -1336,7 +1340,9 @@
         <c:crossBetween val="between"/>
       </c:valAx>
       <c:spPr>
-        <a:noFill/>
+        <a:solidFill>
+          <a:srgbClr val="FFFFFF"/>
+        </a:solidFill>
         <a:ln>
           <a:noFill/>
         </a:ln>
@@ -2054,7 +2060,9 @@
         <c:crossBetween val="between"/>
       </c:valAx>
       <c:spPr>
-        <a:noFill/>
+        <a:solidFill>
+          <a:srgbClr val="FFFFFF"/>
+        </a:solidFill>
         <a:ln>
           <a:noFill/>
         </a:ln>
@@ -2422,7 +2430,9 @@
         <c:crossBetween val="between"/>
       </c:valAx>
       <c:spPr>
-        <a:noFill/>
+        <a:solidFill>
+          <a:srgbClr val="FFFFFF"/>
+        </a:solidFill>
         <a:ln>
           <a:noFill/>
         </a:ln>
@@ -2683,7 +2693,9 @@
         <c:crossBetween val="between"/>
       </c:valAx>
       <c:spPr>
-        <a:noFill/>
+        <a:solidFill>
+          <a:srgbClr val="FFFFFF"/>
+        </a:solidFill>
         <a:ln>
           <a:noFill/>
         </a:ln>
@@ -2930,7 +2942,9 @@
         <c:crossBetween val="between"/>
       </c:valAx>
       <c:spPr>
-        <a:noFill/>
+        <a:solidFill>
+          <a:srgbClr val="FFFFFF"/>
+        </a:solidFill>
         <a:ln>
           <a:noFill/>
         </a:ln>
@@ -3190,7 +3204,9 @@
         <c:crossBetween val="between"/>
       </c:valAx>
       <c:spPr>
-        <a:noFill/>
+        <a:solidFill>
+          <a:srgbClr val="FFFFFF"/>
+        </a:solidFill>
         <a:ln>
           <a:noFill/>
         </a:ln>
@@ -3550,7 +3566,9 @@
         <c:crossBetween val="between"/>
       </c:valAx>
       <c:spPr>
-        <a:noFill/>
+        <a:solidFill>
+          <a:srgbClr val="FFFFFF"/>
+        </a:solidFill>
         <a:ln>
           <a:noFill/>
         </a:ln>

</xml_diff>